<commit_message>
Phased architecture diagram with the trust model; docs and decks updated
- New as-built diagram in six labelled phases (protect, normalize,
  AI-assisted resolution, human in the loop, deterministic verdict,
  auditable report) with the human-in-the-loop phase prominent and the
  learning loop drawn explicitly. architecture-slide.svg keeps the idea-PPT
  corner free for its tech-stack box; architecture-phases.svg fills it
  with the trust model (AI suggests, humans decide, rules judge).
- 2-page PDF and technical deck use it; the deck's results slide now shows
  measured per-file times against the old build (8-16 s vs 2-12 min).
- README / 2-page doc: batched classification, non-security structure at
  Tier 1, measured speed, batch-mode golden-set numbers.

Co-Authored-By: Claude Opus 5.5 (1M context) <noreply@anthropic.com>
</commit_message>
<xml_diff>
--- a/docs/AEGIS-Technical-Presentation.pptx
+++ b/docs/AEGIS-Technical-Presentation.pptx
@@ -594,7 +594,7 @@
           <a:p>
             <a:r>
               <a:rPr lang="en-US" dirty="0"/>
-              <a:t/>
+              <a:t>Six phases. The AI only suggests (phase 3); every unsure or blocked line goes to a reviewer (phase 4); verdicts come only from deterministic rules (phase 5); every finding records how it was decided (phase 6).</a:t>
             </a:r>
             <a:endParaRPr lang="en-US" dirty="0"/>
           </a:p>
@@ -1938,7 +1938,7 @@
                 <a:ea typeface="Cambria" pitchFamily="34" charset="-122"/>
                 <a:cs typeface="Cambria" pitchFamily="34" charset="-120"/>
               </a:rPr>
-              <a:t>148</a:t>
+              <a:t>160</a:t>
             </a:r>
             <a:endParaRPr lang="en-US" sz="4400" dirty="0"/>
           </a:p>
@@ -2279,7 +2279,7 @@
                 <a:ea typeface="Cambria" pitchFamily="34" charset="-122"/>
                 <a:cs typeface="Cambria" pitchFamily="34" charset="-120"/>
               </a:rPr>
-              <a:t>Architecture: one pipeline for every vendor</a:t>
+              <a:t>AI suggests, humans decide, rules judge</a:t>
             </a:r>
             <a:endParaRPr lang="en-US" sz="3000" dirty="0"/>
           </a:p>
@@ -2365,7 +2365,7 @@
       </p:sp>
       <p:pic>
         <p:nvPicPr>
-          <p:cNvPr id="7" name="Image 2" descr="C:\Users\ADVAIT\SAVECODE\sih\documents\tech-deck\assets\architecture-compact.png">    </p:cNvPr>
+          <p:cNvPr id="7" name="Image 2" descr="C:\Users\ADVAIT\SAVECODE\sih\documents\tech-deck\assets\architecture-phases.png">    </p:cNvPr>
           <p:cNvPicPr>
             <a:picLocks noChangeAspect="1"/>
           </p:cNvPicPr>
@@ -2379,329 +2379,14 @@
         </p:blipFill>
         <p:spPr>
           <a:xfrm>
-            <a:off x="502920" y="1143000"/>
-            <a:ext cx="11155680" cy="3546577"/>
+            <a:off x="502920" y="1097280"/>
+            <a:ext cx="11183112" cy="5120933"/>
           </a:xfrm>
           <a:prstGeom prst="rect">
             <a:avLst/>
           </a:prstGeom>
         </p:spPr>
       </p:pic>
-      <p:sp>
-        <p:nvSpPr>
-          <p:cNvPr id="8" name="Shape 3"/>
-          <p:cNvSpPr/>
-          <p:nvPr/>
-        </p:nvSpPr>
-        <p:spPr>
-          <a:xfrm>
-            <a:off x="502920" y="4846320"/>
-            <a:ext cx="3566160" cy="1463040"/>
-          </a:xfrm>
-          <a:prstGeom prst="roundRect">
-            <a:avLst>
-              <a:gd name="adj" fmla="val 5000"/>
-            </a:avLst>
-          </a:prstGeom>
-          <a:solidFill>
-            <a:srgbClr val="F1F5F9"/>
-          </a:solidFill>
-          <a:ln w="12700">
-            <a:solidFill>
-              <a:srgbClr val="F1F5F9"/>
-            </a:solidFill>
-            <a:prstDash val="solid"/>
-          </a:ln>
-        </p:spPr>
-      </p:sp>
-      <p:sp>
-        <p:nvSpPr>
-          <p:cNvPr id="9" name="Text 4"/>
-          <p:cNvSpPr txBox="1"/>
-          <p:nvPr/>
-        </p:nvSpPr>
-        <p:spPr>
-          <a:xfrm>
-            <a:off x="685800" y="4937760"/>
-            <a:ext cx="3200400" cy="365760"/>
-          </a:xfrm>
-          <a:prstGeom prst="rect">
-            <a:avLst/>
-          </a:prstGeom>
-          <a:noFill/>
-          <a:ln/>
-        </p:spPr>
-        <p:txBody>
-          <a:bodyPr wrap="square" lIns="0" tIns="0" rIns="0" bIns="0" rtlCol="0" anchor="ctr"/>
-          <a:lstStyle/>
-          <a:p>
-            <a:pPr indent="0" marL="0">
-              <a:buNone/>
-            </a:pPr>
-            <a:r>
-              <a:rPr lang="en-US" sz="1500" b="1" dirty="0">
-                <a:solidFill>
-                  <a:srgbClr val="0F172A"/>
-                </a:solidFill>
-                <a:latin typeface="Calibri" pitchFamily="34" charset="0"/>
-                <a:ea typeface="Calibri" pitchFamily="34" charset="-122"/>
-                <a:cs typeface="Calibri" pitchFamily="34" charset="-120"/>
-              </a:rPr>
-              <a:t>Fail-closed by construction</a:t>
-            </a:r>
-            <a:endParaRPr lang="en-US" sz="1500" dirty="0"/>
-          </a:p>
-        </p:txBody>
-      </p:sp>
-      <p:sp>
-        <p:nvSpPr>
-          <p:cNvPr id="10" name="Text 5"/>
-          <p:cNvSpPr txBox="1"/>
-          <p:nvPr/>
-        </p:nvSpPr>
-        <p:spPr>
-          <a:xfrm>
-            <a:off x="685800" y="5303520"/>
-            <a:ext cx="3200400" cy="960120"/>
-          </a:xfrm>
-          <a:prstGeom prst="rect">
-            <a:avLst/>
-          </a:prstGeom>
-          <a:noFill/>
-          <a:ln/>
-        </p:spPr>
-        <p:txBody>
-          <a:bodyPr wrap="square" lIns="0" tIns="0" rIns="0" bIns="0" rtlCol="0" anchor="t"/>
-          <a:lstStyle/>
-          <a:p>
-            <a:pPr indent="0" marL="0">
-              <a:buNone/>
-            </a:pPr>
-            <a:r>
-              <a:rPr lang="en-US" sz="1150" dirty="0">
-                <a:solidFill>
-                  <a:srgbClr val="1E293B"/>
-                </a:solidFill>
-                <a:latin typeface="Calibri" pitchFamily="34" charset="0"/>
-                <a:ea typeface="Calibri" pitchFamily="34" charset="-122"/>
-                <a:cs typeface="Calibri" pitchFamily="34" charset="-120"/>
-              </a:rPr>
-              <a:t>A setting the config never mentions is NOT_EVALUATED, never a silent PASS. Any malformed, invented or mistyped AI answer falls to a human instead of being used.</a:t>
-            </a:r>
-            <a:endParaRPr lang="en-US" sz="1150" dirty="0"/>
-          </a:p>
-        </p:txBody>
-      </p:sp>
-      <p:sp>
-        <p:nvSpPr>
-          <p:cNvPr id="11" name="Shape 6"/>
-          <p:cNvSpPr/>
-          <p:nvPr/>
-        </p:nvSpPr>
-        <p:spPr>
-          <a:xfrm>
-            <a:off x="4279392" y="4846320"/>
-            <a:ext cx="3566160" cy="1463040"/>
-          </a:xfrm>
-          <a:prstGeom prst="roundRect">
-            <a:avLst>
-              <a:gd name="adj" fmla="val 5000"/>
-            </a:avLst>
-          </a:prstGeom>
-          <a:solidFill>
-            <a:srgbClr val="F1F5F9"/>
-          </a:solidFill>
-          <a:ln w="12700">
-            <a:solidFill>
-              <a:srgbClr val="F1F5F9"/>
-            </a:solidFill>
-            <a:prstDash val="solid"/>
-          </a:ln>
-        </p:spPr>
-      </p:sp>
-      <p:sp>
-        <p:nvSpPr>
-          <p:cNvPr id="12" name="Text 7"/>
-          <p:cNvSpPr txBox="1"/>
-          <p:nvPr/>
-        </p:nvSpPr>
-        <p:spPr>
-          <a:xfrm>
-            <a:off x="4462272" y="4937760"/>
-            <a:ext cx="3200400" cy="365760"/>
-          </a:xfrm>
-          <a:prstGeom prst="rect">
-            <a:avLst/>
-          </a:prstGeom>
-          <a:noFill/>
-          <a:ln/>
-        </p:spPr>
-        <p:txBody>
-          <a:bodyPr wrap="square" lIns="0" tIns="0" rIns="0" bIns="0" rtlCol="0" anchor="ctr"/>
-          <a:lstStyle/>
-          <a:p>
-            <a:pPr indent="0" marL="0">
-              <a:buNone/>
-            </a:pPr>
-            <a:r>
-              <a:rPr lang="en-US" sz="1500" b="1" dirty="0">
-                <a:solidFill>
-                  <a:srgbClr val="0F172A"/>
-                </a:solidFill>
-                <a:latin typeface="Calibri" pitchFamily="34" charset="0"/>
-                <a:ea typeface="Calibri" pitchFamily="34" charset="-122"/>
-                <a:cs typeface="Calibri" pitchFamily="34" charset="-120"/>
-              </a:rPr>
-              <a:t>No AI in the verdict</a:t>
-            </a:r>
-            <a:endParaRPr lang="en-US" sz="1500" dirty="0"/>
-          </a:p>
-        </p:txBody>
-      </p:sp>
-      <p:sp>
-        <p:nvSpPr>
-          <p:cNvPr id="13" name="Text 8"/>
-          <p:cNvSpPr txBox="1"/>
-          <p:nvPr/>
-        </p:nvSpPr>
-        <p:spPr>
-          <a:xfrm>
-            <a:off x="4462272" y="5303520"/>
-            <a:ext cx="3200400" cy="960120"/>
-          </a:xfrm>
-          <a:prstGeom prst="rect">
-            <a:avLst/>
-          </a:prstGeom>
-          <a:noFill/>
-          <a:ln/>
-        </p:spPr>
-        <p:txBody>
-          <a:bodyPr wrap="square" lIns="0" tIns="0" rIns="0" bIns="0" rtlCol="0" anchor="t"/>
-          <a:lstStyle/>
-          <a:p>
-            <a:pPr indent="0" marL="0">
-              <a:buNone/>
-            </a:pPr>
-            <a:r>
-              <a:rPr lang="en-US" sz="1150" dirty="0">
-                <a:solidFill>
-                  <a:srgbClr val="1E293B"/>
-                </a:solidFill>
-                <a:latin typeface="Calibri" pitchFamily="34" charset="0"/>
-                <a:ea typeface="Calibri" pitchFamily="34" charset="-122"/>
-                <a:cs typeface="Calibri" pitchFamily="34" charset="-120"/>
-              </a:rPr>
-              <a:t>Six generic predicate types, including ordered first-match for ACLs. A permit-any before a deny-telnet is caught as a FAIL; a presence check would call it safe.</a:t>
-            </a:r>
-            <a:endParaRPr lang="en-US" sz="1150" dirty="0"/>
-          </a:p>
-        </p:txBody>
-      </p:sp>
-      <p:sp>
-        <p:nvSpPr>
-          <p:cNvPr id="14" name="Shape 9"/>
-          <p:cNvSpPr/>
-          <p:nvPr/>
-        </p:nvSpPr>
-        <p:spPr>
-          <a:xfrm>
-            <a:off x="8055864" y="4846320"/>
-            <a:ext cx="3566160" cy="1463040"/>
-          </a:xfrm>
-          <a:prstGeom prst="roundRect">
-            <a:avLst>
-              <a:gd name="adj" fmla="val 5000"/>
-            </a:avLst>
-          </a:prstGeom>
-          <a:solidFill>
-            <a:srgbClr val="F1F5F9"/>
-          </a:solidFill>
-          <a:ln w="12700">
-            <a:solidFill>
-              <a:srgbClr val="F1F5F9"/>
-            </a:solidFill>
-            <a:prstDash val="solid"/>
-          </a:ln>
-        </p:spPr>
-      </p:sp>
-      <p:sp>
-        <p:nvSpPr>
-          <p:cNvPr id="15" name="Text 10"/>
-          <p:cNvSpPr txBox="1"/>
-          <p:nvPr/>
-        </p:nvSpPr>
-        <p:spPr>
-          <a:xfrm>
-            <a:off x="8238744" y="4937760"/>
-            <a:ext cx="3200400" cy="365760"/>
-          </a:xfrm>
-          <a:prstGeom prst="rect">
-            <a:avLst/>
-          </a:prstGeom>
-          <a:noFill/>
-          <a:ln/>
-        </p:spPr>
-        <p:txBody>
-          <a:bodyPr wrap="square" lIns="0" tIns="0" rIns="0" bIns="0" rtlCol="0" anchor="ctr"/>
-          <a:lstStyle/>
-          <a:p>
-            <a:pPr indent="0" marL="0">
-              <a:buNone/>
-            </a:pPr>
-            <a:r>
-              <a:rPr lang="en-US" sz="1500" b="1" dirty="0">
-                <a:solidFill>
-                  <a:srgbClr val="0F172A"/>
-                </a:solidFill>
-                <a:latin typeface="Calibri" pitchFamily="34" charset="0"/>
-                <a:ea typeface="Calibri" pitchFamily="34" charset="-122"/>
-                <a:cs typeface="Calibri" pitchFamily="34" charset="-120"/>
-              </a:rPr>
-              <a:t>Learning = new rows, not new code</a:t>
-            </a:r>
-            <a:endParaRPr lang="en-US" sz="1500" dirty="0"/>
-          </a:p>
-        </p:txBody>
-      </p:sp>
-      <p:sp>
-        <p:nvSpPr>
-          <p:cNvPr id="16" name="Text 11"/>
-          <p:cNvSpPr txBox="1"/>
-          <p:nvPr/>
-        </p:nvSpPr>
-        <p:spPr>
-          <a:xfrm>
-            <a:off x="8238744" y="5303520"/>
-            <a:ext cx="3200400" cy="960120"/>
-          </a:xfrm>
-          <a:prstGeom prst="rect">
-            <a:avLst/>
-          </a:prstGeom>
-          <a:noFill/>
-          <a:ln/>
-        </p:spPr>
-        <p:txBody>
-          <a:bodyPr wrap="square" lIns="0" tIns="0" rIns="0" bIns="0" rtlCol="0" anchor="t"/>
-          <a:lstStyle/>
-          <a:p>
-            <a:pPr indent="0" marL="0">
-              <a:buNone/>
-            </a:pPr>
-            <a:r>
-              <a:rPr lang="en-US" sz="1150" dirty="0">
-                <a:solidFill>
-                  <a:srgbClr val="1E293B"/>
-                </a:solidFill>
-                <a:latin typeface="Calibri" pitchFamily="34" charset="0"/>
-                <a:ea typeface="Calibri" pitchFamily="34" charset="-122"/>
-                <a:cs typeface="Calibri" pitchFamily="34" charset="-120"/>
-              </a:rPr>
-              <a:t>A reviewer's confirmation becomes a Tier-1 pattern immediately. Vendor-specific benchmarks apply only to their vendor; NIST and ISO apply to all.</a:t>
-            </a:r>
-            <a:endParaRPr lang="en-US" sz="1150" dirty="0"/>
-          </a:p>
-        </p:txBody>
-      </p:sp>
     </p:spTree>
   </p:cSld>
   <p:clrMapOvr>
@@ -4275,12 +3960,12 @@
             <a:tbl>
               <a:tblPr/>
               <a:tblGrid>
-                <a:gridCol w="2331720"/>
-                <a:gridCol w="1097280"/>
+                <a:gridCol w="2240280"/>
                 <a:gridCol w="502920"/>
+                <a:gridCol w="1143000"/>
                 <a:gridCol w="1188720"/>
                 <a:gridCol w="640080"/>
-                <a:gridCol w="685800"/>
+                <a:gridCol w="731520"/>
                 <a:gridCol w="1005840"/>
               </a:tblGrid>
               <a:tr h="384048">
@@ -4301,75 +3986,7 @@
                           <a:ea typeface="Calibri" pitchFamily="34" charset="-122"/>
                           <a:cs typeface="Calibri" pitchFamily="34" charset="-120"/>
                         </a:rPr>
-                        <a:t>Device (source)</a:t>
-                      </a:r>
-                      <a:endParaRPr lang="en-US" sz="1000" dirty="0">
-                        <a:latin typeface="Calibri" charset="0"/>
-                        <a:ea typeface="Calibri" charset="0"/>
-                        <a:cs typeface="Calibri" charset="0"/>
-                      </a:endParaRPr>
-                    </a:p>
-                  </a:txBody>
-                  <a:tcPr marL="45720" marR="45720" marT="45720" marB="45720" anchor="ctr">
-                    <a:lnL w="6350" cap="flat" cmpd="sng" algn="ctr">
-                      <a:solidFill>
-                        <a:srgbClr val="CBD5E1"/>
-                      </a:solidFill>
-                      <a:prstDash val="solid"/>
-                      <a:round/>
-                      <a:headEnd type="none" w="med" len="med"/>
-                      <a:tailEnd type="none" w="med" len="med"/>
-                    </a:lnL>
-                    <a:lnR w="6350" cap="flat" cmpd="sng" algn="ctr">
-                      <a:solidFill>
-                        <a:srgbClr val="CBD5E1"/>
-                      </a:solidFill>
-                      <a:prstDash val="solid"/>
-                      <a:round/>
-                      <a:headEnd type="none" w="med" len="med"/>
-                      <a:tailEnd type="none" w="med" len="med"/>
-                    </a:lnR>
-                    <a:lnT w="6350" cap="flat" cmpd="sng" algn="ctr">
-                      <a:solidFill>
-                        <a:srgbClr val="CBD5E1"/>
-                      </a:solidFill>
-                      <a:prstDash val="solid"/>
-                      <a:round/>
-                      <a:headEnd type="none" w="med" len="med"/>
-                      <a:tailEnd type="none" w="med" len="med"/>
-                    </a:lnT>
-                    <a:lnB w="6350" cap="flat" cmpd="sng" algn="ctr">
-                      <a:solidFill>
-                        <a:srgbClr val="CBD5E1"/>
-                      </a:solidFill>
-                      <a:prstDash val="solid"/>
-                      <a:round/>
-                      <a:headEnd type="none" w="med" len="med"/>
-                      <a:tailEnd type="none" w="med" len="med"/>
-                    </a:lnB>
-                    <a:solidFill>
-                      <a:srgbClr val="0F172A"/>
-                    </a:solidFill>
-                  </a:tcPr>
-                </a:tc>
-                <a:tc>
-                  <a:txBody>
-                    <a:bodyPr/>
-                    <a:lstStyle/>
-                    <a:p>
-                      <a:pPr indent="0" marL="0">
-                        <a:buNone/>
-                      </a:pPr>
-                      <a:r>
-                        <a:rPr lang="en-US" sz="1000" b="1" dirty="0">
-                          <a:solidFill>
-                            <a:srgbClr val="FFFFFF"/>
-                          </a:solidFill>
-                          <a:latin typeface="Calibri" pitchFamily="34" charset="0"/>
-                          <a:ea typeface="Calibri" pitchFamily="34" charset="-122"/>
-                          <a:cs typeface="Calibri" pitchFamily="34" charset="-120"/>
-                        </a:rPr>
-                        <a:t>Format</a:t>
+                        <a:t>Device</a:t>
                       </a:r>
                       <a:endParaRPr lang="en-US" sz="1000" dirty="0">
                         <a:latin typeface="Calibri" charset="0"/>
@@ -4438,6 +4055,74 @@
                           <a:cs typeface="Calibri" pitchFamily="34" charset="-120"/>
                         </a:rPr>
                         <a:t>Lines</a:t>
+                      </a:r>
+                      <a:endParaRPr lang="en-US" sz="1000" dirty="0">
+                        <a:latin typeface="Calibri" charset="0"/>
+                        <a:ea typeface="Calibri" charset="0"/>
+                        <a:cs typeface="Calibri" charset="0"/>
+                      </a:endParaRPr>
+                    </a:p>
+                  </a:txBody>
+                  <a:tcPr marL="45720" marR="45720" marT="45720" marB="45720" anchor="ctr">
+                    <a:lnL w="6350" cap="flat" cmpd="sng" algn="ctr">
+                      <a:solidFill>
+                        <a:srgbClr val="CBD5E1"/>
+                      </a:solidFill>
+                      <a:prstDash val="solid"/>
+                      <a:round/>
+                      <a:headEnd type="none" w="med" len="med"/>
+                      <a:tailEnd type="none" w="med" len="med"/>
+                    </a:lnL>
+                    <a:lnR w="6350" cap="flat" cmpd="sng" algn="ctr">
+                      <a:solidFill>
+                        <a:srgbClr val="CBD5E1"/>
+                      </a:solidFill>
+                      <a:prstDash val="solid"/>
+                      <a:round/>
+                      <a:headEnd type="none" w="med" len="med"/>
+                      <a:tailEnd type="none" w="med" len="med"/>
+                    </a:lnR>
+                    <a:lnT w="6350" cap="flat" cmpd="sng" algn="ctr">
+                      <a:solidFill>
+                        <a:srgbClr val="CBD5E1"/>
+                      </a:solidFill>
+                      <a:prstDash val="solid"/>
+                      <a:round/>
+                      <a:headEnd type="none" w="med" len="med"/>
+                      <a:tailEnd type="none" w="med" len="med"/>
+                    </a:lnT>
+                    <a:lnB w="6350" cap="flat" cmpd="sng" algn="ctr">
+                      <a:solidFill>
+                        <a:srgbClr val="CBD5E1"/>
+                      </a:solidFill>
+                      <a:prstDash val="solid"/>
+                      <a:round/>
+                      <a:headEnd type="none" w="med" len="med"/>
+                      <a:tailEnd type="none" w="med" len="med"/>
+                    </a:lnB>
+                    <a:solidFill>
+                      <a:srgbClr val="0F172A"/>
+                    </a:solidFill>
+                  </a:tcPr>
+                </a:tc>
+                <a:tc>
+                  <a:txBody>
+                    <a:bodyPr/>
+                    <a:lstStyle/>
+                    <a:p>
+                      <a:pPr indent="0" marL="0">
+                        <a:buNone/>
+                      </a:pPr>
+                      <a:r>
+                        <a:rPr lang="en-US" sz="1000" b="1" dirty="0">
+                          <a:solidFill>
+                            <a:srgbClr val="FFFFFF"/>
+                          </a:solidFill>
+                          <a:latin typeface="Calibri" pitchFamily="34" charset="0"/>
+                          <a:ea typeface="Calibri" pitchFamily="34" charset="-122"/>
+                          <a:cs typeface="Calibri" pitchFamily="34" charset="-120"/>
+                        </a:rPr>
+                        <a:t>Time (before)</a:t>
                       </a:r>
                       <a:endParaRPr lang="en-US" sz="1000" dirty="0">
                         <a:latin typeface="Calibri" charset="0"/>
@@ -4847,7 +4532,7 @@
                           <a:ea typeface="Calibri" pitchFamily="34" charset="-122"/>
                           <a:cs typeface="Calibri" pitchFamily="34" charset="-120"/>
                         </a:rPr>
-                        <a:t>Cisco CLI</a:t>
+                        <a:t>81</a:t>
                       </a:r>
                       <a:endParaRPr lang="en-US" sz="1000" dirty="0">
                         <a:latin typeface="Calibri" charset="0"/>
@@ -4915,7 +4600,7 @@
                           <a:ea typeface="Calibri" pitchFamily="34" charset="-122"/>
                           <a:cs typeface="Calibri" pitchFamily="34" charset="-120"/>
                         </a:rPr>
-                        <a:t>81</a:t>
+                        <a:t>11.6 s (640 s)</a:t>
                       </a:r>
                       <a:endParaRPr lang="en-US" sz="1000" dirty="0">
                         <a:latin typeface="Calibri" charset="0"/>
@@ -4983,7 +4668,7 @@
                           <a:ea typeface="Calibri" pitchFamily="34" charset="-122"/>
                           <a:cs typeface="Calibri" pitchFamily="34" charset="-120"/>
                         </a:rPr>
-                        <a:t>5 / 24 / 52</a:t>
+                        <a:t>30 / 12 / 39</a:t>
                       </a:r>
                       <a:endParaRPr lang="en-US" sz="1000" dirty="0">
                         <a:latin typeface="Calibri" charset="0"/>
@@ -5187,7 +4872,7 @@
                           <a:ea typeface="Calibri" pitchFamily="34" charset="-122"/>
                           <a:cs typeface="Calibri" pitchFamily="34" charset="-120"/>
                         </a:rPr>
-                        <a:t>23 / 1 / 10</a:t>
+                        <a:t>18 / 4 / 12</a:t>
                       </a:r>
                       <a:endParaRPr lang="en-US" sz="1000" dirty="0">
                         <a:latin typeface="Calibri" charset="0"/>
@@ -5325,7 +5010,7 @@
                           <a:ea typeface="Calibri" pitchFamily="34" charset="-122"/>
                           <a:cs typeface="Calibri" pitchFamily="34" charset="-120"/>
                         </a:rPr>
-                        <a:t>pfSense XML</a:t>
+                        <a:t>57</a:t>
                       </a:r>
                       <a:endParaRPr lang="en-US" sz="1000" dirty="0">
                         <a:latin typeface="Calibri" charset="0"/>
@@ -5393,7 +5078,7 @@
                           <a:ea typeface="Calibri" pitchFamily="34" charset="-122"/>
                           <a:cs typeface="Calibri" pitchFamily="34" charset="-120"/>
                         </a:rPr>
-                        <a:t>57</a:t>
+                        <a:t>11.1 s (284 s)</a:t>
                       </a:r>
                       <a:endParaRPr lang="en-US" sz="1000" dirty="0">
                         <a:latin typeface="Calibri" charset="0"/>
@@ -5461,7 +5146,7 @@
                           <a:ea typeface="Calibri" pitchFamily="34" charset="-122"/>
                           <a:cs typeface="Calibri" pitchFamily="34" charset="-120"/>
                         </a:rPr>
-                        <a:t>3 / 8 / 46</a:t>
+                        <a:t>28 / 5 / 24</a:t>
                       </a:r>
                       <a:endParaRPr lang="en-US" sz="1000" dirty="0">
                         <a:latin typeface="Calibri" charset="0"/>
@@ -5665,7 +5350,7 @@
                           <a:ea typeface="Calibri" pitchFamily="34" charset="-122"/>
                           <a:cs typeface="Calibri" pitchFamily="34" charset="-120"/>
                         </a:rPr>
-                        <a:t>14 / 0 / 4</a:t>
+                        <a:t>12 / 0 / 6</a:t>
                       </a:r>
                       <a:endParaRPr lang="en-US" sz="1000" dirty="0">
                         <a:latin typeface="Calibri" charset="0"/>
@@ -5803,7 +5488,7 @@
                           <a:ea typeface="Calibri" pitchFamily="34" charset="-122"/>
                           <a:cs typeface="Calibri" pitchFamily="34" charset="-120"/>
                         </a:rPr>
-                        <a:t>SONiC JSON</a:t>
+                        <a:t>70</a:t>
                       </a:r>
                       <a:endParaRPr lang="en-US" sz="1000" dirty="0">
                         <a:latin typeface="Calibri" charset="0"/>
@@ -5871,7 +5556,7 @@
                           <a:ea typeface="Calibri" pitchFamily="34" charset="-122"/>
                           <a:cs typeface="Calibri" pitchFamily="34" charset="-120"/>
                         </a:rPr>
-                        <a:t>70</a:t>
+                        <a:t>15.7 s (713 s)</a:t>
                       </a:r>
                       <a:endParaRPr lang="en-US" sz="1000" dirty="0">
                         <a:latin typeface="Calibri" charset="0"/>
@@ -5939,7 +5624,7 @@
                           <a:ea typeface="Calibri" pitchFamily="34" charset="-122"/>
                           <a:cs typeface="Calibri" pitchFamily="34" charset="-120"/>
                         </a:rPr>
-                        <a:t>0 / 21 / 49</a:t>
+                        <a:t>29 / 10 / 31</a:t>
                       </a:r>
                       <a:endParaRPr lang="en-US" sz="1000" dirty="0">
                         <a:latin typeface="Calibri" charset="0"/>
@@ -6143,7 +5828,7 @@
                           <a:ea typeface="Calibri" pitchFamily="34" charset="-122"/>
                           <a:cs typeface="Calibri" pitchFamily="34" charset="-120"/>
                         </a:rPr>
-                        <a:t>4 / 2 / 7</a:t>
+                        <a:t>1 / 2 / 10</a:t>
                       </a:r>
                       <a:endParaRPr lang="en-US" sz="1000" dirty="0">
                         <a:latin typeface="Calibri" charset="0"/>
@@ -6281,7 +5966,7 @@
                           <a:ea typeface="Calibri" pitchFamily="34" charset="-122"/>
                           <a:cs typeface="Calibri" pitchFamily="34" charset="-120"/>
                         </a:rPr>
-                        <a:t>Cisco CLI</a:t>
+                        <a:t>55</a:t>
                       </a:r>
                       <a:endParaRPr lang="en-US" sz="1000" dirty="0">
                         <a:latin typeface="Calibri" charset="0"/>
@@ -6349,7 +6034,7 @@
                           <a:ea typeface="Calibri" pitchFamily="34" charset="-122"/>
                           <a:cs typeface="Calibri" pitchFamily="34" charset="-120"/>
                         </a:rPr>
-                        <a:t>55</a:t>
+                        <a:t>12.6 s (387 s)</a:t>
                       </a:r>
                       <a:endParaRPr lang="en-US" sz="1000" dirty="0">
                         <a:latin typeface="Calibri" charset="0"/>
@@ -6417,7 +6102,7 @@
                           <a:ea typeface="Calibri" pitchFamily="34" charset="-122"/>
                           <a:cs typeface="Calibri" pitchFamily="34" charset="-120"/>
                         </a:rPr>
-                        <a:t>2 / 13 / 40</a:t>
+                        <a:t>36 / 7 / 12</a:t>
                       </a:r>
                       <a:endParaRPr lang="en-US" sz="1000" dirty="0">
                         <a:latin typeface="Calibri" charset="0"/>
@@ -6621,7 +6306,7 @@
                           <a:ea typeface="Calibri" pitchFamily="34" charset="-122"/>
                           <a:cs typeface="Calibri" pitchFamily="34" charset="-120"/>
                         </a:rPr>
-                        <a:t>5 / 10 / 19</a:t>
+                        <a:t>2 / 10 / 22</a:t>
                       </a:r>
                       <a:endParaRPr lang="en-US" sz="1000" dirty="0">
                         <a:latin typeface="Calibri" charset="0"/>
@@ -6691,75 +6376,7 @@
                           <a:ea typeface="Calibri" pitchFamily="34" charset="-122"/>
                           <a:cs typeface="Calibri" pitchFamily="34" charset="-120"/>
                         </a:rPr>
-                        <a:t>05 · Arista vEOS</a:t>
-                      </a:r>
-                      <a:endParaRPr lang="en-US" sz="1000" dirty="0">
-                        <a:latin typeface="Calibri" charset="0"/>
-                        <a:ea typeface="Calibri" charset="0"/>
-                        <a:cs typeface="Calibri" charset="0"/>
-                      </a:endParaRPr>
-                    </a:p>
-                  </a:txBody>
-                  <a:tcPr marL="45720" marR="45720" marT="45720" marB="45720" anchor="ctr">
-                    <a:lnL w="6350" cap="flat" cmpd="sng" algn="ctr">
-                      <a:solidFill>
-                        <a:srgbClr val="CBD5E1"/>
-                      </a:solidFill>
-                      <a:prstDash val="solid"/>
-                      <a:round/>
-                      <a:headEnd type="none" w="med" len="med"/>
-                      <a:tailEnd type="none" w="med" len="med"/>
-                    </a:lnL>
-                    <a:lnR w="6350" cap="flat" cmpd="sng" algn="ctr">
-                      <a:solidFill>
-                        <a:srgbClr val="CBD5E1"/>
-                      </a:solidFill>
-                      <a:prstDash val="solid"/>
-                      <a:round/>
-                      <a:headEnd type="none" w="med" len="med"/>
-                      <a:tailEnd type="none" w="med" len="med"/>
-                    </a:lnR>
-                    <a:lnT w="6350" cap="flat" cmpd="sng" algn="ctr">
-                      <a:solidFill>
-                        <a:srgbClr val="CBD5E1"/>
-                      </a:solidFill>
-                      <a:prstDash val="solid"/>
-                      <a:round/>
-                      <a:headEnd type="none" w="med" len="med"/>
-                      <a:tailEnd type="none" w="med" len="med"/>
-                    </a:lnT>
-                    <a:lnB w="6350" cap="flat" cmpd="sng" algn="ctr">
-                      <a:solidFill>
-                        <a:srgbClr val="CBD5E1"/>
-                      </a:solidFill>
-                      <a:prstDash val="solid"/>
-                      <a:round/>
-                      <a:headEnd type="none" w="med" len="med"/>
-                      <a:tailEnd type="none" w="med" len="med"/>
-                    </a:lnB>
-                    <a:solidFill>
-                      <a:srgbClr val="FFFFFF"/>
-                    </a:solidFill>
-                  </a:tcPr>
-                </a:tc>
-                <a:tc>
-                  <a:txBody>
-                    <a:bodyPr/>
-                    <a:lstStyle/>
-                    <a:p>
-                      <a:pPr indent="0" marL="0">
-                        <a:buNone/>
-                      </a:pPr>
-                      <a:r>
-                        <a:rPr lang="en-US" sz="1000" dirty="0">
-                          <a:solidFill>
-                            <a:srgbClr val="1E293B"/>
-                          </a:solidFill>
-                          <a:latin typeface="Calibri" pitchFamily="34" charset="0"/>
-                          <a:ea typeface="Calibri" pitchFamily="34" charset="-122"/>
-                          <a:cs typeface="Calibri" pitchFamily="34" charset="-120"/>
-                        </a:rPr>
-                        <a:t>Unknown vendor</a:t>
+                        <a:t>05 · Arista vEOS (unknown)</a:t>
                       </a:r>
                       <a:endParaRPr lang="en-US" sz="1000" dirty="0">
                         <a:latin typeface="Calibri" charset="0"/>
@@ -6895,7 +6512,75 @@
                           <a:ea typeface="Calibri" pitchFamily="34" charset="-122"/>
                           <a:cs typeface="Calibri" pitchFamily="34" charset="-120"/>
                         </a:rPr>
-                        <a:t>0 / 6 / 12</a:t>
+                        <a:t>8.4 s (120 s)</a:t>
+                      </a:r>
+                      <a:endParaRPr lang="en-US" sz="1000" dirty="0">
+                        <a:latin typeface="Calibri" charset="0"/>
+                        <a:ea typeface="Calibri" charset="0"/>
+                        <a:cs typeface="Calibri" charset="0"/>
+                      </a:endParaRPr>
+                    </a:p>
+                  </a:txBody>
+                  <a:tcPr marL="45720" marR="45720" marT="45720" marB="45720" anchor="ctr">
+                    <a:lnL w="6350" cap="flat" cmpd="sng" algn="ctr">
+                      <a:solidFill>
+                        <a:srgbClr val="CBD5E1"/>
+                      </a:solidFill>
+                      <a:prstDash val="solid"/>
+                      <a:round/>
+                      <a:headEnd type="none" w="med" len="med"/>
+                      <a:tailEnd type="none" w="med" len="med"/>
+                    </a:lnL>
+                    <a:lnR w="6350" cap="flat" cmpd="sng" algn="ctr">
+                      <a:solidFill>
+                        <a:srgbClr val="CBD5E1"/>
+                      </a:solidFill>
+                      <a:prstDash val="solid"/>
+                      <a:round/>
+                      <a:headEnd type="none" w="med" len="med"/>
+                      <a:tailEnd type="none" w="med" len="med"/>
+                    </a:lnR>
+                    <a:lnT w="6350" cap="flat" cmpd="sng" algn="ctr">
+                      <a:solidFill>
+                        <a:srgbClr val="CBD5E1"/>
+                      </a:solidFill>
+                      <a:prstDash val="solid"/>
+                      <a:round/>
+                      <a:headEnd type="none" w="med" len="med"/>
+                      <a:tailEnd type="none" w="med" len="med"/>
+                    </a:lnT>
+                    <a:lnB w="6350" cap="flat" cmpd="sng" algn="ctr">
+                      <a:solidFill>
+                        <a:srgbClr val="CBD5E1"/>
+                      </a:solidFill>
+                      <a:prstDash val="solid"/>
+                      <a:round/>
+                      <a:headEnd type="none" w="med" len="med"/>
+                      <a:tailEnd type="none" w="med" len="med"/>
+                    </a:lnB>
+                    <a:solidFill>
+                      <a:srgbClr val="FFFFFF"/>
+                    </a:solidFill>
+                  </a:tcPr>
+                </a:tc>
+                <a:tc>
+                  <a:txBody>
+                    <a:bodyPr/>
+                    <a:lstStyle/>
+                    <a:p>
+                      <a:pPr indent="0" marL="0">
+                        <a:buNone/>
+                      </a:pPr>
+                      <a:r>
+                        <a:rPr lang="en-US" sz="1000" dirty="0">
+                          <a:solidFill>
+                            <a:srgbClr val="1E293B"/>
+                          </a:solidFill>
+                          <a:latin typeface="Calibri" pitchFamily="34" charset="0"/>
+                          <a:ea typeface="Calibri" pitchFamily="34" charset="-122"/>
+                          <a:cs typeface="Calibri" pitchFamily="34" charset="-120"/>
+                        </a:rPr>
+                        <a:t>0 / 5 / 13</a:t>
                       </a:r>
                       <a:endParaRPr lang="en-US" sz="1000" dirty="0">
                         <a:latin typeface="Calibri" charset="0"/>
@@ -7099,7 +6784,7 @@
                           <a:ea typeface="Calibri" pitchFamily="34" charset="-122"/>
                           <a:cs typeface="Calibri" pitchFamily="34" charset="-120"/>
                         </a:rPr>
-                        <a:t>2 / 0 / 11</a:t>
+                        <a:t>1 / 0 / 12</a:t>
                       </a:r>
                       <a:endParaRPr lang="en-US" sz="1000" dirty="0">
                         <a:latin typeface="Calibri" charset="0"/>
@@ -7237,7 +6922,7 @@
                           <a:ea typeface="Calibri" pitchFamily="34" charset="-122"/>
                           <a:cs typeface="Calibri" pitchFamily="34" charset="-120"/>
                         </a:rPr>
-                        <a:t>Cisco CLI</a:t>
+                        <a:t>64</a:t>
                       </a:r>
                       <a:endParaRPr lang="en-US" sz="1000" dirty="0">
                         <a:latin typeface="Calibri" charset="0"/>
@@ -7305,7 +6990,7 @@
                           <a:ea typeface="Calibri" pitchFamily="34" charset="-122"/>
                           <a:cs typeface="Calibri" pitchFamily="34" charset="-120"/>
                         </a:rPr>
-                        <a:t>64</a:t>
+                        <a:t>7.7 s (505 s)</a:t>
                       </a:r>
                       <a:endParaRPr lang="en-US" sz="1000" dirty="0">
                         <a:latin typeface="Calibri" charset="0"/>
@@ -7373,7 +7058,7 @@
                           <a:ea typeface="Calibri" pitchFamily="34" charset="-122"/>
                           <a:cs typeface="Calibri" pitchFamily="34" charset="-120"/>
                         </a:rPr>
-                        <a:t>7 / 21 / 36</a:t>
+                        <a:t>40 / 10 / 14</a:t>
                       </a:r>
                       <a:endParaRPr lang="en-US" sz="1000" dirty="0">
                         <a:latin typeface="Calibri" charset="0"/>
@@ -7577,7 +7262,7 @@
                           <a:ea typeface="Calibri" pitchFamily="34" charset="-122"/>
                           <a:cs typeface="Calibri" pitchFamily="34" charset="-120"/>
                         </a:rPr>
-                        <a:t>23 / 2 / 9</a:t>
+                        <a:t>19 / 1 / 14</a:t>
                       </a:r>
                       <a:endParaRPr lang="en-US" sz="1000" dirty="0">
                         <a:latin typeface="Calibri" charset="0"/>
@@ -7666,7 +7351,7 @@
                 <a:ea typeface="Calibri" pitchFamily="34" charset="-122"/>
                 <a:cs typeface="Calibri" pitchFamily="34" charset="-120"/>
               </a:rPr>
-              <a:t>Instant = Tier-1 knowledge-base match; AI = accepted Tier-2 classification; Human = sent to the review queue (mostly lines the AI judged not security-relevant, dismissable in one click). Unknown = the setting never appears in the config - reported, never assumed to pass. Device 06 contains the line a reviewer taught once after device 01: it resolved instantly.</a:t>
+              <a:t>Instant = knowledge-base match, including known non-security structure (no AI call). AI = accepted AI suggestion. Human = sent to the review queue. Unknown = the setting never appears in the config, so it is reported, never assumed to pass. Before = the same files on the one-call-per-line build.</a:t>
             </a:r>
             <a:endParaRPr lang="en-US" sz="1100" dirty="0"/>
           </a:p>
@@ -7732,7 +7417,7 @@
                 <a:ea typeface="Calibri" pitchFamily="34" charset="-122"/>
                 <a:cs typeface="Calibri" pitchFamily="34" charset="-120"/>
               </a:rPr>
-              <a:t>What running real configs caught - all fixed, each with a regression test</a:t>
+              <a:t>What running real configs caught: all fixed, each with a regression test</a:t>
             </a:r>
             <a:endParaRPr lang="en-US" sz="1200" dirty="0"/>
           </a:p>
@@ -7796,7 +7481,7 @@
                 <a:ea typeface="Calibri" pitchFamily="34" charset="-122"/>
                 <a:cs typeface="Calibri" pitchFamily="34" charset="-120"/>
               </a:rPr>
-              <a:t>A pfSense rule that BLOCKS telnet read as telnet enabled - rules are now reassembled into one ACL line</a:t>
+              <a:t>A pfSense rule that BLOCKS telnet read as telnet enabled; rules are now reassembled into one ACL line</a:t>
             </a:r>
             <a:endParaRPr lang="en-US" sz="1050" dirty="0"/>
           </a:p>
@@ -7817,7 +7502,7 @@
                 <a:ea typeface="Calibri" pitchFamily="34" charset="-122"/>
                 <a:cs typeface="Calibri" pitchFamily="34" charset="-120"/>
               </a:rPr>
-              <a:t>An AI guess overwriting a deterministic Tier-1 value; the ACL parser silently missing ports</a:t>
+              <a:t>An AI guess overwriting a deterministic value; an AI value 'public RO' that would have hidden a default community</a:t>
             </a:r>
             <a:endParaRPr lang="en-US" sz="1050" dirty="0"/>
           </a:p>
@@ -7838,7 +7523,7 @@
                 <a:ea typeface="Calibri" pitchFamily="34" charset="-122"/>
                 <a:cs typeface="Calibri" pitchFamily="34" charset="-120"/>
               </a:rPr>
-              <a:t>An LLM call with no timeout hanging a whole upload for 10+ minutes</a:t>
+              <a:t>One AI call per line (minutes per file) and a call with no timeout that hung an upload</a:t>
             </a:r>
             <a:endParaRPr lang="en-US" sz="1050" dirty="0"/>
           </a:p>
@@ -7943,7 +7628,7 @@
                 <a:ea typeface="Cambria" pitchFamily="34" charset="-122"/>
                 <a:cs typeface="Cambria" pitchFamily="34" charset="-120"/>
               </a:rPr>
-              <a:t>92%</a:t>
+              <a:t>95.8%</a:t>
             </a:r>
             <a:endParaRPr lang="en-US" sz="2400" dirty="0"/>
           </a:p>
@@ -8099,7 +7784,7 @@
                 <a:ea typeface="Cambria" pitchFamily="34" charset="-122"/>
                 <a:cs typeface="Cambria" pitchFamily="34" charset="-120"/>
               </a:rPr>
-              <a:t>2 of 33</a:t>
+              <a:t>1 of 33</a:t>
             </a:r>
             <a:endParaRPr lang="en-US" sz="2400" dirty="0"/>
           </a:p>
@@ -8177,7 +7862,7 @@
                 <a:ea typeface="Calibri" pitchFamily="34" charset="-122"/>
                 <a:cs typeface="Calibri" pitchFamily="34" charset="-120"/>
               </a:rPr>
-              <a:t>33 hand-labeled lines (24 settings + 9 negatives), live Groq/Gemini, 2026-09-25</a:t>
+              <a:t>33 hand-labeled lines (24 settings, 9 negatives), live batch mode, 2026-09-25</a:t>
             </a:r>
             <a:endParaRPr lang="en-US" sz="950" dirty="0"/>
           </a:p>
@@ -8720,7 +8405,7 @@
                 <a:ea typeface="Calibri" pitchFamily="34" charset="-122"/>
                 <a:cs typeface="Calibri" pitchFamily="34" charset="-120"/>
               </a:rPr>
-              <a:t>148 offline tests + CI; golden-set eval</a:t>
+              <a:t>160 offline tests + CI; golden-set eval</a:t>
             </a:r>
             <a:endParaRPr lang="en-US" sz="1300" dirty="0"/>
           </a:p>

</xml_diff>

<commit_message>
Diagram: one unified parser for any vendor
Co-Authored-By: Claude Opus 5.5 (1M context) <noreply@anthropic.com>
</commit_message>
<xml_diff>
--- a/docs/AEGIS-Technical-Presentation.pptx
+++ b/docs/AEGIS-Technical-Presentation.pptx
@@ -1287,7 +1287,7 @@
       </p:sp>
       <p:pic>
         <p:nvPicPr>
-          <p:cNvPr id="4" name="Image 0" descr="C:\Users\ADVAIT\SAVECODE\sih\documents\tech-deck\assets\sih2026.png">    </p:cNvPr>
+          <p:cNvPr id="4" name="Image 0" descr="documents\tech-deck\assets\sih2026.png">    </p:cNvPr>
           <p:cNvPicPr>
             <a:picLocks noChangeAspect="1"/>
           </p:cNvPicPr>
@@ -1311,7 +1311,7 @@
       </p:pic>
       <p:pic>
         <p:nvPicPr>
-          <p:cNvPr id="5" name="Image 1" descr="C:\Users\ADVAIT\SAVECODE\sih\documents\tech-deck\assets\six_origins.png">    </p:cNvPr>
+          <p:cNvPr id="5" name="Image 1" descr="documents\tech-deck\assets\six_origins.png">    </p:cNvPr>
           <p:cNvPicPr>
             <a:picLocks noChangeAspect="1"/>
           </p:cNvPicPr>
@@ -2200,7 +2200,7 @@
       </p:grpSpPr>
       <p:pic>
         <p:nvPicPr>
-          <p:cNvPr id="2" name="Image 0" descr="C:\Users\ADVAIT\SAVECODE\sih\documents\tech-deck\assets\sih2026.png">    </p:cNvPr>
+          <p:cNvPr id="2" name="Image 0" descr="documents\tech-deck\assets\sih2026.png">    </p:cNvPr>
           <p:cNvPicPr>
             <a:picLocks noChangeAspect="1"/>
           </p:cNvPicPr>
@@ -2224,7 +2224,7 @@
       </p:pic>
       <p:pic>
         <p:nvPicPr>
-          <p:cNvPr id="3" name="Image 1" descr="C:\Users\ADVAIT\SAVECODE\sih\documents\tech-deck\assets\six_origins.png">    </p:cNvPr>
+          <p:cNvPr id="3" name="Image 1" descr="documents\tech-deck\assets\six_origins.png">    </p:cNvPr>
           <p:cNvPicPr>
             <a:picLocks noChangeAspect="1"/>
           </p:cNvPicPr>
@@ -2365,7 +2365,7 @@
       </p:sp>
       <p:pic>
         <p:nvPicPr>
-          <p:cNvPr id="7" name="Image 2" descr="C:\Users\ADVAIT\SAVECODE\sih\documents\tech-deck\assets\architecture-phases.png">    </p:cNvPr>
+          <p:cNvPr id="7" name="Image 2" descr="documents\tech-deck\assets\architecture-phases.png">    </p:cNvPr>
           <p:cNvPicPr>
             <a:picLocks noChangeAspect="1"/>
           </p:cNvPicPr>
@@ -2421,7 +2421,7 @@
       </p:grpSpPr>
       <p:pic>
         <p:nvPicPr>
-          <p:cNvPr id="2" name="Image 0" descr="C:\Users\ADVAIT\SAVECODE\sih\documents\tech-deck\assets\sih2026.png">    </p:cNvPr>
+          <p:cNvPr id="2" name="Image 0" descr="documents\tech-deck\assets\sih2026.png">    </p:cNvPr>
           <p:cNvPicPr>
             <a:picLocks noChangeAspect="1"/>
           </p:cNvPicPr>
@@ -2445,7 +2445,7 @@
       </p:pic>
       <p:pic>
         <p:nvPicPr>
-          <p:cNvPr id="3" name="Image 1" descr="C:\Users\ADVAIT\SAVECODE\sih\documents\tech-deck\assets\six_origins.png">    </p:cNvPr>
+          <p:cNvPr id="3" name="Image 1" descr="documents\tech-deck\assets\six_origins.png">    </p:cNvPr>
           <p:cNvPicPr>
             <a:picLocks noChangeAspect="1"/>
           </p:cNvPicPr>
@@ -3774,7 +3774,7 @@
       </p:grpSpPr>
       <p:pic>
         <p:nvPicPr>
-          <p:cNvPr id="2" name="Image 0" descr="C:\Users\ADVAIT\SAVECODE\sih\documents\tech-deck\assets\sih2026.png">    </p:cNvPr>
+          <p:cNvPr id="2" name="Image 0" descr="documents\tech-deck\assets\sih2026.png">    </p:cNvPr>
           <p:cNvPicPr>
             <a:picLocks noChangeAspect="1"/>
           </p:cNvPicPr>
@@ -3798,7 +3798,7 @@
       </p:pic>
       <p:pic>
         <p:nvPicPr>
-          <p:cNvPr id="3" name="Image 1" descr="C:\Users\ADVAIT\SAVECODE\sih\documents\tech-deck\assets\six_origins.png">    </p:cNvPr>
+          <p:cNvPr id="3" name="Image 1" descr="documents\tech-deck\assets\six_origins.png">    </p:cNvPr>
           <p:cNvPicPr>
             <a:picLocks noChangeAspect="1"/>
           </p:cNvPicPr>
@@ -7870,7 +7870,7 @@
       </p:sp>
       <p:pic>
         <p:nvPicPr>
-          <p:cNvPr id="21" name="Image 2" descr="C:\Users\ADVAIT\SAVECODE\sih\documents\tech-deck\assets\queue_shot.png">    </p:cNvPr>
+          <p:cNvPr id="21" name="Image 2" descr="documents\tech-deck\assets\queue_shot.png">    </p:cNvPr>
           <p:cNvPicPr>
             <a:picLocks noChangeAspect="1"/>
           </p:cNvPicPr>
@@ -8019,7 +8019,7 @@
       </p:sp>
       <p:pic>
         <p:nvPicPr>
-          <p:cNvPr id="4" name="Image 0" descr="C:\Users\ADVAIT\SAVECODE\sih\documents\tech-deck\assets\sih2026.png">    </p:cNvPr>
+          <p:cNvPr id="4" name="Image 0" descr="documents\tech-deck\assets\sih2026.png">    </p:cNvPr>
           <p:cNvPicPr>
             <a:picLocks noChangeAspect="1"/>
           </p:cNvPicPr>
@@ -8043,7 +8043,7 @@
       </p:pic>
       <p:pic>
         <p:nvPicPr>
-          <p:cNvPr id="5" name="Image 1" descr="C:\Users\ADVAIT\SAVECODE\sih\documents\tech-deck\assets\six_origins.png">    </p:cNvPr>
+          <p:cNvPr id="5" name="Image 1" descr="documents\tech-deck\assets\six_origins.png">    </p:cNvPr>
           <p:cNvPicPr>
             <a:picLocks noChangeAspect="1"/>
           </p:cNvPicPr>

</xml_diff>

<commit_message>
Decks and diagrams match the build: tech deck with live 8-device run and verdict ground truth; 13 secret types
Co-Authored-By: Claude Opus 5.5 (1M context) <noreply@anthropic.com>
</commit_message>
<xml_diff>
--- a/docs/AEGIS-Technical-Presentation.pptx
+++ b/docs/AEGIS-Technical-Presentation.pptx
@@ -1584,7 +1584,7 @@
                 <a:ea typeface="Calibri" pitchFamily="34" charset="-122"/>
                 <a:cs typeface="Calibri" pitchFamily="34" charset="-120"/>
               </a:rPr>
-              <a:t>Exactly one parser: a lookup against one knowledge base. A known vendor is a cache hit; unseen syntax is asked of a human once, then recognized instantly on every future device, with no code change or redeploy.</a:t>
+              <a:t>One resolution path for every vendor: a lookup against one knowledge base. A vendor is a data file (Juniper and FortiGate were added with no code); unseen syntax is asked of a human once, then recognized instantly on every future device.</a:t>
             </a:r>
             <a:endParaRPr lang="en-US" sz="1600" dirty="0"/>
           </a:p>
@@ -1689,7 +1689,7 @@
                 <a:ea typeface="Calibri" pitchFamily="34" charset="-122"/>
                 <a:cs typeface="Calibri" pitchFamily="34" charset="-120"/>
               </a:rPr>
-              <a:t>cited rules</a:t>
+              <a:t>rules</a:t>
             </a:r>
             <a:endParaRPr lang="en-US" sz="1500" dirty="0"/>
           </a:p>
@@ -1794,7 +1794,7 @@
                 <a:ea typeface="Cambria" pitchFamily="34" charset="-122"/>
                 <a:cs typeface="Cambria" pitchFamily="34" charset="-120"/>
               </a:rPr>
-              <a:t>11</a:t>
+              <a:t>13</a:t>
             </a:r>
             <a:endParaRPr lang="en-US" sz="4400" dirty="0"/>
           </a:p>
@@ -1938,7 +1938,7 @@
                 <a:ea typeface="Cambria" pitchFamily="34" charset="-122"/>
                 <a:cs typeface="Cambria" pitchFamily="34" charset="-120"/>
               </a:rPr>
-              <a:t>160</a:t>
+              <a:t>240</a:t>
             </a:r>
             <a:endParaRPr lang="en-US" sz="4400" dirty="0"/>
           </a:p>
@@ -2082,7 +2082,7 @@
                 <a:ea typeface="Cambria" pitchFamily="34" charset="-122"/>
                 <a:cs typeface="Cambria" pitchFamily="34" charset="-120"/>
               </a:rPr>
-              <a:t>4</a:t>
+              <a:t>6</a:t>
             </a:r>
             <a:endParaRPr lang="en-US" sz="4400" dirty="0"/>
           </a:p>
@@ -2121,7 +2121,7 @@
                 <a:ea typeface="Calibri" pitchFamily="34" charset="-122"/>
                 <a:cs typeface="Calibri" pitchFamily="34" charset="-120"/>
               </a:rPr>
-              <a:t>config formats</a:t>
+              <a:t>vendor families</a:t>
             </a:r>
             <a:endParaRPr lang="en-US" sz="1500" dirty="0"/>
           </a:p>
@@ -2160,7 +2160,7 @@
                 <a:ea typeface="Calibri" pitchFamily="34" charset="-122"/>
                 <a:cs typeface="Calibri" pitchFamily="34" charset="-120"/>
               </a:rPr>
-              <a:t>Cisco CLI · pfSense XML · SONiC JSON · unknown vendors</a:t>
+              <a:t>Cisco · pfSense · SONiC · Junos · FortiOS · unknown vendors</a:t>
             </a:r>
             <a:endParaRPr lang="en-US" sz="1100" dirty="0"/>
           </a:p>
@@ -3853,7 +3853,7 @@
                 <a:ea typeface="Cambria" pitchFamily="34" charset="-122"/>
                 <a:cs typeface="Cambria" pitchFamily="34" charset="-120"/>
               </a:rPr>
-              <a:t>Measured on real public configs</a:t>
+              <a:t>Measured live, and against ground truth</a:t>
             </a:r>
             <a:endParaRPr lang="en-US" sz="3000" dirty="0"/>
           </a:p>
@@ -3968,7 +3968,7 @@
                 <a:gridCol w="731520"/>
                 <a:gridCol w="1005840"/>
               </a:tblGrid>
-              <a:tr h="384048">
+              <a:tr h="301752">
                 <a:tc>
                   <a:txBody>
                     <a:bodyPr/>
@@ -3978,7 +3978,7 @@
                         <a:buNone/>
                       </a:pPr>
                       <a:r>
-                        <a:rPr lang="en-US" sz="1000" b="1" dirty="0">
+                        <a:rPr lang="en-US" sz="900" b="1" dirty="0">
                           <a:solidFill>
                             <a:srgbClr val="FFFFFF"/>
                           </a:solidFill>
@@ -3988,14 +3988,14 @@
                         </a:rPr>
                         <a:t>Device</a:t>
                       </a:r>
-                      <a:endParaRPr lang="en-US" sz="1000" dirty="0">
+                      <a:endParaRPr lang="en-US" sz="900" dirty="0">
                         <a:latin typeface="Calibri" charset="0"/>
                         <a:ea typeface="Calibri" charset="0"/>
                         <a:cs typeface="Calibri" charset="0"/>
                       </a:endParaRPr>
                     </a:p>
                   </a:txBody>
-                  <a:tcPr marL="45720" marR="45720" marT="45720" marB="45720" anchor="ctr">
+                  <a:tcPr marL="36576" marR="36576" marT="36576" marB="36576" anchor="ctr">
                     <a:lnL w="6350" cap="flat" cmpd="sng" algn="ctr">
                       <a:solidFill>
                         <a:srgbClr val="CBD5E1"/>
@@ -4046,7 +4046,7 @@
                         <a:buNone/>
                       </a:pPr>
                       <a:r>
-                        <a:rPr lang="en-US" sz="1000" b="1" dirty="0">
+                        <a:rPr lang="en-US" sz="900" b="1" dirty="0">
                           <a:solidFill>
                             <a:srgbClr val="FFFFFF"/>
                           </a:solidFill>
@@ -4056,14 +4056,14 @@
                         </a:rPr>
                         <a:t>Lines</a:t>
                       </a:r>
-                      <a:endParaRPr lang="en-US" sz="1000" dirty="0">
+                      <a:endParaRPr lang="en-US" sz="900" dirty="0">
                         <a:latin typeface="Calibri" charset="0"/>
                         <a:ea typeface="Calibri" charset="0"/>
                         <a:cs typeface="Calibri" charset="0"/>
                       </a:endParaRPr>
                     </a:p>
                   </a:txBody>
-                  <a:tcPr marL="45720" marR="45720" marT="45720" marB="45720" anchor="ctr">
+                  <a:tcPr marL="36576" marR="36576" marT="36576" marB="36576" anchor="ctr">
                     <a:lnL w="6350" cap="flat" cmpd="sng" algn="ctr">
                       <a:solidFill>
                         <a:srgbClr val="CBD5E1"/>
@@ -4114,7 +4114,7 @@
                         <a:buNone/>
                       </a:pPr>
                       <a:r>
-                        <a:rPr lang="en-US" sz="1000" b="1" dirty="0">
+                        <a:rPr lang="en-US" sz="900" b="1" dirty="0">
                           <a:solidFill>
                             <a:srgbClr val="FFFFFF"/>
                           </a:solidFill>
@@ -4124,14 +4124,14 @@
                         </a:rPr>
                         <a:t>Time (before)</a:t>
                       </a:r>
-                      <a:endParaRPr lang="en-US" sz="1000" dirty="0">
+                      <a:endParaRPr lang="en-US" sz="900" dirty="0">
                         <a:latin typeface="Calibri" charset="0"/>
                         <a:ea typeface="Calibri" charset="0"/>
                         <a:cs typeface="Calibri" charset="0"/>
                       </a:endParaRPr>
                     </a:p>
                   </a:txBody>
-                  <a:tcPr marL="45720" marR="45720" marT="45720" marB="45720" anchor="ctr">
+                  <a:tcPr marL="36576" marR="36576" marT="36576" marB="36576" anchor="ctr">
                     <a:lnL w="6350" cap="flat" cmpd="sng" algn="ctr">
                       <a:solidFill>
                         <a:srgbClr val="CBD5E1"/>
@@ -4182,7 +4182,7 @@
                         <a:buNone/>
                       </a:pPr>
                       <a:r>
-                        <a:rPr lang="en-US" sz="1000" b="1" dirty="0">
+                        <a:rPr lang="en-US" sz="900" b="1" dirty="0">
                           <a:solidFill>
                             <a:srgbClr val="FFFFFF"/>
                           </a:solidFill>
@@ -4192,14 +4192,14 @@
                         </a:rPr>
                         <a:t>Instant / AI / Human</a:t>
                       </a:r>
-                      <a:endParaRPr lang="en-US" sz="1000" dirty="0">
+                      <a:endParaRPr lang="en-US" sz="900" dirty="0">
                         <a:latin typeface="Calibri" charset="0"/>
                         <a:ea typeface="Calibri" charset="0"/>
                         <a:cs typeface="Calibri" charset="0"/>
                       </a:endParaRPr>
                     </a:p>
                   </a:txBody>
-                  <a:tcPr marL="45720" marR="45720" marT="45720" marB="45720" anchor="ctr">
+                  <a:tcPr marL="36576" marR="36576" marT="36576" marB="36576" anchor="ctr">
                     <a:lnL w="6350" cap="flat" cmpd="sng" algn="ctr">
                       <a:solidFill>
                         <a:srgbClr val="CBD5E1"/>
@@ -4250,7 +4250,7 @@
                         <a:buNone/>
                       </a:pPr>
                       <a:r>
-                        <a:rPr lang="en-US" sz="1000" b="1" dirty="0">
+                        <a:rPr lang="en-US" sz="900" b="1" dirty="0">
                           <a:solidFill>
                             <a:srgbClr val="FFFFFF"/>
                           </a:solidFill>
@@ -4260,14 +4260,14 @@
                         </a:rPr>
                         <a:t>Secrets</a:t>
                       </a:r>
-                      <a:endParaRPr lang="en-US" sz="1000" dirty="0">
+                      <a:endParaRPr lang="en-US" sz="900" dirty="0">
                         <a:latin typeface="Calibri" charset="0"/>
                         <a:ea typeface="Calibri" charset="0"/>
                         <a:cs typeface="Calibri" charset="0"/>
                       </a:endParaRPr>
                     </a:p>
                   </a:txBody>
-                  <a:tcPr marL="45720" marR="45720" marT="45720" marB="45720" anchor="ctr">
+                  <a:tcPr marL="36576" marR="36576" marT="36576" marB="36576" anchor="ctr">
                     <a:lnL w="6350" cap="flat" cmpd="sng" algn="ctr">
                       <a:solidFill>
                         <a:srgbClr val="CBD5E1"/>
@@ -4318,7 +4318,7 @@
                         <a:buNone/>
                       </a:pPr>
                       <a:r>
-                        <a:rPr lang="en-US" sz="1000" b="1" dirty="0">
+                        <a:rPr lang="en-US" sz="900" b="1" dirty="0">
                           <a:solidFill>
                             <a:srgbClr val="FFFFFF"/>
                           </a:solidFill>
@@ -4328,14 +4328,14 @@
                         </a:rPr>
                         <a:t>Attacks blocked</a:t>
                       </a:r>
-                      <a:endParaRPr lang="en-US" sz="1000" dirty="0">
+                      <a:endParaRPr lang="en-US" sz="900" dirty="0">
                         <a:latin typeface="Calibri" charset="0"/>
                         <a:ea typeface="Calibri" charset="0"/>
                         <a:cs typeface="Calibri" charset="0"/>
                       </a:endParaRPr>
                     </a:p>
                   </a:txBody>
-                  <a:tcPr marL="45720" marR="45720" marT="45720" marB="45720" anchor="ctr">
+                  <a:tcPr marL="36576" marR="36576" marT="36576" marB="36576" anchor="ctr">
                     <a:lnL w="6350" cap="flat" cmpd="sng" algn="ctr">
                       <a:solidFill>
                         <a:srgbClr val="CBD5E1"/>
@@ -4386,7 +4386,7 @@
                         <a:buNone/>
                       </a:pPr>
                       <a:r>
-                        <a:rPr lang="en-US" sz="1000" b="1" dirty="0">
+                        <a:rPr lang="en-US" sz="900" b="1" dirty="0">
                           <a:solidFill>
                             <a:srgbClr val="FFFFFF"/>
                           </a:solidFill>
@@ -4396,14 +4396,14 @@
                         </a:rPr>
                         <a:t>Pass / Fail / Unknown</a:t>
                       </a:r>
-                      <a:endParaRPr lang="en-US" sz="1000" dirty="0">
+                      <a:endParaRPr lang="en-US" sz="900" dirty="0">
                         <a:latin typeface="Calibri" charset="0"/>
                         <a:ea typeface="Calibri" charset="0"/>
                         <a:cs typeface="Calibri" charset="0"/>
                       </a:endParaRPr>
                     </a:p>
                   </a:txBody>
-                  <a:tcPr marL="45720" marR="45720" marT="45720" marB="45720" anchor="ctr">
+                  <a:tcPr marL="36576" marR="36576" marT="36576" marB="36576" anchor="ctr">
                     <a:lnL w="6350" cap="flat" cmpd="sng" algn="ctr">
                       <a:solidFill>
                         <a:srgbClr val="CBD5E1"/>
@@ -4446,7 +4446,7 @@
                   </a:tcPr>
                 </a:tc>
               </a:tr>
-              <a:tr h="384048">
+              <a:tr h="301752">
                 <a:tc>
                   <a:txBody>
                     <a:bodyPr/>
@@ -4456,7 +4456,7 @@
                         <a:buNone/>
                       </a:pPr>
                       <a:r>
-                        <a:rPr lang="en-US" sz="1000" dirty="0">
+                        <a:rPr lang="en-US" sz="900" dirty="0">
                           <a:solidFill>
                             <a:srgbClr val="1E293B"/>
                           </a:solidFill>
@@ -4466,14 +4466,14 @@
                         </a:rPr>
                         <a:t>01 · Cisco branch (hardened)</a:t>
                       </a:r>
-                      <a:endParaRPr lang="en-US" sz="1000" dirty="0">
+                      <a:endParaRPr lang="en-US" sz="900" dirty="0">
                         <a:latin typeface="Calibri" charset="0"/>
                         <a:ea typeface="Calibri" charset="0"/>
                         <a:cs typeface="Calibri" charset="0"/>
                       </a:endParaRPr>
                     </a:p>
                   </a:txBody>
-                  <a:tcPr marL="45720" marR="45720" marT="45720" marB="45720" anchor="ctr">
+                  <a:tcPr marL="36576" marR="36576" marT="36576" marB="36576" anchor="ctr">
                     <a:lnL w="6350" cap="flat" cmpd="sng" algn="ctr">
                       <a:solidFill>
                         <a:srgbClr val="CBD5E1"/>
@@ -4524,7 +4524,7 @@
                         <a:buNone/>
                       </a:pPr>
                       <a:r>
-                        <a:rPr lang="en-US" sz="1000" dirty="0">
+                        <a:rPr lang="en-US" sz="900" dirty="0">
                           <a:solidFill>
                             <a:srgbClr val="1E293B"/>
                           </a:solidFill>
@@ -4534,14 +4534,14 @@
                         </a:rPr>
                         <a:t>81</a:t>
                       </a:r>
-                      <a:endParaRPr lang="en-US" sz="1000" dirty="0">
+                      <a:endParaRPr lang="en-US" sz="900" dirty="0">
                         <a:latin typeface="Calibri" charset="0"/>
                         <a:ea typeface="Calibri" charset="0"/>
                         <a:cs typeface="Calibri" charset="0"/>
                       </a:endParaRPr>
                     </a:p>
                   </a:txBody>
-                  <a:tcPr marL="45720" marR="45720" marT="45720" marB="45720" anchor="ctr">
+                  <a:tcPr marL="36576" marR="36576" marT="36576" marB="36576" anchor="ctr">
                     <a:lnL w="6350" cap="flat" cmpd="sng" algn="ctr">
                       <a:solidFill>
                         <a:srgbClr val="CBD5E1"/>
@@ -4592,7 +4592,7 @@
                         <a:buNone/>
                       </a:pPr>
                       <a:r>
-                        <a:rPr lang="en-US" sz="1000" dirty="0">
+                        <a:rPr lang="en-US" sz="900" dirty="0">
                           <a:solidFill>
                             <a:srgbClr val="1E293B"/>
                           </a:solidFill>
@@ -4600,16 +4600,16 @@
                           <a:ea typeface="Calibri" pitchFamily="34" charset="-122"/>
                           <a:cs typeface="Calibri" pitchFamily="34" charset="-120"/>
                         </a:rPr>
-                        <a:t>11.6 s (640 s)</a:t>
+                        <a:t>14 s (640 s)</a:t>
                       </a:r>
-                      <a:endParaRPr lang="en-US" sz="1000" dirty="0">
+                      <a:endParaRPr lang="en-US" sz="900" dirty="0">
                         <a:latin typeface="Calibri" charset="0"/>
                         <a:ea typeface="Calibri" charset="0"/>
                         <a:cs typeface="Calibri" charset="0"/>
                       </a:endParaRPr>
                     </a:p>
                   </a:txBody>
-                  <a:tcPr marL="45720" marR="45720" marT="45720" marB="45720" anchor="ctr">
+                  <a:tcPr marL="36576" marR="36576" marT="36576" marB="36576" anchor="ctr">
                     <a:lnL w="6350" cap="flat" cmpd="sng" algn="ctr">
                       <a:solidFill>
                         <a:srgbClr val="CBD5E1"/>
@@ -4660,7 +4660,7 @@
                         <a:buNone/>
                       </a:pPr>
                       <a:r>
-                        <a:rPr lang="en-US" sz="1000" dirty="0">
+                        <a:rPr lang="en-US" sz="900" dirty="0">
                           <a:solidFill>
                             <a:srgbClr val="1E293B"/>
                           </a:solidFill>
@@ -4668,16 +4668,16 @@
                           <a:ea typeface="Calibri" pitchFamily="34" charset="-122"/>
                           <a:cs typeface="Calibri" pitchFamily="34" charset="-120"/>
                         </a:rPr>
-                        <a:t>30 / 12 / 39</a:t>
+                        <a:t>36 / 14 / 31</a:t>
                       </a:r>
-                      <a:endParaRPr lang="en-US" sz="1000" dirty="0">
+                      <a:endParaRPr lang="en-US" sz="900" dirty="0">
                         <a:latin typeface="Calibri" charset="0"/>
                         <a:ea typeface="Calibri" charset="0"/>
                         <a:cs typeface="Calibri" charset="0"/>
                       </a:endParaRPr>
                     </a:p>
                   </a:txBody>
-                  <a:tcPr marL="45720" marR="45720" marT="45720" marB="45720" anchor="ctr">
+                  <a:tcPr marL="36576" marR="36576" marT="36576" marB="36576" anchor="ctr">
                     <a:lnL w="6350" cap="flat" cmpd="sng" algn="ctr">
                       <a:solidFill>
                         <a:srgbClr val="CBD5E1"/>
@@ -4728,7 +4728,7 @@
                         <a:buNone/>
                       </a:pPr>
                       <a:r>
-                        <a:rPr lang="en-US" sz="1000" dirty="0">
+                        <a:rPr lang="en-US" sz="900" dirty="0">
                           <a:solidFill>
                             <a:srgbClr val="1E293B"/>
                           </a:solidFill>
@@ -4738,14 +4738,14 @@
                         </a:rPr>
                         <a:t>6</a:t>
                       </a:r>
-                      <a:endParaRPr lang="en-US" sz="1000" dirty="0">
+                      <a:endParaRPr lang="en-US" sz="900" dirty="0">
                         <a:latin typeface="Calibri" charset="0"/>
                         <a:ea typeface="Calibri" charset="0"/>
                         <a:cs typeface="Calibri" charset="0"/>
                       </a:endParaRPr>
                     </a:p>
                   </a:txBody>
-                  <a:tcPr marL="45720" marR="45720" marT="45720" marB="45720" anchor="ctr">
+                  <a:tcPr marL="36576" marR="36576" marT="36576" marB="36576" anchor="ctr">
                     <a:lnL w="6350" cap="flat" cmpd="sng" algn="ctr">
                       <a:solidFill>
                         <a:srgbClr val="CBD5E1"/>
@@ -4796,7 +4796,7 @@
                         <a:buNone/>
                       </a:pPr>
                       <a:r>
-                        <a:rPr lang="en-US" sz="1000" dirty="0">
+                        <a:rPr lang="en-US" sz="900" dirty="0">
                           <a:solidFill>
                             <a:srgbClr val="1E293B"/>
                           </a:solidFill>
@@ -4806,14 +4806,14 @@
                         </a:rPr>
                         <a:t>0</a:t>
                       </a:r>
-                      <a:endParaRPr lang="en-US" sz="1000" dirty="0">
+                      <a:endParaRPr lang="en-US" sz="900" dirty="0">
                         <a:latin typeface="Calibri" charset="0"/>
                         <a:ea typeface="Calibri" charset="0"/>
                         <a:cs typeface="Calibri" charset="0"/>
                       </a:endParaRPr>
                     </a:p>
                   </a:txBody>
-                  <a:tcPr marL="45720" marR="45720" marT="45720" marB="45720" anchor="ctr">
+                  <a:tcPr marL="36576" marR="36576" marT="36576" marB="36576" anchor="ctr">
                     <a:lnL w="6350" cap="flat" cmpd="sng" algn="ctr">
                       <a:solidFill>
                         <a:srgbClr val="CBD5E1"/>
@@ -4864,7 +4864,7 @@
                         <a:buNone/>
                       </a:pPr>
                       <a:r>
-                        <a:rPr lang="en-US" sz="1000" dirty="0">
+                        <a:rPr lang="en-US" sz="900" dirty="0">
                           <a:solidFill>
                             <a:srgbClr val="1E293B"/>
                           </a:solidFill>
@@ -4872,16 +4872,16 @@
                           <a:ea typeface="Calibri" pitchFamily="34" charset="-122"/>
                           <a:cs typeface="Calibri" pitchFamily="34" charset="-120"/>
                         </a:rPr>
-                        <a:t>18 / 4 / 12</a:t>
+                        <a:t>15 / 7 / 12</a:t>
                       </a:r>
-                      <a:endParaRPr lang="en-US" sz="1000" dirty="0">
+                      <a:endParaRPr lang="en-US" sz="900" dirty="0">
                         <a:latin typeface="Calibri" charset="0"/>
                         <a:ea typeface="Calibri" charset="0"/>
                         <a:cs typeface="Calibri" charset="0"/>
                       </a:endParaRPr>
                     </a:p>
                   </a:txBody>
-                  <a:tcPr marL="45720" marR="45720" marT="45720" marB="45720" anchor="ctr">
+                  <a:tcPr marL="36576" marR="36576" marT="36576" marB="36576" anchor="ctr">
                     <a:lnL w="6350" cap="flat" cmpd="sng" algn="ctr">
                       <a:solidFill>
                         <a:srgbClr val="CBD5E1"/>
@@ -4924,7 +4924,7 @@
                   </a:tcPr>
                 </a:tc>
               </a:tr>
-              <a:tr h="384048">
+              <a:tr h="301752">
                 <a:tc>
                   <a:txBody>
                     <a:bodyPr/>
@@ -4934,7 +4934,7 @@
                         <a:buNone/>
                       </a:pPr>
                       <a:r>
-                        <a:rPr lang="en-US" sz="1000" dirty="0">
+                        <a:rPr lang="en-US" sz="900" dirty="0">
                           <a:solidFill>
                             <a:srgbClr val="1E293B"/>
                           </a:solidFill>
@@ -4944,14 +4944,14 @@
                         </a:rPr>
                         <a:t>02 · pfSense HQ firewall</a:t>
                       </a:r>
-                      <a:endParaRPr lang="en-US" sz="1000" dirty="0">
+                      <a:endParaRPr lang="en-US" sz="900" dirty="0">
                         <a:latin typeface="Calibri" charset="0"/>
                         <a:ea typeface="Calibri" charset="0"/>
                         <a:cs typeface="Calibri" charset="0"/>
                       </a:endParaRPr>
                     </a:p>
                   </a:txBody>
-                  <a:tcPr marL="45720" marR="45720" marT="45720" marB="45720" anchor="ctr">
+                  <a:tcPr marL="36576" marR="36576" marT="36576" marB="36576" anchor="ctr">
                     <a:lnL w="6350" cap="flat" cmpd="sng" algn="ctr">
                       <a:solidFill>
                         <a:srgbClr val="CBD5E1"/>
@@ -5002,7 +5002,7 @@
                         <a:buNone/>
                       </a:pPr>
                       <a:r>
-                        <a:rPr lang="en-US" sz="1000" dirty="0">
+                        <a:rPr lang="en-US" sz="900" dirty="0">
                           <a:solidFill>
                             <a:srgbClr val="1E293B"/>
                           </a:solidFill>
@@ -5012,14 +5012,14 @@
                         </a:rPr>
                         <a:t>57</a:t>
                       </a:r>
-                      <a:endParaRPr lang="en-US" sz="1000" dirty="0">
+                      <a:endParaRPr lang="en-US" sz="900" dirty="0">
                         <a:latin typeface="Calibri" charset="0"/>
                         <a:ea typeface="Calibri" charset="0"/>
                         <a:cs typeface="Calibri" charset="0"/>
                       </a:endParaRPr>
                     </a:p>
                   </a:txBody>
-                  <a:tcPr marL="45720" marR="45720" marT="45720" marB="45720" anchor="ctr">
+                  <a:tcPr marL="36576" marR="36576" marT="36576" marB="36576" anchor="ctr">
                     <a:lnL w="6350" cap="flat" cmpd="sng" algn="ctr">
                       <a:solidFill>
                         <a:srgbClr val="CBD5E1"/>
@@ -5070,7 +5070,7 @@
                         <a:buNone/>
                       </a:pPr>
                       <a:r>
-                        <a:rPr lang="en-US" sz="1000" dirty="0">
+                        <a:rPr lang="en-US" sz="900" dirty="0">
                           <a:solidFill>
                             <a:srgbClr val="1E293B"/>
                           </a:solidFill>
@@ -5078,16 +5078,16 @@
                           <a:ea typeface="Calibri" pitchFamily="34" charset="-122"/>
                           <a:cs typeface="Calibri" pitchFamily="34" charset="-120"/>
                         </a:rPr>
-                        <a:t>11.1 s (284 s)</a:t>
+                        <a:t>11.5 s (284 s)</a:t>
                       </a:r>
-                      <a:endParaRPr lang="en-US" sz="1000" dirty="0">
+                      <a:endParaRPr lang="en-US" sz="900" dirty="0">
                         <a:latin typeface="Calibri" charset="0"/>
                         <a:ea typeface="Calibri" charset="0"/>
                         <a:cs typeface="Calibri" charset="0"/>
                       </a:endParaRPr>
                     </a:p>
                   </a:txBody>
-                  <a:tcPr marL="45720" marR="45720" marT="45720" marB="45720" anchor="ctr">
+                  <a:tcPr marL="36576" marR="36576" marT="36576" marB="36576" anchor="ctr">
                     <a:lnL w="6350" cap="flat" cmpd="sng" algn="ctr">
                       <a:solidFill>
                         <a:srgbClr val="CBD5E1"/>
@@ -5138,7 +5138,7 @@
                         <a:buNone/>
                       </a:pPr>
                       <a:r>
-                        <a:rPr lang="en-US" sz="1000" dirty="0">
+                        <a:rPr lang="en-US" sz="900" dirty="0">
                           <a:solidFill>
                             <a:srgbClr val="1E293B"/>
                           </a:solidFill>
@@ -5146,16 +5146,16 @@
                           <a:ea typeface="Calibri" pitchFamily="34" charset="-122"/>
                           <a:cs typeface="Calibri" pitchFamily="34" charset="-120"/>
                         </a:rPr>
-                        <a:t>28 / 5 / 24</a:t>
+                        <a:t>30 / 6 / 21</a:t>
                       </a:r>
-                      <a:endParaRPr lang="en-US" sz="1000" dirty="0">
+                      <a:endParaRPr lang="en-US" sz="900" dirty="0">
                         <a:latin typeface="Calibri" charset="0"/>
                         <a:ea typeface="Calibri" charset="0"/>
                         <a:cs typeface="Calibri" charset="0"/>
                       </a:endParaRPr>
                     </a:p>
                   </a:txBody>
-                  <a:tcPr marL="45720" marR="45720" marT="45720" marB="45720" anchor="ctr">
+                  <a:tcPr marL="36576" marR="36576" marT="36576" marB="36576" anchor="ctr">
                     <a:lnL w="6350" cap="flat" cmpd="sng" algn="ctr">
                       <a:solidFill>
                         <a:srgbClr val="CBD5E1"/>
@@ -5206,7 +5206,7 @@
                         <a:buNone/>
                       </a:pPr>
                       <a:r>
-                        <a:rPr lang="en-US" sz="1000" dirty="0">
+                        <a:rPr lang="en-US" sz="900" dirty="0">
                           <a:solidFill>
                             <a:srgbClr val="1E293B"/>
                           </a:solidFill>
@@ -5216,14 +5216,14 @@
                         </a:rPr>
                         <a:t>3</a:t>
                       </a:r>
-                      <a:endParaRPr lang="en-US" sz="1000" dirty="0">
+                      <a:endParaRPr lang="en-US" sz="900" dirty="0">
                         <a:latin typeface="Calibri" charset="0"/>
                         <a:ea typeface="Calibri" charset="0"/>
                         <a:cs typeface="Calibri" charset="0"/>
                       </a:endParaRPr>
                     </a:p>
                   </a:txBody>
-                  <a:tcPr marL="45720" marR="45720" marT="45720" marB="45720" anchor="ctr">
+                  <a:tcPr marL="36576" marR="36576" marT="36576" marB="36576" anchor="ctr">
                     <a:lnL w="6350" cap="flat" cmpd="sng" algn="ctr">
                       <a:solidFill>
                         <a:srgbClr val="CBD5E1"/>
@@ -5274,7 +5274,7 @@
                         <a:buNone/>
                       </a:pPr>
                       <a:r>
-                        <a:rPr lang="en-US" sz="1000" dirty="0">
+                        <a:rPr lang="en-US" sz="900" dirty="0">
                           <a:solidFill>
                             <a:srgbClr val="1E293B"/>
                           </a:solidFill>
@@ -5284,14 +5284,14 @@
                         </a:rPr>
                         <a:t>1</a:t>
                       </a:r>
-                      <a:endParaRPr lang="en-US" sz="1000" dirty="0">
+                      <a:endParaRPr lang="en-US" sz="900" dirty="0">
                         <a:latin typeface="Calibri" charset="0"/>
                         <a:ea typeface="Calibri" charset="0"/>
                         <a:cs typeface="Calibri" charset="0"/>
                       </a:endParaRPr>
                     </a:p>
                   </a:txBody>
-                  <a:tcPr marL="45720" marR="45720" marT="45720" marB="45720" anchor="ctr">
+                  <a:tcPr marL="36576" marR="36576" marT="36576" marB="36576" anchor="ctr">
                     <a:lnL w="6350" cap="flat" cmpd="sng" algn="ctr">
                       <a:solidFill>
                         <a:srgbClr val="CBD5E1"/>
@@ -5342,7 +5342,7 @@
                         <a:buNone/>
                       </a:pPr>
                       <a:r>
-                        <a:rPr lang="en-US" sz="1000" dirty="0">
+                        <a:rPr lang="en-US" sz="900" dirty="0">
                           <a:solidFill>
                             <a:srgbClr val="1E293B"/>
                           </a:solidFill>
@@ -5350,16 +5350,16 @@
                           <a:ea typeface="Calibri" pitchFamily="34" charset="-122"/>
                           <a:cs typeface="Calibri" pitchFamily="34" charset="-120"/>
                         </a:rPr>
-                        <a:t>12 / 0 / 6</a:t>
+                        <a:t>8 / 0 / 10</a:t>
                       </a:r>
-                      <a:endParaRPr lang="en-US" sz="1000" dirty="0">
+                      <a:endParaRPr lang="en-US" sz="900" dirty="0">
                         <a:latin typeface="Calibri" charset="0"/>
                         <a:ea typeface="Calibri" charset="0"/>
                         <a:cs typeface="Calibri" charset="0"/>
                       </a:endParaRPr>
                     </a:p>
                   </a:txBody>
-                  <a:tcPr marL="45720" marR="45720" marT="45720" marB="45720" anchor="ctr">
+                  <a:tcPr marL="36576" marR="36576" marT="36576" marB="36576" anchor="ctr">
                     <a:lnL w="6350" cap="flat" cmpd="sng" algn="ctr">
                       <a:solidFill>
                         <a:srgbClr val="CBD5E1"/>
@@ -5402,7 +5402,7 @@
                   </a:tcPr>
                 </a:tc>
               </a:tr>
-              <a:tr h="384048">
+              <a:tr h="301752">
                 <a:tc>
                   <a:txBody>
                     <a:bodyPr/>
@@ -5412,7 +5412,7 @@
                         <a:buNone/>
                       </a:pPr>
                       <a:r>
-                        <a:rPr lang="en-US" sz="1000" dirty="0">
+                        <a:rPr lang="en-US" sz="900" dirty="0">
                           <a:solidFill>
                             <a:srgbClr val="1E293B"/>
                           </a:solidFill>
@@ -5422,14 +5422,14 @@
                         </a:rPr>
                         <a:t>03 · SONiC spine linecard</a:t>
                       </a:r>
-                      <a:endParaRPr lang="en-US" sz="1000" dirty="0">
+                      <a:endParaRPr lang="en-US" sz="900" dirty="0">
                         <a:latin typeface="Calibri" charset="0"/>
                         <a:ea typeface="Calibri" charset="0"/>
                         <a:cs typeface="Calibri" charset="0"/>
                       </a:endParaRPr>
                     </a:p>
                   </a:txBody>
-                  <a:tcPr marL="45720" marR="45720" marT="45720" marB="45720" anchor="ctr">
+                  <a:tcPr marL="36576" marR="36576" marT="36576" marB="36576" anchor="ctr">
                     <a:lnL w="6350" cap="flat" cmpd="sng" algn="ctr">
                       <a:solidFill>
                         <a:srgbClr val="CBD5E1"/>
@@ -5480,7 +5480,7 @@
                         <a:buNone/>
                       </a:pPr>
                       <a:r>
-                        <a:rPr lang="en-US" sz="1000" dirty="0">
+                        <a:rPr lang="en-US" sz="900" dirty="0">
                           <a:solidFill>
                             <a:srgbClr val="1E293B"/>
                           </a:solidFill>
@@ -5490,14 +5490,14 @@
                         </a:rPr>
                         <a:t>70</a:t>
                       </a:r>
-                      <a:endParaRPr lang="en-US" sz="1000" dirty="0">
+                      <a:endParaRPr lang="en-US" sz="900" dirty="0">
                         <a:latin typeface="Calibri" charset="0"/>
                         <a:ea typeface="Calibri" charset="0"/>
                         <a:cs typeface="Calibri" charset="0"/>
                       </a:endParaRPr>
                     </a:p>
                   </a:txBody>
-                  <a:tcPr marL="45720" marR="45720" marT="45720" marB="45720" anchor="ctr">
+                  <a:tcPr marL="36576" marR="36576" marT="36576" marB="36576" anchor="ctr">
                     <a:lnL w="6350" cap="flat" cmpd="sng" algn="ctr">
                       <a:solidFill>
                         <a:srgbClr val="CBD5E1"/>
@@ -5548,7 +5548,7 @@
                         <a:buNone/>
                       </a:pPr>
                       <a:r>
-                        <a:rPr lang="en-US" sz="1000" dirty="0">
+                        <a:rPr lang="en-US" sz="900" dirty="0">
                           <a:solidFill>
                             <a:srgbClr val="1E293B"/>
                           </a:solidFill>
@@ -5556,16 +5556,16 @@
                           <a:ea typeface="Calibri" pitchFamily="34" charset="-122"/>
                           <a:cs typeface="Calibri" pitchFamily="34" charset="-120"/>
                         </a:rPr>
-                        <a:t>15.7 s (713 s)</a:t>
+                        <a:t>17 s (713 s)</a:t>
                       </a:r>
-                      <a:endParaRPr lang="en-US" sz="1000" dirty="0">
+                      <a:endParaRPr lang="en-US" sz="900" dirty="0">
                         <a:latin typeface="Calibri" charset="0"/>
                         <a:ea typeface="Calibri" charset="0"/>
                         <a:cs typeface="Calibri" charset="0"/>
                       </a:endParaRPr>
                     </a:p>
                   </a:txBody>
-                  <a:tcPr marL="45720" marR="45720" marT="45720" marB="45720" anchor="ctr">
+                  <a:tcPr marL="36576" marR="36576" marT="36576" marB="36576" anchor="ctr">
                     <a:lnL w="6350" cap="flat" cmpd="sng" algn="ctr">
                       <a:solidFill>
                         <a:srgbClr val="CBD5E1"/>
@@ -5616,7 +5616,7 @@
                         <a:buNone/>
                       </a:pPr>
                       <a:r>
-                        <a:rPr lang="en-US" sz="1000" dirty="0">
+                        <a:rPr lang="en-US" sz="900" dirty="0">
                           <a:solidFill>
                             <a:srgbClr val="1E293B"/>
                           </a:solidFill>
@@ -5626,14 +5626,14 @@
                         </a:rPr>
                         <a:t>29 / 10 / 31</a:t>
                       </a:r>
-                      <a:endParaRPr lang="en-US" sz="1000" dirty="0">
+                      <a:endParaRPr lang="en-US" sz="900" dirty="0">
                         <a:latin typeface="Calibri" charset="0"/>
                         <a:ea typeface="Calibri" charset="0"/>
                         <a:cs typeface="Calibri" charset="0"/>
                       </a:endParaRPr>
                     </a:p>
                   </a:txBody>
-                  <a:tcPr marL="45720" marR="45720" marT="45720" marB="45720" anchor="ctr">
+                  <a:tcPr marL="36576" marR="36576" marT="36576" marB="36576" anchor="ctr">
                     <a:lnL w="6350" cap="flat" cmpd="sng" algn="ctr">
                       <a:solidFill>
                         <a:srgbClr val="CBD5E1"/>
@@ -5684,7 +5684,7 @@
                         <a:buNone/>
                       </a:pPr>
                       <a:r>
-                        <a:rPr lang="en-US" sz="1000" dirty="0">
+                        <a:rPr lang="en-US" sz="900" dirty="0">
                           <a:solidFill>
                             <a:srgbClr val="1E293B"/>
                           </a:solidFill>
@@ -5694,14 +5694,14 @@
                         </a:rPr>
                         <a:t>0</a:t>
                       </a:r>
-                      <a:endParaRPr lang="en-US" sz="1000" dirty="0">
+                      <a:endParaRPr lang="en-US" sz="900" dirty="0">
                         <a:latin typeface="Calibri" charset="0"/>
                         <a:ea typeface="Calibri" charset="0"/>
                         <a:cs typeface="Calibri" charset="0"/>
                       </a:endParaRPr>
                     </a:p>
                   </a:txBody>
-                  <a:tcPr marL="45720" marR="45720" marT="45720" marB="45720" anchor="ctr">
+                  <a:tcPr marL="36576" marR="36576" marT="36576" marB="36576" anchor="ctr">
                     <a:lnL w="6350" cap="flat" cmpd="sng" algn="ctr">
                       <a:solidFill>
                         <a:srgbClr val="CBD5E1"/>
@@ -5752,7 +5752,7 @@
                         <a:buNone/>
                       </a:pPr>
                       <a:r>
-                        <a:rPr lang="en-US" sz="1000" dirty="0">
+                        <a:rPr lang="en-US" sz="900" dirty="0">
                           <a:solidFill>
                             <a:srgbClr val="1E293B"/>
                           </a:solidFill>
@@ -5762,14 +5762,14 @@
                         </a:rPr>
                         <a:t>0</a:t>
                       </a:r>
-                      <a:endParaRPr lang="en-US" sz="1000" dirty="0">
+                      <a:endParaRPr lang="en-US" sz="900" dirty="0">
                         <a:latin typeface="Calibri" charset="0"/>
                         <a:ea typeface="Calibri" charset="0"/>
                         <a:cs typeface="Calibri" charset="0"/>
                       </a:endParaRPr>
                     </a:p>
                   </a:txBody>
-                  <a:tcPr marL="45720" marR="45720" marT="45720" marB="45720" anchor="ctr">
+                  <a:tcPr marL="36576" marR="36576" marT="36576" marB="36576" anchor="ctr">
                     <a:lnL w="6350" cap="flat" cmpd="sng" algn="ctr">
                       <a:solidFill>
                         <a:srgbClr val="CBD5E1"/>
@@ -5820,7 +5820,7 @@
                         <a:buNone/>
                       </a:pPr>
                       <a:r>
-                        <a:rPr lang="en-US" sz="1000" dirty="0">
+                        <a:rPr lang="en-US" sz="900" dirty="0">
                           <a:solidFill>
                             <a:srgbClr val="1E293B"/>
                           </a:solidFill>
@@ -5830,14 +5830,14 @@
                         </a:rPr>
                         <a:t>1 / 2 / 10</a:t>
                       </a:r>
-                      <a:endParaRPr lang="en-US" sz="1000" dirty="0">
+                      <a:endParaRPr lang="en-US" sz="900" dirty="0">
                         <a:latin typeface="Calibri" charset="0"/>
                         <a:ea typeface="Calibri" charset="0"/>
                         <a:cs typeface="Calibri" charset="0"/>
                       </a:endParaRPr>
                     </a:p>
                   </a:txBody>
-                  <a:tcPr marL="45720" marR="45720" marT="45720" marB="45720" anchor="ctr">
+                  <a:tcPr marL="36576" marR="36576" marT="36576" marB="36576" anchor="ctr">
                     <a:lnL w="6350" cap="flat" cmpd="sng" algn="ctr">
                       <a:solidFill>
                         <a:srgbClr val="CBD5E1"/>
@@ -5880,7 +5880,7 @@
                   </a:tcPr>
                 </a:tc>
               </a:tr>
-              <a:tr h="384048">
+              <a:tr h="301752">
                 <a:tc>
                   <a:txBody>
                     <a:bodyPr/>
@@ -5890,7 +5890,7 @@
                         <a:buNone/>
                       </a:pPr>
                       <a:r>
-                        <a:rPr lang="en-US" sz="1000" dirty="0">
+                        <a:rPr lang="en-US" sz="900" dirty="0">
                           <a:solidFill>
                             <a:srgbClr val="1E293B"/>
                           </a:solidFill>
@@ -5900,14 +5900,14 @@
                         </a:rPr>
                         <a:t>04 · Cisco edge (misconfigured)</a:t>
                       </a:r>
-                      <a:endParaRPr lang="en-US" sz="1000" dirty="0">
+                      <a:endParaRPr lang="en-US" sz="900" dirty="0">
                         <a:latin typeface="Calibri" charset="0"/>
                         <a:ea typeface="Calibri" charset="0"/>
                         <a:cs typeface="Calibri" charset="0"/>
                       </a:endParaRPr>
                     </a:p>
                   </a:txBody>
-                  <a:tcPr marL="45720" marR="45720" marT="45720" marB="45720" anchor="ctr">
+                  <a:tcPr marL="36576" marR="36576" marT="36576" marB="36576" anchor="ctr">
                     <a:lnL w="6350" cap="flat" cmpd="sng" algn="ctr">
                       <a:solidFill>
                         <a:srgbClr val="CBD5E1"/>
@@ -5958,7 +5958,7 @@
                         <a:buNone/>
                       </a:pPr>
                       <a:r>
-                        <a:rPr lang="en-US" sz="1000" dirty="0">
+                        <a:rPr lang="en-US" sz="900" dirty="0">
                           <a:solidFill>
                             <a:srgbClr val="1E293B"/>
                           </a:solidFill>
@@ -5968,14 +5968,14 @@
                         </a:rPr>
                         <a:t>55</a:t>
                       </a:r>
-                      <a:endParaRPr lang="en-US" sz="1000" dirty="0">
+                      <a:endParaRPr lang="en-US" sz="900" dirty="0">
                         <a:latin typeface="Calibri" charset="0"/>
                         <a:ea typeface="Calibri" charset="0"/>
                         <a:cs typeface="Calibri" charset="0"/>
                       </a:endParaRPr>
                     </a:p>
                   </a:txBody>
-                  <a:tcPr marL="45720" marR="45720" marT="45720" marB="45720" anchor="ctr">
+                  <a:tcPr marL="36576" marR="36576" marT="36576" marB="36576" anchor="ctr">
                     <a:lnL w="6350" cap="flat" cmpd="sng" algn="ctr">
                       <a:solidFill>
                         <a:srgbClr val="CBD5E1"/>
@@ -6026,7 +6026,7 @@
                         <a:buNone/>
                       </a:pPr>
                       <a:r>
-                        <a:rPr lang="en-US" sz="1000" dirty="0">
+                        <a:rPr lang="en-US" sz="900" dirty="0">
                           <a:solidFill>
                             <a:srgbClr val="1E293B"/>
                           </a:solidFill>
@@ -6034,16 +6034,16 @@
                           <a:ea typeface="Calibri" pitchFamily="34" charset="-122"/>
                           <a:cs typeface="Calibri" pitchFamily="34" charset="-120"/>
                         </a:rPr>
-                        <a:t>12.6 s (387 s)</a:t>
+                        <a:t>3.1 s (387 s)</a:t>
                       </a:r>
-                      <a:endParaRPr lang="en-US" sz="1000" dirty="0">
+                      <a:endParaRPr lang="en-US" sz="900" dirty="0">
                         <a:latin typeface="Calibri" charset="0"/>
                         <a:ea typeface="Calibri" charset="0"/>
                         <a:cs typeface="Calibri" charset="0"/>
                       </a:endParaRPr>
                     </a:p>
                   </a:txBody>
-                  <a:tcPr marL="45720" marR="45720" marT="45720" marB="45720" anchor="ctr">
+                  <a:tcPr marL="36576" marR="36576" marT="36576" marB="36576" anchor="ctr">
                     <a:lnL w="6350" cap="flat" cmpd="sng" algn="ctr">
                       <a:solidFill>
                         <a:srgbClr val="CBD5E1"/>
@@ -6094,7 +6094,7 @@
                         <a:buNone/>
                       </a:pPr>
                       <a:r>
-                        <a:rPr lang="en-US" sz="1000" dirty="0">
+                        <a:rPr lang="en-US" sz="900" dirty="0">
                           <a:solidFill>
                             <a:srgbClr val="1E293B"/>
                           </a:solidFill>
@@ -6102,16 +6102,16 @@
                           <a:ea typeface="Calibri" pitchFamily="34" charset="-122"/>
                           <a:cs typeface="Calibri" pitchFamily="34" charset="-120"/>
                         </a:rPr>
-                        <a:t>36 / 7 / 12</a:t>
+                        <a:t>40 / 2 / 13</a:t>
                       </a:r>
-                      <a:endParaRPr lang="en-US" sz="1000" dirty="0">
+                      <a:endParaRPr lang="en-US" sz="900" dirty="0">
                         <a:latin typeface="Calibri" charset="0"/>
                         <a:ea typeface="Calibri" charset="0"/>
                         <a:cs typeface="Calibri" charset="0"/>
                       </a:endParaRPr>
                     </a:p>
                   </a:txBody>
-                  <a:tcPr marL="45720" marR="45720" marT="45720" marB="45720" anchor="ctr">
+                  <a:tcPr marL="36576" marR="36576" marT="36576" marB="36576" anchor="ctr">
                     <a:lnL w="6350" cap="flat" cmpd="sng" algn="ctr">
                       <a:solidFill>
                         <a:srgbClr val="CBD5E1"/>
@@ -6162,7 +6162,7 @@
                         <a:buNone/>
                       </a:pPr>
                       <a:r>
-                        <a:rPr lang="en-US" sz="1000" dirty="0">
+                        <a:rPr lang="en-US" sz="900" dirty="0">
                           <a:solidFill>
                             <a:srgbClr val="1E293B"/>
                           </a:solidFill>
@@ -6172,14 +6172,14 @@
                         </a:rPr>
                         <a:t>2</a:t>
                       </a:r>
-                      <a:endParaRPr lang="en-US" sz="1000" dirty="0">
+                      <a:endParaRPr lang="en-US" sz="900" dirty="0">
                         <a:latin typeface="Calibri" charset="0"/>
                         <a:ea typeface="Calibri" charset="0"/>
                         <a:cs typeface="Calibri" charset="0"/>
                       </a:endParaRPr>
                     </a:p>
                   </a:txBody>
-                  <a:tcPr marL="45720" marR="45720" marT="45720" marB="45720" anchor="ctr">
+                  <a:tcPr marL="36576" marR="36576" marT="36576" marB="36576" anchor="ctr">
                     <a:lnL w="6350" cap="flat" cmpd="sng" algn="ctr">
                       <a:solidFill>
                         <a:srgbClr val="CBD5E1"/>
@@ -6230,7 +6230,7 @@
                         <a:buNone/>
                       </a:pPr>
                       <a:r>
-                        <a:rPr lang="en-US" sz="1000" dirty="0">
+                        <a:rPr lang="en-US" sz="900" dirty="0">
                           <a:solidFill>
                             <a:srgbClr val="1E293B"/>
                           </a:solidFill>
@@ -6240,14 +6240,14 @@
                         </a:rPr>
                         <a:t>1</a:t>
                       </a:r>
-                      <a:endParaRPr lang="en-US" sz="1000" dirty="0">
+                      <a:endParaRPr lang="en-US" sz="900" dirty="0">
                         <a:latin typeface="Calibri" charset="0"/>
                         <a:ea typeface="Calibri" charset="0"/>
                         <a:cs typeface="Calibri" charset="0"/>
                       </a:endParaRPr>
                     </a:p>
                   </a:txBody>
-                  <a:tcPr marL="45720" marR="45720" marT="45720" marB="45720" anchor="ctr">
+                  <a:tcPr marL="36576" marR="36576" marT="36576" marB="36576" anchor="ctr">
                     <a:lnL w="6350" cap="flat" cmpd="sng" algn="ctr">
                       <a:solidFill>
                         <a:srgbClr val="CBD5E1"/>
@@ -6298,7 +6298,7 @@
                         <a:buNone/>
                       </a:pPr>
                       <a:r>
-                        <a:rPr lang="en-US" sz="1000" dirty="0">
+                        <a:rPr lang="en-US" sz="900" dirty="0">
                           <a:solidFill>
                             <a:srgbClr val="1E293B"/>
                           </a:solidFill>
@@ -6306,16 +6306,16 @@
                           <a:ea typeface="Calibri" pitchFamily="34" charset="-122"/>
                           <a:cs typeface="Calibri" pitchFamily="34" charset="-120"/>
                         </a:rPr>
-                        <a:t>2 / 10 / 22</a:t>
+                        <a:t>4 / 10 / 20</a:t>
                       </a:r>
-                      <a:endParaRPr lang="en-US" sz="1000" dirty="0">
+                      <a:endParaRPr lang="en-US" sz="900" dirty="0">
                         <a:latin typeface="Calibri" charset="0"/>
                         <a:ea typeface="Calibri" charset="0"/>
                         <a:cs typeface="Calibri" charset="0"/>
                       </a:endParaRPr>
                     </a:p>
                   </a:txBody>
-                  <a:tcPr marL="45720" marR="45720" marT="45720" marB="45720" anchor="ctr">
+                  <a:tcPr marL="36576" marR="36576" marT="36576" marB="36576" anchor="ctr">
                     <a:lnL w="6350" cap="flat" cmpd="sng" algn="ctr">
                       <a:solidFill>
                         <a:srgbClr val="CBD5E1"/>
@@ -6358,7 +6358,7 @@
                   </a:tcPr>
                 </a:tc>
               </a:tr>
-              <a:tr h="384048">
+              <a:tr h="301752">
                 <a:tc>
                   <a:txBody>
                     <a:bodyPr/>
@@ -6368,7 +6368,7 @@
                         <a:buNone/>
                       </a:pPr>
                       <a:r>
-                        <a:rPr lang="en-US" sz="1000" dirty="0">
+                        <a:rPr lang="en-US" sz="900" dirty="0">
                           <a:solidFill>
                             <a:srgbClr val="1E293B"/>
                           </a:solidFill>
@@ -6378,14 +6378,14 @@
                         </a:rPr>
                         <a:t>05 · Arista vEOS (unknown)</a:t>
                       </a:r>
-                      <a:endParaRPr lang="en-US" sz="1000" dirty="0">
+                      <a:endParaRPr lang="en-US" sz="900" dirty="0">
                         <a:latin typeface="Calibri" charset="0"/>
                         <a:ea typeface="Calibri" charset="0"/>
                         <a:cs typeface="Calibri" charset="0"/>
                       </a:endParaRPr>
                     </a:p>
                   </a:txBody>
-                  <a:tcPr marL="45720" marR="45720" marT="45720" marB="45720" anchor="ctr">
+                  <a:tcPr marL="36576" marR="36576" marT="36576" marB="36576" anchor="ctr">
                     <a:lnL w="6350" cap="flat" cmpd="sng" algn="ctr">
                       <a:solidFill>
                         <a:srgbClr val="CBD5E1"/>
@@ -6436,7 +6436,7 @@
                         <a:buNone/>
                       </a:pPr>
                       <a:r>
-                        <a:rPr lang="en-US" sz="1000" dirty="0">
+                        <a:rPr lang="en-US" sz="900" dirty="0">
                           <a:solidFill>
                             <a:srgbClr val="1E293B"/>
                           </a:solidFill>
@@ -6446,14 +6446,14 @@
                         </a:rPr>
                         <a:t>18</a:t>
                       </a:r>
-                      <a:endParaRPr lang="en-US" sz="1000" dirty="0">
+                      <a:endParaRPr lang="en-US" sz="900" dirty="0">
                         <a:latin typeface="Calibri" charset="0"/>
                         <a:ea typeface="Calibri" charset="0"/>
                         <a:cs typeface="Calibri" charset="0"/>
                       </a:endParaRPr>
                     </a:p>
                   </a:txBody>
-                  <a:tcPr marL="45720" marR="45720" marT="45720" marB="45720" anchor="ctr">
+                  <a:tcPr marL="36576" marR="36576" marT="36576" marB="36576" anchor="ctr">
                     <a:lnL w="6350" cap="flat" cmpd="sng" algn="ctr">
                       <a:solidFill>
                         <a:srgbClr val="CBD5E1"/>
@@ -6504,7 +6504,7 @@
                         <a:buNone/>
                       </a:pPr>
                       <a:r>
-                        <a:rPr lang="en-US" sz="1000" dirty="0">
+                        <a:rPr lang="en-US" sz="900" dirty="0">
                           <a:solidFill>
                             <a:srgbClr val="1E293B"/>
                           </a:solidFill>
@@ -6512,16 +6512,16 @@
                           <a:ea typeface="Calibri" pitchFamily="34" charset="-122"/>
                           <a:cs typeface="Calibri" pitchFamily="34" charset="-120"/>
                         </a:rPr>
-                        <a:t>8.4 s (120 s)</a:t>
+                        <a:t>9.1 s (120 s)</a:t>
                       </a:r>
-                      <a:endParaRPr lang="en-US" sz="1000" dirty="0">
+                      <a:endParaRPr lang="en-US" sz="900" dirty="0">
                         <a:latin typeface="Calibri" charset="0"/>
                         <a:ea typeface="Calibri" charset="0"/>
                         <a:cs typeface="Calibri" charset="0"/>
                       </a:endParaRPr>
                     </a:p>
                   </a:txBody>
-                  <a:tcPr marL="45720" marR="45720" marT="45720" marB="45720" anchor="ctr">
+                  <a:tcPr marL="36576" marR="36576" marT="36576" marB="36576" anchor="ctr">
                     <a:lnL w="6350" cap="flat" cmpd="sng" algn="ctr">
                       <a:solidFill>
                         <a:srgbClr val="CBD5E1"/>
@@ -6572,7 +6572,7 @@
                         <a:buNone/>
                       </a:pPr>
                       <a:r>
-                        <a:rPr lang="en-US" sz="1000" dirty="0">
+                        <a:rPr lang="en-US" sz="900" dirty="0">
                           <a:solidFill>
                             <a:srgbClr val="1E293B"/>
                           </a:solidFill>
@@ -6580,16 +6580,16 @@
                           <a:ea typeface="Calibri" pitchFamily="34" charset="-122"/>
                           <a:cs typeface="Calibri" pitchFamily="34" charset="-120"/>
                         </a:rPr>
-                        <a:t>0 / 5 / 13</a:t>
+                        <a:t>0 / 2 / 16</a:t>
                       </a:r>
-                      <a:endParaRPr lang="en-US" sz="1000" dirty="0">
+                      <a:endParaRPr lang="en-US" sz="900" dirty="0">
                         <a:latin typeface="Calibri" charset="0"/>
                         <a:ea typeface="Calibri" charset="0"/>
                         <a:cs typeface="Calibri" charset="0"/>
                       </a:endParaRPr>
                     </a:p>
                   </a:txBody>
-                  <a:tcPr marL="45720" marR="45720" marT="45720" marB="45720" anchor="ctr">
+                  <a:tcPr marL="36576" marR="36576" marT="36576" marB="36576" anchor="ctr">
                     <a:lnL w="6350" cap="flat" cmpd="sng" algn="ctr">
                       <a:solidFill>
                         <a:srgbClr val="CBD5E1"/>
@@ -6640,7 +6640,7 @@
                         <a:buNone/>
                       </a:pPr>
                       <a:r>
-                        <a:rPr lang="en-US" sz="1000" dirty="0">
+                        <a:rPr lang="en-US" sz="900" dirty="0">
                           <a:solidFill>
                             <a:srgbClr val="1E293B"/>
                           </a:solidFill>
@@ -6650,14 +6650,14 @@
                         </a:rPr>
                         <a:t>3</a:t>
                       </a:r>
-                      <a:endParaRPr lang="en-US" sz="1000" dirty="0">
+                      <a:endParaRPr lang="en-US" sz="900" dirty="0">
                         <a:latin typeface="Calibri" charset="0"/>
                         <a:ea typeface="Calibri" charset="0"/>
                         <a:cs typeface="Calibri" charset="0"/>
                       </a:endParaRPr>
                     </a:p>
                   </a:txBody>
-                  <a:tcPr marL="45720" marR="45720" marT="45720" marB="45720" anchor="ctr">
+                  <a:tcPr marL="36576" marR="36576" marT="36576" marB="36576" anchor="ctr">
                     <a:lnL w="6350" cap="flat" cmpd="sng" algn="ctr">
                       <a:solidFill>
                         <a:srgbClr val="CBD5E1"/>
@@ -6708,7 +6708,7 @@
                         <a:buNone/>
                       </a:pPr>
                       <a:r>
-                        <a:rPr lang="en-US" sz="1000" dirty="0">
+                        <a:rPr lang="en-US" sz="900" dirty="0">
                           <a:solidFill>
                             <a:srgbClr val="1E293B"/>
                           </a:solidFill>
@@ -6718,14 +6718,14 @@
                         </a:rPr>
                         <a:t>1</a:t>
                       </a:r>
-                      <a:endParaRPr lang="en-US" sz="1000" dirty="0">
+                      <a:endParaRPr lang="en-US" sz="900" dirty="0">
                         <a:latin typeface="Calibri" charset="0"/>
                         <a:ea typeface="Calibri" charset="0"/>
                         <a:cs typeface="Calibri" charset="0"/>
                       </a:endParaRPr>
                     </a:p>
                   </a:txBody>
-                  <a:tcPr marL="45720" marR="45720" marT="45720" marB="45720" anchor="ctr">
+                  <a:tcPr marL="36576" marR="36576" marT="36576" marB="36576" anchor="ctr">
                     <a:lnL w="6350" cap="flat" cmpd="sng" algn="ctr">
                       <a:solidFill>
                         <a:srgbClr val="CBD5E1"/>
@@ -6776,7 +6776,7 @@
                         <a:buNone/>
                       </a:pPr>
                       <a:r>
-                        <a:rPr lang="en-US" sz="1000" dirty="0">
+                        <a:rPr lang="en-US" sz="900" dirty="0">
                           <a:solidFill>
                             <a:srgbClr val="1E293B"/>
                           </a:solidFill>
@@ -6784,16 +6784,16 @@
                           <a:ea typeface="Calibri" pitchFamily="34" charset="-122"/>
                           <a:cs typeface="Calibri" pitchFamily="34" charset="-120"/>
                         </a:rPr>
-                        <a:t>1 / 0 / 12</a:t>
+                        <a:t>0 / 0 / 13</a:t>
                       </a:r>
-                      <a:endParaRPr lang="en-US" sz="1000" dirty="0">
+                      <a:endParaRPr lang="en-US" sz="900" dirty="0">
                         <a:latin typeface="Calibri" charset="0"/>
                         <a:ea typeface="Calibri" charset="0"/>
                         <a:cs typeface="Calibri" charset="0"/>
                       </a:endParaRPr>
                     </a:p>
                   </a:txBody>
-                  <a:tcPr marL="45720" marR="45720" marT="45720" marB="45720" anchor="ctr">
+                  <a:tcPr marL="36576" marR="36576" marT="36576" marB="36576" anchor="ctr">
                     <a:lnL w="6350" cap="flat" cmpd="sng" algn="ctr">
                       <a:solidFill>
                         <a:srgbClr val="CBD5E1"/>
@@ -6836,7 +6836,7 @@
                   </a:tcPr>
                 </a:tc>
               </a:tr>
-              <a:tr h="384048">
+              <a:tr h="301752">
                 <a:tc>
                   <a:txBody>
                     <a:bodyPr/>
@@ -6846,7 +6846,7 @@
                         <a:buNone/>
                       </a:pPr>
                       <a:r>
-                        <a:rPr lang="en-US" sz="1000" dirty="0">
+                        <a:rPr lang="en-US" sz="900" dirty="0">
                           <a:solidFill>
                             <a:srgbClr val="1E293B"/>
                           </a:solidFill>
@@ -6856,14 +6856,14 @@
                         </a:rPr>
                         <a:t>06 · Cisco edge (remediated)</a:t>
                       </a:r>
-                      <a:endParaRPr lang="en-US" sz="1000" dirty="0">
+                      <a:endParaRPr lang="en-US" sz="900" dirty="0">
                         <a:latin typeface="Calibri" charset="0"/>
                         <a:ea typeface="Calibri" charset="0"/>
                         <a:cs typeface="Calibri" charset="0"/>
                       </a:endParaRPr>
                     </a:p>
                   </a:txBody>
-                  <a:tcPr marL="45720" marR="45720" marT="45720" marB="45720" anchor="ctr">
+                  <a:tcPr marL="36576" marR="36576" marT="36576" marB="36576" anchor="ctr">
                     <a:lnL w="6350" cap="flat" cmpd="sng" algn="ctr">
                       <a:solidFill>
                         <a:srgbClr val="CBD5E1"/>
@@ -6914,7 +6914,7 @@
                         <a:buNone/>
                       </a:pPr>
                       <a:r>
-                        <a:rPr lang="en-US" sz="1000" dirty="0">
+                        <a:rPr lang="en-US" sz="900" dirty="0">
                           <a:solidFill>
                             <a:srgbClr val="1E293B"/>
                           </a:solidFill>
@@ -6922,16 +6922,16 @@
                           <a:ea typeface="Calibri" pitchFamily="34" charset="-122"/>
                           <a:cs typeface="Calibri" pitchFamily="34" charset="-120"/>
                         </a:rPr>
-                        <a:t>64</a:t>
+                        <a:t>62</a:t>
                       </a:r>
-                      <a:endParaRPr lang="en-US" sz="1000" dirty="0">
+                      <a:endParaRPr lang="en-US" sz="900" dirty="0">
                         <a:latin typeface="Calibri" charset="0"/>
                         <a:ea typeface="Calibri" charset="0"/>
                         <a:cs typeface="Calibri" charset="0"/>
                       </a:endParaRPr>
                     </a:p>
                   </a:txBody>
-                  <a:tcPr marL="45720" marR="45720" marT="45720" marB="45720" anchor="ctr">
+                  <a:tcPr marL="36576" marR="36576" marT="36576" marB="36576" anchor="ctr">
                     <a:lnL w="6350" cap="flat" cmpd="sng" algn="ctr">
                       <a:solidFill>
                         <a:srgbClr val="CBD5E1"/>
@@ -6982,7 +6982,7 @@
                         <a:buNone/>
                       </a:pPr>
                       <a:r>
-                        <a:rPr lang="en-US" sz="1000" dirty="0">
+                        <a:rPr lang="en-US" sz="900" dirty="0">
                           <a:solidFill>
                             <a:srgbClr val="1E293B"/>
                           </a:solidFill>
@@ -6990,16 +6990,16 @@
                           <a:ea typeface="Calibri" pitchFamily="34" charset="-122"/>
                           <a:cs typeface="Calibri" pitchFamily="34" charset="-120"/>
                         </a:rPr>
-                        <a:t>7.7 s (505 s)</a:t>
+                        <a:t>3 s (505 s)</a:t>
                       </a:r>
-                      <a:endParaRPr lang="en-US" sz="1000" dirty="0">
+                      <a:endParaRPr lang="en-US" sz="900" dirty="0">
                         <a:latin typeface="Calibri" charset="0"/>
                         <a:ea typeface="Calibri" charset="0"/>
                         <a:cs typeface="Calibri" charset="0"/>
                       </a:endParaRPr>
                     </a:p>
                   </a:txBody>
-                  <a:tcPr marL="45720" marR="45720" marT="45720" marB="45720" anchor="ctr">
+                  <a:tcPr marL="36576" marR="36576" marT="36576" marB="36576" anchor="ctr">
                     <a:lnL w="6350" cap="flat" cmpd="sng" algn="ctr">
                       <a:solidFill>
                         <a:srgbClr val="CBD5E1"/>
@@ -7050,7 +7050,7 @@
                         <a:buNone/>
                       </a:pPr>
                       <a:r>
-                        <a:rPr lang="en-US" sz="1000" dirty="0">
+                        <a:rPr lang="en-US" sz="900" dirty="0">
                           <a:solidFill>
                             <a:srgbClr val="1E293B"/>
                           </a:solidFill>
@@ -7058,16 +7058,16 @@
                           <a:ea typeface="Calibri" pitchFamily="34" charset="-122"/>
                           <a:cs typeface="Calibri" pitchFamily="34" charset="-120"/>
                         </a:rPr>
-                        <a:t>40 / 10 / 14</a:t>
+                        <a:t>48 / 2 / 12</a:t>
                       </a:r>
-                      <a:endParaRPr lang="en-US" sz="1000" dirty="0">
+                      <a:endParaRPr lang="en-US" sz="900" dirty="0">
                         <a:latin typeface="Calibri" charset="0"/>
                         <a:ea typeface="Calibri" charset="0"/>
                         <a:cs typeface="Calibri" charset="0"/>
                       </a:endParaRPr>
                     </a:p>
                   </a:txBody>
-                  <a:tcPr marL="45720" marR="45720" marT="45720" marB="45720" anchor="ctr">
+                  <a:tcPr marL="36576" marR="36576" marT="36576" marB="36576" anchor="ctr">
                     <a:lnL w="6350" cap="flat" cmpd="sng" algn="ctr">
                       <a:solidFill>
                         <a:srgbClr val="CBD5E1"/>
@@ -7118,7 +7118,7 @@
                         <a:buNone/>
                       </a:pPr>
                       <a:r>
-                        <a:rPr lang="en-US" sz="1000" dirty="0">
+                        <a:rPr lang="en-US" sz="900" dirty="0">
                           <a:solidFill>
                             <a:srgbClr val="1E293B"/>
                           </a:solidFill>
@@ -7128,14 +7128,14 @@
                         </a:rPr>
                         <a:t>3</a:t>
                       </a:r>
-                      <a:endParaRPr lang="en-US" sz="1000" dirty="0">
+                      <a:endParaRPr lang="en-US" sz="900" dirty="0">
                         <a:latin typeface="Calibri" charset="0"/>
                         <a:ea typeface="Calibri" charset="0"/>
                         <a:cs typeface="Calibri" charset="0"/>
                       </a:endParaRPr>
                     </a:p>
                   </a:txBody>
-                  <a:tcPr marL="45720" marR="45720" marT="45720" marB="45720" anchor="ctr">
+                  <a:tcPr marL="36576" marR="36576" marT="36576" marB="36576" anchor="ctr">
                     <a:lnL w="6350" cap="flat" cmpd="sng" algn="ctr">
                       <a:solidFill>
                         <a:srgbClr val="CBD5E1"/>
@@ -7186,7 +7186,7 @@
                         <a:buNone/>
                       </a:pPr>
                       <a:r>
-                        <a:rPr lang="en-US" sz="1000" dirty="0">
+                        <a:rPr lang="en-US" sz="900" dirty="0">
                           <a:solidFill>
                             <a:srgbClr val="1E293B"/>
                           </a:solidFill>
@@ -7196,14 +7196,14 @@
                         </a:rPr>
                         <a:t>0</a:t>
                       </a:r>
-                      <a:endParaRPr lang="en-US" sz="1000" dirty="0">
+                      <a:endParaRPr lang="en-US" sz="900" dirty="0">
                         <a:latin typeface="Calibri" charset="0"/>
                         <a:ea typeface="Calibri" charset="0"/>
                         <a:cs typeface="Calibri" charset="0"/>
                       </a:endParaRPr>
                     </a:p>
                   </a:txBody>
-                  <a:tcPr marL="45720" marR="45720" marT="45720" marB="45720" anchor="ctr">
+                  <a:tcPr marL="36576" marR="36576" marT="36576" marB="36576" anchor="ctr">
                     <a:lnL w="6350" cap="flat" cmpd="sng" algn="ctr">
                       <a:solidFill>
                         <a:srgbClr val="CBD5E1"/>
@@ -7254,7 +7254,7 @@
                         <a:buNone/>
                       </a:pPr>
                       <a:r>
-                        <a:rPr lang="en-US" sz="1000" dirty="0">
+                        <a:rPr lang="en-US" sz="900" dirty="0">
                           <a:solidFill>
                             <a:srgbClr val="1E293B"/>
                           </a:solidFill>
@@ -7262,16 +7262,972 @@
                           <a:ea typeface="Calibri" pitchFamily="34" charset="-122"/>
                           <a:cs typeface="Calibri" pitchFamily="34" charset="-120"/>
                         </a:rPr>
-                        <a:t>19 / 1 / 14</a:t>
+                        <a:t>21 / 1 / 12</a:t>
                       </a:r>
-                      <a:endParaRPr lang="en-US" sz="1000" dirty="0">
+                      <a:endParaRPr lang="en-US" sz="900" dirty="0">
                         <a:latin typeface="Calibri" charset="0"/>
                         <a:ea typeface="Calibri" charset="0"/>
                         <a:cs typeface="Calibri" charset="0"/>
                       </a:endParaRPr>
                     </a:p>
                   </a:txBody>
-                  <a:tcPr marL="45720" marR="45720" marT="45720" marB="45720" anchor="ctr">
+                  <a:tcPr marL="36576" marR="36576" marT="36576" marB="36576" anchor="ctr">
+                    <a:lnL w="6350" cap="flat" cmpd="sng" algn="ctr">
+                      <a:solidFill>
+                        <a:srgbClr val="CBD5E1"/>
+                      </a:solidFill>
+                      <a:prstDash val="solid"/>
+                      <a:round/>
+                      <a:headEnd type="none" w="med" len="med"/>
+                      <a:tailEnd type="none" w="med" len="med"/>
+                    </a:lnL>
+                    <a:lnR w="6350" cap="flat" cmpd="sng" algn="ctr">
+                      <a:solidFill>
+                        <a:srgbClr val="CBD5E1"/>
+                      </a:solidFill>
+                      <a:prstDash val="solid"/>
+                      <a:round/>
+                      <a:headEnd type="none" w="med" len="med"/>
+                      <a:tailEnd type="none" w="med" len="med"/>
+                    </a:lnR>
+                    <a:lnT w="6350" cap="flat" cmpd="sng" algn="ctr">
+                      <a:solidFill>
+                        <a:srgbClr val="CBD5E1"/>
+                      </a:solidFill>
+                      <a:prstDash val="solid"/>
+                      <a:round/>
+                      <a:headEnd type="none" w="med" len="med"/>
+                      <a:tailEnd type="none" w="med" len="med"/>
+                    </a:lnT>
+                    <a:lnB w="6350" cap="flat" cmpd="sng" algn="ctr">
+                      <a:solidFill>
+                        <a:srgbClr val="CBD5E1"/>
+                      </a:solidFill>
+                      <a:prstDash val="solid"/>
+                      <a:round/>
+                      <a:headEnd type="none" w="med" len="med"/>
+                      <a:tailEnd type="none" w="med" len="med"/>
+                    </a:lnB>
+                    <a:solidFill>
+                      <a:srgbClr val="FFFFFF"/>
+                    </a:solidFill>
+                  </a:tcPr>
+                </a:tc>
+              </a:tr>
+              <a:tr h="301752">
+                <a:tc>
+                  <a:txBody>
+                    <a:bodyPr/>
+                    <a:lstStyle/>
+                    <a:p>
+                      <a:pPr indent="0" marL="0">
+                        <a:buNone/>
+                      </a:pPr>
+                      <a:r>
+                        <a:rPr lang="en-US" sz="900" dirty="0">
+                          <a:solidFill>
+                            <a:srgbClr val="1E293B"/>
+                          </a:solidFill>
+                          <a:latin typeface="Calibri" pitchFamily="34" charset="0"/>
+                          <a:ea typeface="Calibri" pitchFamily="34" charset="-122"/>
+                          <a:cs typeface="Calibri" pitchFamily="34" charset="-120"/>
+                        </a:rPr>
+                        <a:t>07 · Juniper SRX (YAML only)</a:t>
+                      </a:r>
+                      <a:endParaRPr lang="en-US" sz="900" dirty="0">
+                        <a:latin typeface="Calibri" charset="0"/>
+                        <a:ea typeface="Calibri" charset="0"/>
+                        <a:cs typeface="Calibri" charset="0"/>
+                      </a:endParaRPr>
+                    </a:p>
+                  </a:txBody>
+                  <a:tcPr marL="36576" marR="36576" marT="36576" marB="36576" anchor="ctr">
+                    <a:lnL w="6350" cap="flat" cmpd="sng" algn="ctr">
+                      <a:solidFill>
+                        <a:srgbClr val="CBD5E1"/>
+                      </a:solidFill>
+                      <a:prstDash val="solid"/>
+                      <a:round/>
+                      <a:headEnd type="none" w="med" len="med"/>
+                      <a:tailEnd type="none" w="med" len="med"/>
+                    </a:lnL>
+                    <a:lnR w="6350" cap="flat" cmpd="sng" algn="ctr">
+                      <a:solidFill>
+                        <a:srgbClr val="CBD5E1"/>
+                      </a:solidFill>
+                      <a:prstDash val="solid"/>
+                      <a:round/>
+                      <a:headEnd type="none" w="med" len="med"/>
+                      <a:tailEnd type="none" w="med" len="med"/>
+                    </a:lnR>
+                    <a:lnT w="6350" cap="flat" cmpd="sng" algn="ctr">
+                      <a:solidFill>
+                        <a:srgbClr val="CBD5E1"/>
+                      </a:solidFill>
+                      <a:prstDash val="solid"/>
+                      <a:round/>
+                      <a:headEnd type="none" w="med" len="med"/>
+                      <a:tailEnd type="none" w="med" len="med"/>
+                    </a:lnT>
+                    <a:lnB w="6350" cap="flat" cmpd="sng" algn="ctr">
+                      <a:solidFill>
+                        <a:srgbClr val="CBD5E1"/>
+                      </a:solidFill>
+                      <a:prstDash val="solid"/>
+                      <a:round/>
+                      <a:headEnd type="none" w="med" len="med"/>
+                      <a:tailEnd type="none" w="med" len="med"/>
+                    </a:lnB>
+                    <a:solidFill>
+                      <a:srgbClr val="FFFFFF"/>
+                    </a:solidFill>
+                  </a:tcPr>
+                </a:tc>
+                <a:tc>
+                  <a:txBody>
+                    <a:bodyPr/>
+                    <a:lstStyle/>
+                    <a:p>
+                      <a:pPr indent="0" marL="0">
+                        <a:buNone/>
+                      </a:pPr>
+                      <a:r>
+                        <a:rPr lang="en-US" sz="900" dirty="0">
+                          <a:solidFill>
+                            <a:srgbClr val="1E293B"/>
+                          </a:solidFill>
+                          <a:latin typeface="Calibri" pitchFamily="34" charset="0"/>
+                          <a:ea typeface="Calibri" pitchFamily="34" charset="-122"/>
+                          <a:cs typeface="Calibri" pitchFamily="34" charset="-120"/>
+                        </a:rPr>
+                        <a:t>20</a:t>
+                      </a:r>
+                      <a:endParaRPr lang="en-US" sz="900" dirty="0">
+                        <a:latin typeface="Calibri" charset="0"/>
+                        <a:ea typeface="Calibri" charset="0"/>
+                        <a:cs typeface="Calibri" charset="0"/>
+                      </a:endParaRPr>
+                    </a:p>
+                  </a:txBody>
+                  <a:tcPr marL="36576" marR="36576" marT="36576" marB="36576" anchor="ctr">
+                    <a:lnL w="6350" cap="flat" cmpd="sng" algn="ctr">
+                      <a:solidFill>
+                        <a:srgbClr val="CBD5E1"/>
+                      </a:solidFill>
+                      <a:prstDash val="solid"/>
+                      <a:round/>
+                      <a:headEnd type="none" w="med" len="med"/>
+                      <a:tailEnd type="none" w="med" len="med"/>
+                    </a:lnL>
+                    <a:lnR w="6350" cap="flat" cmpd="sng" algn="ctr">
+                      <a:solidFill>
+                        <a:srgbClr val="CBD5E1"/>
+                      </a:solidFill>
+                      <a:prstDash val="solid"/>
+                      <a:round/>
+                      <a:headEnd type="none" w="med" len="med"/>
+                      <a:tailEnd type="none" w="med" len="med"/>
+                    </a:lnR>
+                    <a:lnT w="6350" cap="flat" cmpd="sng" algn="ctr">
+                      <a:solidFill>
+                        <a:srgbClr val="CBD5E1"/>
+                      </a:solidFill>
+                      <a:prstDash val="solid"/>
+                      <a:round/>
+                      <a:headEnd type="none" w="med" len="med"/>
+                      <a:tailEnd type="none" w="med" len="med"/>
+                    </a:lnT>
+                    <a:lnB w="6350" cap="flat" cmpd="sng" algn="ctr">
+                      <a:solidFill>
+                        <a:srgbClr val="CBD5E1"/>
+                      </a:solidFill>
+                      <a:prstDash val="solid"/>
+                      <a:round/>
+                      <a:headEnd type="none" w="med" len="med"/>
+                      <a:tailEnd type="none" w="med" len="med"/>
+                    </a:lnB>
+                    <a:solidFill>
+                      <a:srgbClr val="FFFFFF"/>
+                    </a:solidFill>
+                  </a:tcPr>
+                </a:tc>
+                <a:tc>
+                  <a:txBody>
+                    <a:bodyPr/>
+                    <a:lstStyle/>
+                    <a:p>
+                      <a:pPr indent="0" marL="0">
+                        <a:buNone/>
+                      </a:pPr>
+                      <a:r>
+                        <a:rPr lang="en-US" sz="900" dirty="0">
+                          <a:solidFill>
+                            <a:srgbClr val="1E293B"/>
+                          </a:solidFill>
+                          <a:latin typeface="Calibri" pitchFamily="34" charset="0"/>
+                          <a:ea typeface="Calibri" pitchFamily="34" charset="-122"/>
+                          <a:cs typeface="Calibri" pitchFamily="34" charset="-120"/>
+                        </a:rPr>
+                        <a:t>2.9 s</a:t>
+                      </a:r>
+                      <a:endParaRPr lang="en-US" sz="900" dirty="0">
+                        <a:latin typeface="Calibri" charset="0"/>
+                        <a:ea typeface="Calibri" charset="0"/>
+                        <a:cs typeface="Calibri" charset="0"/>
+                      </a:endParaRPr>
+                    </a:p>
+                  </a:txBody>
+                  <a:tcPr marL="36576" marR="36576" marT="36576" marB="36576" anchor="ctr">
+                    <a:lnL w="6350" cap="flat" cmpd="sng" algn="ctr">
+                      <a:solidFill>
+                        <a:srgbClr val="CBD5E1"/>
+                      </a:solidFill>
+                      <a:prstDash val="solid"/>
+                      <a:round/>
+                      <a:headEnd type="none" w="med" len="med"/>
+                      <a:tailEnd type="none" w="med" len="med"/>
+                    </a:lnL>
+                    <a:lnR w="6350" cap="flat" cmpd="sng" algn="ctr">
+                      <a:solidFill>
+                        <a:srgbClr val="CBD5E1"/>
+                      </a:solidFill>
+                      <a:prstDash val="solid"/>
+                      <a:round/>
+                      <a:headEnd type="none" w="med" len="med"/>
+                      <a:tailEnd type="none" w="med" len="med"/>
+                    </a:lnR>
+                    <a:lnT w="6350" cap="flat" cmpd="sng" algn="ctr">
+                      <a:solidFill>
+                        <a:srgbClr val="CBD5E1"/>
+                      </a:solidFill>
+                      <a:prstDash val="solid"/>
+                      <a:round/>
+                      <a:headEnd type="none" w="med" len="med"/>
+                      <a:tailEnd type="none" w="med" len="med"/>
+                    </a:lnT>
+                    <a:lnB w="6350" cap="flat" cmpd="sng" algn="ctr">
+                      <a:solidFill>
+                        <a:srgbClr val="CBD5E1"/>
+                      </a:solidFill>
+                      <a:prstDash val="solid"/>
+                      <a:round/>
+                      <a:headEnd type="none" w="med" len="med"/>
+                      <a:tailEnd type="none" w="med" len="med"/>
+                    </a:lnB>
+                    <a:solidFill>
+                      <a:srgbClr val="FFFFFF"/>
+                    </a:solidFill>
+                  </a:tcPr>
+                </a:tc>
+                <a:tc>
+                  <a:txBody>
+                    <a:bodyPr/>
+                    <a:lstStyle/>
+                    <a:p>
+                      <a:pPr indent="0" marL="0">
+                        <a:buNone/>
+                      </a:pPr>
+                      <a:r>
+                        <a:rPr lang="en-US" sz="900" dirty="0">
+                          <a:solidFill>
+                            <a:srgbClr val="1E293B"/>
+                          </a:solidFill>
+                          <a:latin typeface="Calibri" pitchFamily="34" charset="0"/>
+                          <a:ea typeface="Calibri" pitchFamily="34" charset="-122"/>
+                          <a:cs typeface="Calibri" pitchFamily="34" charset="-120"/>
+                        </a:rPr>
+                        <a:t>15 / 0 / 5</a:t>
+                      </a:r>
+                      <a:endParaRPr lang="en-US" sz="900" dirty="0">
+                        <a:latin typeface="Calibri" charset="0"/>
+                        <a:ea typeface="Calibri" charset="0"/>
+                        <a:cs typeface="Calibri" charset="0"/>
+                      </a:endParaRPr>
+                    </a:p>
+                  </a:txBody>
+                  <a:tcPr marL="36576" marR="36576" marT="36576" marB="36576" anchor="ctr">
+                    <a:lnL w="6350" cap="flat" cmpd="sng" algn="ctr">
+                      <a:solidFill>
+                        <a:srgbClr val="CBD5E1"/>
+                      </a:solidFill>
+                      <a:prstDash val="solid"/>
+                      <a:round/>
+                      <a:headEnd type="none" w="med" len="med"/>
+                      <a:tailEnd type="none" w="med" len="med"/>
+                    </a:lnL>
+                    <a:lnR w="6350" cap="flat" cmpd="sng" algn="ctr">
+                      <a:solidFill>
+                        <a:srgbClr val="CBD5E1"/>
+                      </a:solidFill>
+                      <a:prstDash val="solid"/>
+                      <a:round/>
+                      <a:headEnd type="none" w="med" len="med"/>
+                      <a:tailEnd type="none" w="med" len="med"/>
+                    </a:lnR>
+                    <a:lnT w="6350" cap="flat" cmpd="sng" algn="ctr">
+                      <a:solidFill>
+                        <a:srgbClr val="CBD5E1"/>
+                      </a:solidFill>
+                      <a:prstDash val="solid"/>
+                      <a:round/>
+                      <a:headEnd type="none" w="med" len="med"/>
+                      <a:tailEnd type="none" w="med" len="med"/>
+                    </a:lnT>
+                    <a:lnB w="6350" cap="flat" cmpd="sng" algn="ctr">
+                      <a:solidFill>
+                        <a:srgbClr val="CBD5E1"/>
+                      </a:solidFill>
+                      <a:prstDash val="solid"/>
+                      <a:round/>
+                      <a:headEnd type="none" w="med" len="med"/>
+                      <a:tailEnd type="none" w="med" len="med"/>
+                    </a:lnB>
+                    <a:solidFill>
+                      <a:srgbClr val="FFFFFF"/>
+                    </a:solidFill>
+                  </a:tcPr>
+                </a:tc>
+                <a:tc>
+                  <a:txBody>
+                    <a:bodyPr/>
+                    <a:lstStyle/>
+                    <a:p>
+                      <a:pPr indent="0" marL="0">
+                        <a:buNone/>
+                      </a:pPr>
+                      <a:r>
+                        <a:rPr lang="en-US" sz="900" dirty="0">
+                          <a:solidFill>
+                            <a:srgbClr val="1E293B"/>
+                          </a:solidFill>
+                          <a:latin typeface="Calibri" pitchFamily="34" charset="0"/>
+                          <a:ea typeface="Calibri" pitchFamily="34" charset="-122"/>
+                          <a:cs typeface="Calibri" pitchFamily="34" charset="-120"/>
+                        </a:rPr>
+                        <a:t>2</a:t>
+                      </a:r>
+                      <a:endParaRPr lang="en-US" sz="900" dirty="0">
+                        <a:latin typeface="Calibri" charset="0"/>
+                        <a:ea typeface="Calibri" charset="0"/>
+                        <a:cs typeface="Calibri" charset="0"/>
+                      </a:endParaRPr>
+                    </a:p>
+                  </a:txBody>
+                  <a:tcPr marL="36576" marR="36576" marT="36576" marB="36576" anchor="ctr">
+                    <a:lnL w="6350" cap="flat" cmpd="sng" algn="ctr">
+                      <a:solidFill>
+                        <a:srgbClr val="CBD5E1"/>
+                      </a:solidFill>
+                      <a:prstDash val="solid"/>
+                      <a:round/>
+                      <a:headEnd type="none" w="med" len="med"/>
+                      <a:tailEnd type="none" w="med" len="med"/>
+                    </a:lnL>
+                    <a:lnR w="6350" cap="flat" cmpd="sng" algn="ctr">
+                      <a:solidFill>
+                        <a:srgbClr val="CBD5E1"/>
+                      </a:solidFill>
+                      <a:prstDash val="solid"/>
+                      <a:round/>
+                      <a:headEnd type="none" w="med" len="med"/>
+                      <a:tailEnd type="none" w="med" len="med"/>
+                    </a:lnR>
+                    <a:lnT w="6350" cap="flat" cmpd="sng" algn="ctr">
+                      <a:solidFill>
+                        <a:srgbClr val="CBD5E1"/>
+                      </a:solidFill>
+                      <a:prstDash val="solid"/>
+                      <a:round/>
+                      <a:headEnd type="none" w="med" len="med"/>
+                      <a:tailEnd type="none" w="med" len="med"/>
+                    </a:lnT>
+                    <a:lnB w="6350" cap="flat" cmpd="sng" algn="ctr">
+                      <a:solidFill>
+                        <a:srgbClr val="CBD5E1"/>
+                      </a:solidFill>
+                      <a:prstDash val="solid"/>
+                      <a:round/>
+                      <a:headEnd type="none" w="med" len="med"/>
+                      <a:tailEnd type="none" w="med" len="med"/>
+                    </a:lnB>
+                    <a:solidFill>
+                      <a:srgbClr val="FFFFFF"/>
+                    </a:solidFill>
+                  </a:tcPr>
+                </a:tc>
+                <a:tc>
+                  <a:txBody>
+                    <a:bodyPr/>
+                    <a:lstStyle/>
+                    <a:p>
+                      <a:pPr indent="0" marL="0">
+                        <a:buNone/>
+                      </a:pPr>
+                      <a:r>
+                        <a:rPr lang="en-US" sz="900" dirty="0">
+                          <a:solidFill>
+                            <a:srgbClr val="1E293B"/>
+                          </a:solidFill>
+                          <a:latin typeface="Calibri" pitchFamily="34" charset="0"/>
+                          <a:ea typeface="Calibri" pitchFamily="34" charset="-122"/>
+                          <a:cs typeface="Calibri" pitchFamily="34" charset="-120"/>
+                        </a:rPr>
+                        <a:t>0</a:t>
+                      </a:r>
+                      <a:endParaRPr lang="en-US" sz="900" dirty="0">
+                        <a:latin typeface="Calibri" charset="0"/>
+                        <a:ea typeface="Calibri" charset="0"/>
+                        <a:cs typeface="Calibri" charset="0"/>
+                      </a:endParaRPr>
+                    </a:p>
+                  </a:txBody>
+                  <a:tcPr marL="36576" marR="36576" marT="36576" marB="36576" anchor="ctr">
+                    <a:lnL w="6350" cap="flat" cmpd="sng" algn="ctr">
+                      <a:solidFill>
+                        <a:srgbClr val="CBD5E1"/>
+                      </a:solidFill>
+                      <a:prstDash val="solid"/>
+                      <a:round/>
+                      <a:headEnd type="none" w="med" len="med"/>
+                      <a:tailEnd type="none" w="med" len="med"/>
+                    </a:lnL>
+                    <a:lnR w="6350" cap="flat" cmpd="sng" algn="ctr">
+                      <a:solidFill>
+                        <a:srgbClr val="CBD5E1"/>
+                      </a:solidFill>
+                      <a:prstDash val="solid"/>
+                      <a:round/>
+                      <a:headEnd type="none" w="med" len="med"/>
+                      <a:tailEnd type="none" w="med" len="med"/>
+                    </a:lnR>
+                    <a:lnT w="6350" cap="flat" cmpd="sng" algn="ctr">
+                      <a:solidFill>
+                        <a:srgbClr val="CBD5E1"/>
+                      </a:solidFill>
+                      <a:prstDash val="solid"/>
+                      <a:round/>
+                      <a:headEnd type="none" w="med" len="med"/>
+                      <a:tailEnd type="none" w="med" len="med"/>
+                    </a:lnT>
+                    <a:lnB w="6350" cap="flat" cmpd="sng" algn="ctr">
+                      <a:solidFill>
+                        <a:srgbClr val="CBD5E1"/>
+                      </a:solidFill>
+                      <a:prstDash val="solid"/>
+                      <a:round/>
+                      <a:headEnd type="none" w="med" len="med"/>
+                      <a:tailEnd type="none" w="med" len="med"/>
+                    </a:lnB>
+                    <a:solidFill>
+                      <a:srgbClr val="FFFFFF"/>
+                    </a:solidFill>
+                  </a:tcPr>
+                </a:tc>
+                <a:tc>
+                  <a:txBody>
+                    <a:bodyPr/>
+                    <a:lstStyle/>
+                    <a:p>
+                      <a:pPr indent="0" marL="0">
+                        <a:buNone/>
+                      </a:pPr>
+                      <a:r>
+                        <a:rPr lang="en-US" sz="900" dirty="0">
+                          <a:solidFill>
+                            <a:srgbClr val="1E293B"/>
+                          </a:solidFill>
+                          <a:latin typeface="Calibri" pitchFamily="34" charset="0"/>
+                          <a:ea typeface="Calibri" pitchFamily="34" charset="-122"/>
+                          <a:cs typeface="Calibri" pitchFamily="34" charset="-120"/>
+                        </a:rPr>
+                        <a:t>4 / 1 / 8</a:t>
+                      </a:r>
+                      <a:endParaRPr lang="en-US" sz="900" dirty="0">
+                        <a:latin typeface="Calibri" charset="0"/>
+                        <a:ea typeface="Calibri" charset="0"/>
+                        <a:cs typeface="Calibri" charset="0"/>
+                      </a:endParaRPr>
+                    </a:p>
+                  </a:txBody>
+                  <a:tcPr marL="36576" marR="36576" marT="36576" marB="36576" anchor="ctr">
+                    <a:lnL w="6350" cap="flat" cmpd="sng" algn="ctr">
+                      <a:solidFill>
+                        <a:srgbClr val="CBD5E1"/>
+                      </a:solidFill>
+                      <a:prstDash val="solid"/>
+                      <a:round/>
+                      <a:headEnd type="none" w="med" len="med"/>
+                      <a:tailEnd type="none" w="med" len="med"/>
+                    </a:lnL>
+                    <a:lnR w="6350" cap="flat" cmpd="sng" algn="ctr">
+                      <a:solidFill>
+                        <a:srgbClr val="CBD5E1"/>
+                      </a:solidFill>
+                      <a:prstDash val="solid"/>
+                      <a:round/>
+                      <a:headEnd type="none" w="med" len="med"/>
+                      <a:tailEnd type="none" w="med" len="med"/>
+                    </a:lnR>
+                    <a:lnT w="6350" cap="flat" cmpd="sng" algn="ctr">
+                      <a:solidFill>
+                        <a:srgbClr val="CBD5E1"/>
+                      </a:solidFill>
+                      <a:prstDash val="solid"/>
+                      <a:round/>
+                      <a:headEnd type="none" w="med" len="med"/>
+                      <a:tailEnd type="none" w="med" len="med"/>
+                    </a:lnT>
+                    <a:lnB w="6350" cap="flat" cmpd="sng" algn="ctr">
+                      <a:solidFill>
+                        <a:srgbClr val="CBD5E1"/>
+                      </a:solidFill>
+                      <a:prstDash val="solid"/>
+                      <a:round/>
+                      <a:headEnd type="none" w="med" len="med"/>
+                      <a:tailEnd type="none" w="med" len="med"/>
+                    </a:lnB>
+                    <a:solidFill>
+                      <a:srgbClr val="FFFFFF"/>
+                    </a:solidFill>
+                  </a:tcPr>
+                </a:tc>
+              </a:tr>
+              <a:tr h="301752">
+                <a:tc>
+                  <a:txBody>
+                    <a:bodyPr/>
+                    <a:lstStyle/>
+                    <a:p>
+                      <a:pPr indent="0" marL="0">
+                        <a:buNone/>
+                      </a:pPr>
+                      <a:r>
+                        <a:rPr lang="en-US" sz="900" dirty="0">
+                          <a:solidFill>
+                            <a:srgbClr val="1E293B"/>
+                          </a:solidFill>
+                          <a:latin typeface="Calibri" pitchFamily="34" charset="0"/>
+                          <a:ea typeface="Calibri" pitchFamily="34" charset="-122"/>
+                          <a:cs typeface="Calibri" pitchFamily="34" charset="-120"/>
+                        </a:rPr>
+                        <a:t>08 · FortiGate 60F (YAML only)</a:t>
+                      </a:r>
+                      <a:endParaRPr lang="en-US" sz="900" dirty="0">
+                        <a:latin typeface="Calibri" charset="0"/>
+                        <a:ea typeface="Calibri" charset="0"/>
+                        <a:cs typeface="Calibri" charset="0"/>
+                      </a:endParaRPr>
+                    </a:p>
+                  </a:txBody>
+                  <a:tcPr marL="36576" marR="36576" marT="36576" marB="36576" anchor="ctr">
+                    <a:lnL w="6350" cap="flat" cmpd="sng" algn="ctr">
+                      <a:solidFill>
+                        <a:srgbClr val="CBD5E1"/>
+                      </a:solidFill>
+                      <a:prstDash val="solid"/>
+                      <a:round/>
+                      <a:headEnd type="none" w="med" len="med"/>
+                      <a:tailEnd type="none" w="med" len="med"/>
+                    </a:lnL>
+                    <a:lnR w="6350" cap="flat" cmpd="sng" algn="ctr">
+                      <a:solidFill>
+                        <a:srgbClr val="CBD5E1"/>
+                      </a:solidFill>
+                      <a:prstDash val="solid"/>
+                      <a:round/>
+                      <a:headEnd type="none" w="med" len="med"/>
+                      <a:tailEnd type="none" w="med" len="med"/>
+                    </a:lnR>
+                    <a:lnT w="6350" cap="flat" cmpd="sng" algn="ctr">
+                      <a:solidFill>
+                        <a:srgbClr val="CBD5E1"/>
+                      </a:solidFill>
+                      <a:prstDash val="solid"/>
+                      <a:round/>
+                      <a:headEnd type="none" w="med" len="med"/>
+                      <a:tailEnd type="none" w="med" len="med"/>
+                    </a:lnT>
+                    <a:lnB w="6350" cap="flat" cmpd="sng" algn="ctr">
+                      <a:solidFill>
+                        <a:srgbClr val="CBD5E1"/>
+                      </a:solidFill>
+                      <a:prstDash val="solid"/>
+                      <a:round/>
+                      <a:headEnd type="none" w="med" len="med"/>
+                      <a:tailEnd type="none" w="med" len="med"/>
+                    </a:lnB>
+                    <a:solidFill>
+                      <a:srgbClr val="FFFFFF"/>
+                    </a:solidFill>
+                  </a:tcPr>
+                </a:tc>
+                <a:tc>
+                  <a:txBody>
+                    <a:bodyPr/>
+                    <a:lstStyle/>
+                    <a:p>
+                      <a:pPr indent="0" marL="0">
+                        <a:buNone/>
+                      </a:pPr>
+                      <a:r>
+                        <a:rPr lang="en-US" sz="900" dirty="0">
+                          <a:solidFill>
+                            <a:srgbClr val="1E293B"/>
+                          </a:solidFill>
+                          <a:latin typeface="Calibri" pitchFamily="34" charset="0"/>
+                          <a:ea typeface="Calibri" pitchFamily="34" charset="-122"/>
+                          <a:cs typeface="Calibri" pitchFamily="34" charset="-120"/>
+                        </a:rPr>
+                        <a:t>21</a:t>
+                      </a:r>
+                      <a:endParaRPr lang="en-US" sz="900" dirty="0">
+                        <a:latin typeface="Calibri" charset="0"/>
+                        <a:ea typeface="Calibri" charset="0"/>
+                        <a:cs typeface="Calibri" charset="0"/>
+                      </a:endParaRPr>
+                    </a:p>
+                  </a:txBody>
+                  <a:tcPr marL="36576" marR="36576" marT="36576" marB="36576" anchor="ctr">
+                    <a:lnL w="6350" cap="flat" cmpd="sng" algn="ctr">
+                      <a:solidFill>
+                        <a:srgbClr val="CBD5E1"/>
+                      </a:solidFill>
+                      <a:prstDash val="solid"/>
+                      <a:round/>
+                      <a:headEnd type="none" w="med" len="med"/>
+                      <a:tailEnd type="none" w="med" len="med"/>
+                    </a:lnL>
+                    <a:lnR w="6350" cap="flat" cmpd="sng" algn="ctr">
+                      <a:solidFill>
+                        <a:srgbClr val="CBD5E1"/>
+                      </a:solidFill>
+                      <a:prstDash val="solid"/>
+                      <a:round/>
+                      <a:headEnd type="none" w="med" len="med"/>
+                      <a:tailEnd type="none" w="med" len="med"/>
+                    </a:lnR>
+                    <a:lnT w="6350" cap="flat" cmpd="sng" algn="ctr">
+                      <a:solidFill>
+                        <a:srgbClr val="CBD5E1"/>
+                      </a:solidFill>
+                      <a:prstDash val="solid"/>
+                      <a:round/>
+                      <a:headEnd type="none" w="med" len="med"/>
+                      <a:tailEnd type="none" w="med" len="med"/>
+                    </a:lnT>
+                    <a:lnB w="6350" cap="flat" cmpd="sng" algn="ctr">
+                      <a:solidFill>
+                        <a:srgbClr val="CBD5E1"/>
+                      </a:solidFill>
+                      <a:prstDash val="solid"/>
+                      <a:round/>
+                      <a:headEnd type="none" w="med" len="med"/>
+                      <a:tailEnd type="none" w="med" len="med"/>
+                    </a:lnB>
+                    <a:solidFill>
+                      <a:srgbClr val="FFFFFF"/>
+                    </a:solidFill>
+                  </a:tcPr>
+                </a:tc>
+                <a:tc>
+                  <a:txBody>
+                    <a:bodyPr/>
+                    <a:lstStyle/>
+                    <a:p>
+                      <a:pPr indent="0" marL="0">
+                        <a:buNone/>
+                      </a:pPr>
+                      <a:r>
+                        <a:rPr lang="en-US" sz="900" dirty="0">
+                          <a:solidFill>
+                            <a:srgbClr val="1E293B"/>
+                          </a:solidFill>
+                          <a:latin typeface="Calibri" pitchFamily="34" charset="0"/>
+                          <a:ea typeface="Calibri" pitchFamily="34" charset="-122"/>
+                          <a:cs typeface="Calibri" pitchFamily="34" charset="-120"/>
+                        </a:rPr>
+                        <a:t>3.6 s</a:t>
+                      </a:r>
+                      <a:endParaRPr lang="en-US" sz="900" dirty="0">
+                        <a:latin typeface="Calibri" charset="0"/>
+                        <a:ea typeface="Calibri" charset="0"/>
+                        <a:cs typeface="Calibri" charset="0"/>
+                      </a:endParaRPr>
+                    </a:p>
+                  </a:txBody>
+                  <a:tcPr marL="36576" marR="36576" marT="36576" marB="36576" anchor="ctr">
+                    <a:lnL w="6350" cap="flat" cmpd="sng" algn="ctr">
+                      <a:solidFill>
+                        <a:srgbClr val="CBD5E1"/>
+                      </a:solidFill>
+                      <a:prstDash val="solid"/>
+                      <a:round/>
+                      <a:headEnd type="none" w="med" len="med"/>
+                      <a:tailEnd type="none" w="med" len="med"/>
+                    </a:lnL>
+                    <a:lnR w="6350" cap="flat" cmpd="sng" algn="ctr">
+                      <a:solidFill>
+                        <a:srgbClr val="CBD5E1"/>
+                      </a:solidFill>
+                      <a:prstDash val="solid"/>
+                      <a:round/>
+                      <a:headEnd type="none" w="med" len="med"/>
+                      <a:tailEnd type="none" w="med" len="med"/>
+                    </a:lnR>
+                    <a:lnT w="6350" cap="flat" cmpd="sng" algn="ctr">
+                      <a:solidFill>
+                        <a:srgbClr val="CBD5E1"/>
+                      </a:solidFill>
+                      <a:prstDash val="solid"/>
+                      <a:round/>
+                      <a:headEnd type="none" w="med" len="med"/>
+                      <a:tailEnd type="none" w="med" len="med"/>
+                    </a:lnT>
+                    <a:lnB w="6350" cap="flat" cmpd="sng" algn="ctr">
+                      <a:solidFill>
+                        <a:srgbClr val="CBD5E1"/>
+                      </a:solidFill>
+                      <a:prstDash val="solid"/>
+                      <a:round/>
+                      <a:headEnd type="none" w="med" len="med"/>
+                      <a:tailEnd type="none" w="med" len="med"/>
+                    </a:lnB>
+                    <a:solidFill>
+                      <a:srgbClr val="FFFFFF"/>
+                    </a:solidFill>
+                  </a:tcPr>
+                </a:tc>
+                <a:tc>
+                  <a:txBody>
+                    <a:bodyPr/>
+                    <a:lstStyle/>
+                    <a:p>
+                      <a:pPr indent="0" marL="0">
+                        <a:buNone/>
+                      </a:pPr>
+                      <a:r>
+                        <a:rPr lang="en-US" sz="900" dirty="0">
+                          <a:solidFill>
+                            <a:srgbClr val="1E293B"/>
+                          </a:solidFill>
+                          <a:latin typeface="Calibri" pitchFamily="34" charset="0"/>
+                          <a:ea typeface="Calibri" pitchFamily="34" charset="-122"/>
+                          <a:cs typeface="Calibri" pitchFamily="34" charset="-120"/>
+                        </a:rPr>
+                        <a:t>16 / 0 / 5</a:t>
+                      </a:r>
+                      <a:endParaRPr lang="en-US" sz="900" dirty="0">
+                        <a:latin typeface="Calibri" charset="0"/>
+                        <a:ea typeface="Calibri" charset="0"/>
+                        <a:cs typeface="Calibri" charset="0"/>
+                      </a:endParaRPr>
+                    </a:p>
+                  </a:txBody>
+                  <a:tcPr marL="36576" marR="36576" marT="36576" marB="36576" anchor="ctr">
+                    <a:lnL w="6350" cap="flat" cmpd="sng" algn="ctr">
+                      <a:solidFill>
+                        <a:srgbClr val="CBD5E1"/>
+                      </a:solidFill>
+                      <a:prstDash val="solid"/>
+                      <a:round/>
+                      <a:headEnd type="none" w="med" len="med"/>
+                      <a:tailEnd type="none" w="med" len="med"/>
+                    </a:lnL>
+                    <a:lnR w="6350" cap="flat" cmpd="sng" algn="ctr">
+                      <a:solidFill>
+                        <a:srgbClr val="CBD5E1"/>
+                      </a:solidFill>
+                      <a:prstDash val="solid"/>
+                      <a:round/>
+                      <a:headEnd type="none" w="med" len="med"/>
+                      <a:tailEnd type="none" w="med" len="med"/>
+                    </a:lnR>
+                    <a:lnT w="6350" cap="flat" cmpd="sng" algn="ctr">
+                      <a:solidFill>
+                        <a:srgbClr val="CBD5E1"/>
+                      </a:solidFill>
+                      <a:prstDash val="solid"/>
+                      <a:round/>
+                      <a:headEnd type="none" w="med" len="med"/>
+                      <a:tailEnd type="none" w="med" len="med"/>
+                    </a:lnT>
+                    <a:lnB w="6350" cap="flat" cmpd="sng" algn="ctr">
+                      <a:solidFill>
+                        <a:srgbClr val="CBD5E1"/>
+                      </a:solidFill>
+                      <a:prstDash val="solid"/>
+                      <a:round/>
+                      <a:headEnd type="none" w="med" len="med"/>
+                      <a:tailEnd type="none" w="med" len="med"/>
+                    </a:lnB>
+                    <a:solidFill>
+                      <a:srgbClr val="FFFFFF"/>
+                    </a:solidFill>
+                  </a:tcPr>
+                </a:tc>
+                <a:tc>
+                  <a:txBody>
+                    <a:bodyPr/>
+                    <a:lstStyle/>
+                    <a:p>
+                      <a:pPr indent="0" marL="0">
+                        <a:buNone/>
+                      </a:pPr>
+                      <a:r>
+                        <a:rPr lang="en-US" sz="900" dirty="0">
+                          <a:solidFill>
+                            <a:srgbClr val="1E293B"/>
+                          </a:solidFill>
+                          <a:latin typeface="Calibri" pitchFamily="34" charset="0"/>
+                          <a:ea typeface="Calibri" pitchFamily="34" charset="-122"/>
+                          <a:cs typeface="Calibri" pitchFamily="34" charset="-120"/>
+                        </a:rPr>
+                        <a:t>2</a:t>
+                      </a:r>
+                      <a:endParaRPr lang="en-US" sz="900" dirty="0">
+                        <a:latin typeface="Calibri" charset="0"/>
+                        <a:ea typeface="Calibri" charset="0"/>
+                        <a:cs typeface="Calibri" charset="0"/>
+                      </a:endParaRPr>
+                    </a:p>
+                  </a:txBody>
+                  <a:tcPr marL="36576" marR="36576" marT="36576" marB="36576" anchor="ctr">
+                    <a:lnL w="6350" cap="flat" cmpd="sng" algn="ctr">
+                      <a:solidFill>
+                        <a:srgbClr val="CBD5E1"/>
+                      </a:solidFill>
+                      <a:prstDash val="solid"/>
+                      <a:round/>
+                      <a:headEnd type="none" w="med" len="med"/>
+                      <a:tailEnd type="none" w="med" len="med"/>
+                    </a:lnL>
+                    <a:lnR w="6350" cap="flat" cmpd="sng" algn="ctr">
+                      <a:solidFill>
+                        <a:srgbClr val="CBD5E1"/>
+                      </a:solidFill>
+                      <a:prstDash val="solid"/>
+                      <a:round/>
+                      <a:headEnd type="none" w="med" len="med"/>
+                      <a:tailEnd type="none" w="med" len="med"/>
+                    </a:lnR>
+                    <a:lnT w="6350" cap="flat" cmpd="sng" algn="ctr">
+                      <a:solidFill>
+                        <a:srgbClr val="CBD5E1"/>
+                      </a:solidFill>
+                      <a:prstDash val="solid"/>
+                      <a:round/>
+                      <a:headEnd type="none" w="med" len="med"/>
+                      <a:tailEnd type="none" w="med" len="med"/>
+                    </a:lnT>
+                    <a:lnB w="6350" cap="flat" cmpd="sng" algn="ctr">
+                      <a:solidFill>
+                        <a:srgbClr val="CBD5E1"/>
+                      </a:solidFill>
+                      <a:prstDash val="solid"/>
+                      <a:round/>
+                      <a:headEnd type="none" w="med" len="med"/>
+                      <a:tailEnd type="none" w="med" len="med"/>
+                    </a:lnB>
+                    <a:solidFill>
+                      <a:srgbClr val="FFFFFF"/>
+                    </a:solidFill>
+                  </a:tcPr>
+                </a:tc>
+                <a:tc>
+                  <a:txBody>
+                    <a:bodyPr/>
+                    <a:lstStyle/>
+                    <a:p>
+                      <a:pPr indent="0" marL="0">
+                        <a:buNone/>
+                      </a:pPr>
+                      <a:r>
+                        <a:rPr lang="en-US" sz="900" dirty="0">
+                          <a:solidFill>
+                            <a:srgbClr val="1E293B"/>
+                          </a:solidFill>
+                          <a:latin typeface="Calibri" pitchFamily="34" charset="0"/>
+                          <a:ea typeface="Calibri" pitchFamily="34" charset="-122"/>
+                          <a:cs typeface="Calibri" pitchFamily="34" charset="-120"/>
+                        </a:rPr>
+                        <a:t>0</a:t>
+                      </a:r>
+                      <a:endParaRPr lang="en-US" sz="900" dirty="0">
+                        <a:latin typeface="Calibri" charset="0"/>
+                        <a:ea typeface="Calibri" charset="0"/>
+                        <a:cs typeface="Calibri" charset="0"/>
+                      </a:endParaRPr>
+                    </a:p>
+                  </a:txBody>
+                  <a:tcPr marL="36576" marR="36576" marT="36576" marB="36576" anchor="ctr">
+                    <a:lnL w="6350" cap="flat" cmpd="sng" algn="ctr">
+                      <a:solidFill>
+                        <a:srgbClr val="CBD5E1"/>
+                      </a:solidFill>
+                      <a:prstDash val="solid"/>
+                      <a:round/>
+                      <a:headEnd type="none" w="med" len="med"/>
+                      <a:tailEnd type="none" w="med" len="med"/>
+                    </a:lnL>
+                    <a:lnR w="6350" cap="flat" cmpd="sng" algn="ctr">
+                      <a:solidFill>
+                        <a:srgbClr val="CBD5E1"/>
+                      </a:solidFill>
+                      <a:prstDash val="solid"/>
+                      <a:round/>
+                      <a:headEnd type="none" w="med" len="med"/>
+                      <a:tailEnd type="none" w="med" len="med"/>
+                    </a:lnR>
+                    <a:lnT w="6350" cap="flat" cmpd="sng" algn="ctr">
+                      <a:solidFill>
+                        <a:srgbClr val="CBD5E1"/>
+                      </a:solidFill>
+                      <a:prstDash val="solid"/>
+                      <a:round/>
+                      <a:headEnd type="none" w="med" len="med"/>
+                      <a:tailEnd type="none" w="med" len="med"/>
+                    </a:lnT>
+                    <a:lnB w="6350" cap="flat" cmpd="sng" algn="ctr">
+                      <a:solidFill>
+                        <a:srgbClr val="CBD5E1"/>
+                      </a:solidFill>
+                      <a:prstDash val="solid"/>
+                      <a:round/>
+                      <a:headEnd type="none" w="med" len="med"/>
+                      <a:tailEnd type="none" w="med" len="med"/>
+                    </a:lnB>
+                    <a:solidFill>
+                      <a:srgbClr val="FFFFFF"/>
+                    </a:solidFill>
+                  </a:tcPr>
+                </a:tc>
+                <a:tc>
+                  <a:txBody>
+                    <a:bodyPr/>
+                    <a:lstStyle/>
+                    <a:p>
+                      <a:pPr indent="0" marL="0">
+                        <a:buNone/>
+                      </a:pPr>
+                      <a:r>
+                        <a:rPr lang="en-US" sz="900" dirty="0">
+                          <a:solidFill>
+                            <a:srgbClr val="1E293B"/>
+                          </a:solidFill>
+                          <a:latin typeface="Calibri" pitchFamily="34" charset="0"/>
+                          <a:ea typeface="Calibri" pitchFamily="34" charset="-122"/>
+                          <a:cs typeface="Calibri" pitchFamily="34" charset="-120"/>
+                        </a:rPr>
+                        <a:t>3 / 1 / 9</a:t>
+                      </a:r>
+                      <a:endParaRPr lang="en-US" sz="900" dirty="0">
+                        <a:latin typeface="Calibri" charset="0"/>
+                        <a:ea typeface="Calibri" charset="0"/>
+                        <a:cs typeface="Calibri" charset="0"/>
+                      </a:endParaRPr>
+                    </a:p>
+                  </a:txBody>
+                  <a:tcPr marL="36576" marR="36576" marT="36576" marB="36576" anchor="ctr">
                     <a:lnL w="6350" cap="flat" cmpd="sng" algn="ctr">
                       <a:solidFill>
                         <a:srgbClr val="CBD5E1"/>
@@ -7326,8 +8282,8 @@
         </p:nvSpPr>
         <p:spPr>
           <a:xfrm>
-            <a:off x="411480" y="4105656"/>
-            <a:ext cx="7452360" cy="1005840"/>
+            <a:off x="411480" y="4014216"/>
+            <a:ext cx="7452360" cy="822960"/>
           </a:xfrm>
           <a:prstGeom prst="rect">
             <a:avLst/>
@@ -7343,7 +8299,7 @@
               <a:buNone/>
             </a:pPr>
             <a:r>
-              <a:rPr lang="en-US" sz="1100" dirty="0">
+              <a:rPr lang="en-US" sz="950" dirty="0">
                 <a:solidFill>
                   <a:srgbClr val="64748B"/>
                 </a:solidFill>
@@ -7351,9 +8307,9 @@
                 <a:ea typeface="Calibri" pitchFamily="34" charset="-122"/>
                 <a:cs typeface="Calibri" pitchFamily="34" charset="-120"/>
               </a:rPr>
-              <a:t>Instant = knowledge-base match, including known non-security structure (no AI call). AI = accepted AI suggestion. Human = sent to the review queue. Unknown = the setting never appears in the config, so it is reported, never assumed to pass. Before = the same files on the one-call-per-line build.</a:t>
-            </a:r>
-            <a:endParaRPr lang="en-US" sz="1100" dirty="0"/>
+              <a:t>Live run 2026-09-27 in the documented demo order (04 and 06 come after the review step, so their taught line is instant). Instant = knowledge-base or human-taught pattern, no AI. AI = accepted AI suggestion. Human = sent to review. Unknown = not in the config, unreadable, or AI-only evidence on a CAT I control; never assumed to pass. Before = one-call-per-line build.</a:t>
+            </a:r>
+            <a:endParaRPr lang="en-US" sz="950" dirty="0"/>
           </a:p>
         </p:txBody>
       </p:sp>
@@ -7460,7 +8416,49 @@
                 <a:ea typeface="Calibri" pitchFamily="34" charset="-122"/>
                 <a:cs typeface="Calibri" pitchFamily="34" charset="-120"/>
               </a:rPr>
-              <a:t>Secrets counted as redacted while the key stayed in place (tacacs/radius 'key 7', PSK variants)</a:t>
+              <a:t>An adversarial review got false PASSes from mixed VTY lines, banner text and an unapplied ACL: all closed, each a regression test</a:t>
+            </a:r>
+            <a:endParaRPr lang="en-US" sz="1050" dirty="0"/>
+          </a:p>
+          <a:p>
+            <a:pPr marL="342900" indent="-342900">
+              <a:spcAft>
+                <a:spcPts val="100"/>
+              </a:spcAft>
+              <a:buSzPct val="100000"/>
+              <a:buChar char="•"/>
+            </a:pPr>
+            <a:r>
+              <a:rPr lang="en-US" sz="1050" dirty="0">
+                <a:solidFill>
+                  <a:srgbClr val="1E293B"/>
+                </a:solidFill>
+                <a:latin typeface="Calibri" pitchFamily="34" charset="0"/>
+                <a:ea typeface="Calibri" pitchFamily="34" charset="-122"/>
+                <a:cs typeface="Calibri" pitchFamily="34" charset="-120"/>
+              </a:rPr>
+              <a:t>A live run: a cipher check compared 'SHA1' to 'sha1' case-sensitively (a false PASS): fixed, now labelled</a:t>
+            </a:r>
+            <a:endParaRPr lang="en-US" sz="1050" dirty="0"/>
+          </a:p>
+          <a:p>
+            <a:pPr marL="342900" indent="-342900">
+              <a:spcAft>
+                <a:spcPts val="100"/>
+              </a:spcAft>
+              <a:buSzPct val="100000"/>
+              <a:buChar char="•"/>
+            </a:pPr>
+            <a:r>
+              <a:rPr lang="en-US" sz="1050" dirty="0">
+                <a:solidFill>
+                  <a:srgbClr val="1E293B"/>
+                </a:solidFill>
+                <a:latin typeface="Calibri" pitchFamily="34" charset="0"/>
+                <a:ea typeface="Calibri" pitchFamily="34" charset="-122"/>
+                <a:cs typeface="Calibri" pitchFamily="34" charset="-120"/>
+              </a:rPr>
+              <a:t>Secrets counted as redacted while the key stayed; FortiOS, Junos and PAN-OS secret shapes added</a:t>
             </a:r>
             <a:endParaRPr lang="en-US" sz="1050" dirty="0"/>
           </a:p>
@@ -7485,48 +8483,6 @@
             </a:r>
             <a:endParaRPr lang="en-US" sz="1050" dirty="0"/>
           </a:p>
-          <a:p>
-            <a:pPr marL="342900" indent="-342900">
-              <a:spcAft>
-                <a:spcPts val="100"/>
-              </a:spcAft>
-              <a:buSzPct val="100000"/>
-              <a:buChar char="•"/>
-            </a:pPr>
-            <a:r>
-              <a:rPr lang="en-US" sz="1050" dirty="0">
-                <a:solidFill>
-                  <a:srgbClr val="1E293B"/>
-                </a:solidFill>
-                <a:latin typeface="Calibri" pitchFamily="34" charset="0"/>
-                <a:ea typeface="Calibri" pitchFamily="34" charset="-122"/>
-                <a:cs typeface="Calibri" pitchFamily="34" charset="-120"/>
-              </a:rPr>
-              <a:t>An AI guess overwriting a deterministic value; an AI value 'public RO' that would have hidden a default community</a:t>
-            </a:r>
-            <a:endParaRPr lang="en-US" sz="1050" dirty="0"/>
-          </a:p>
-          <a:p>
-            <a:pPr marL="342900" indent="-342900">
-              <a:spcAft>
-                <a:spcPts val="100"/>
-              </a:spcAft>
-              <a:buSzPct val="100000"/>
-              <a:buChar char="•"/>
-            </a:pPr>
-            <a:r>
-              <a:rPr lang="en-US" sz="1050" dirty="0">
-                <a:solidFill>
-                  <a:srgbClr val="1E293B"/>
-                </a:solidFill>
-                <a:latin typeface="Calibri" pitchFamily="34" charset="0"/>
-                <a:ea typeface="Calibri" pitchFamily="34" charset="-122"/>
-                <a:cs typeface="Calibri" pitchFamily="34" charset="-120"/>
-              </a:rPr>
-              <a:t>One AI call per line (minutes per file) and a call with no timeout that hung an upload</a:t>
-            </a:r>
-            <a:endParaRPr lang="en-US" sz="1050" dirty="0"/>
-          </a:p>
         </p:txBody>
       </p:sp>
       <p:sp>
@@ -7589,7 +8545,7 @@
                 <a:ea typeface="Calibri" pitchFamily="34" charset="-122"/>
                 <a:cs typeface="Calibri" pitchFamily="34" charset="-120"/>
               </a:rPr>
-              <a:t>Tier-2 classifier vs. hand-labeled golden set</a:t>
+              <a:t>Verdicts vs. hand-labelled ground truth</a:t>
             </a:r>
             <a:endParaRPr lang="en-US" sz="1300" dirty="0"/>
           </a:p>
@@ -7628,7 +8584,7 @@
                 <a:ea typeface="Cambria" pitchFamily="34" charset="-122"/>
                 <a:cs typeface="Cambria" pitchFamily="34" charset="-120"/>
               </a:rPr>
-              <a:t>95.8%</a:t>
+              <a:t>0</a:t>
             </a:r>
             <a:endParaRPr lang="en-US" sz="2400" dirty="0"/>
           </a:p>
@@ -7667,7 +8623,7 @@
                 <a:ea typeface="Calibri" pitchFamily="34" charset="-122"/>
                 <a:cs typeface="Calibri" pitchFamily="34" charset="-120"/>
               </a:rPr>
-              <a:t>precision on auto-accepted mappings</a:t>
+              <a:t>wrong verdicts (false PASS or FAIL) of 59 decided</a:t>
             </a:r>
             <a:endParaRPr lang="en-US" sz="1200" dirty="0"/>
           </a:p>
@@ -7706,7 +8662,7 @@
                 <a:ea typeface="Cambria" pitchFamily="34" charset="-122"/>
                 <a:cs typeface="Cambria" pitchFamily="34" charset="-120"/>
               </a:rPr>
-              <a:t>95.8%</a:t>
+              <a:t>91%</a:t>
             </a:r>
             <a:endParaRPr lang="en-US" sz="2400" dirty="0"/>
           </a:p>
@@ -7745,7 +8701,7 @@
                 <a:ea typeface="Calibri" pitchFamily="34" charset="-122"/>
                 <a:cs typeface="Calibri" pitchFamily="34" charset="-120"/>
               </a:rPr>
-              <a:t>recall on real security settings</a:t>
+              <a:t>of 65 labelled checks decided; the rest reported unknown</a:t>
             </a:r>
             <a:endParaRPr lang="en-US" sz="1200" dirty="0"/>
           </a:p>
@@ -7778,13 +8734,13 @@
             <a:r>
               <a:rPr lang="en-US" sz="2400" b="1" dirty="0">
                 <a:solidFill>
-                  <a:srgbClr val="FCA5A5"/>
+                  <a:srgbClr val="BEF264"/>
                 </a:solidFill>
                 <a:latin typeface="Cambria" pitchFamily="34" charset="0"/>
                 <a:ea typeface="Cambria" pitchFamily="34" charset="-122"/>
                 <a:cs typeface="Cambria" pitchFamily="34" charset="-120"/>
               </a:rPr>
-              <a:t>1 of 33</a:t>
+              <a:t>0 / 52</a:t>
             </a:r>
             <a:endParaRPr lang="en-US" sz="2400" dirty="0"/>
           </a:p>
@@ -7823,7 +8779,7 @@
                 <a:ea typeface="Calibri" pitchFamily="34" charset="-122"/>
                 <a:cs typeface="Calibri" pitchFamily="34" charset="-120"/>
               </a:rPr>
-              <a:t>wrong mappings auto-accepted</a:t>
+              <a:t>prompt-injection lines that reach the AI</a:t>
             </a:r>
             <a:endParaRPr lang="en-US" sz="1200" dirty="0"/>
           </a:p>
@@ -7862,7 +8818,7 @@
                 <a:ea typeface="Calibri" pitchFamily="34" charset="-122"/>
                 <a:cs typeface="Calibri" pitchFamily="34" charset="-120"/>
               </a:rPr>
-              <a:t>33 hand-labeled lines (24 settings, 9 negatives), live batch mode, 2026-09-25</a:t>
+              <a:t>7 configs, 5 vendors, AI off and on; enforced in CI. Classifier golden set: 95.8% precision.</a:t>
             </a:r>
             <a:endParaRPr lang="en-US" sz="950" dirty="0"/>
           </a:p>
@@ -8258,7 +9214,7 @@
                 <a:ea typeface="Calibri" pitchFamily="34" charset="-122"/>
                 <a:cs typeface="Calibri" pitchFamily="34" charset="-120"/>
               </a:rPr>
-              <a:t>Single + bulk upload, any format</a:t>
+              <a:t>Upload: CLI, block CLI, XML, JSON; bulk</a:t>
             </a:r>
             <a:endParaRPr lang="en-US" sz="1300" dirty="0"/>
           </a:p>
@@ -8279,7 +9235,7 @@
                 <a:ea typeface="Calibri" pitchFamily="34" charset="-122"/>
                 <a:cs typeface="Calibri" pitchFamily="34" charset="-120"/>
               </a:rPr>
-              <a:t>11-type redaction before any AI call</a:t>
+              <a:t>13-type redaction + injection gate before AI</a:t>
             </a:r>
             <a:endParaRPr lang="en-US" sz="1300" dirty="0"/>
           </a:p>
@@ -8300,7 +9256,7 @@
                 <a:ea typeface="Calibri" pitchFamily="34" charset="-122"/>
                 <a:cs typeface="Calibri" pitchFamily="34" charset="-120"/>
               </a:rPr>
-              <a:t>Prompt-injection gate before any AI call</a:t>
+              <a:t>Tier 1 → 2 → 3, type-validated; offline modes</a:t>
             </a:r>
             <a:endParaRPr lang="en-US" sz="1300" dirty="0"/>
           </a:p>
@@ -8321,7 +9277,7 @@
                 <a:ea typeface="Calibri" pitchFamily="34" charset="-122"/>
                 <a:cs typeface="Calibri" pitchFamily="34" charset="-120"/>
               </a:rPr>
-              <a:t>Tier 1 → 2 → 3 resolution, type-validated</a:t>
+              <a:t>Review queue: verified, hash-chained decisions</a:t>
             </a:r>
             <a:endParaRPr lang="en-US" sz="1300" dirty="0"/>
           </a:p>
@@ -8342,7 +9298,7 @@
                 <a:ea typeface="Calibri" pitchFamily="34" charset="-122"/>
                 <a:cs typeface="Calibri" pitchFamily="34" charset="-120"/>
               </a:rPr>
-              <a:t>Review queue with auditor judgment</a:t>
+              <a:t>39 rules; fail-closed, per-list ACL engine</a:t>
             </a:r>
             <a:endParaRPr lang="en-US" sz="1300" dirty="0"/>
           </a:p>
@@ -8363,7 +9319,7 @@
                 <a:ea typeface="Calibri" pitchFamily="34" charset="-122"/>
                 <a:cs typeface="Calibri" pitchFamily="34" charset="-120"/>
               </a:rPr>
-              <a:t>39 rules, 6 predicate types, vendor-scoped</a:t>
+              <a:t>5 vendors as data (Juniper, FortiGate: no code)</a:t>
             </a:r>
             <a:endParaRPr lang="en-US" sz="1300" dirty="0"/>
           </a:p>
@@ -8384,7 +9340,7 @@
                 <a:ea typeface="Calibri" pitchFamily="34" charset="-122"/>
                 <a:cs typeface="Calibri" pitchFamily="34" charset="-120"/>
               </a:rPr>
-              <a:t>Per-device PDF, executive summary</a:t>
+              <a:t>PDF: integrity panel, evidence per finding</a:t>
             </a:r>
             <a:endParaRPr lang="en-US" sz="1300" dirty="0"/>
           </a:p>
@@ -8405,7 +9361,7 @@
                 <a:ea typeface="Calibri" pitchFamily="34" charset="-122"/>
                 <a:cs typeface="Calibri" pitchFamily="34" charset="-120"/>
               </a:rPr>
-              <a:t>160 offline tests + CI; golden-set eval</a:t>
+              <a:t>240 tests + CI incl. verdict ground truth</a:t>
             </a:r>
             <a:endParaRPr lang="en-US" sz="1300" dirty="0"/>
           </a:p>
@@ -8487,7 +9443,28 @@
                 <a:ea typeface="Calibri" pitchFamily="34" charset="-122"/>
                 <a:cs typeface="Calibri" pitchFamily="34" charset="-120"/>
               </a:rPr>
-              <a:t>General cross-reference linking (e.g. Cisco AAA method lists)</a:t>
+              <a:t>Cross-reference linking by name (AAA lists, FortiOS policies)</a:t>
+            </a:r>
+            <a:endParaRPr lang="en-US" sz="1300" dirty="0"/>
+          </a:p>
+          <a:p>
+            <a:pPr marL="342900" indent="-342900">
+              <a:spcAft>
+                <a:spcPts val="600"/>
+              </a:spcAft>
+              <a:buSzPct val="100000"/>
+              <a:buChar char="•"/>
+            </a:pPr>
+            <a:r>
+              <a:rPr lang="en-US" sz="1300" dirty="0">
+                <a:solidFill>
+                  <a:srgbClr val="E2E8F0"/>
+                </a:solidFill>
+                <a:latin typeface="Calibri" pitchFamily="34" charset="0"/>
+                <a:ea typeface="Calibri" pitchFamily="34" charset="-122"/>
+                <a:cs typeface="Calibri" pitchFamily="34" charset="-120"/>
+              </a:rPr>
+              <a:t>Vendor defaults for settings a config omits</a:t>
             </a:r>
             <a:endParaRPr lang="en-US" sz="1300" dirty="0"/>
           </a:p>
@@ -8529,7 +9506,7 @@
                 <a:ea typeface="Calibri" pitchFamily="34" charset="-122"/>
                 <a:cs typeface="Calibri" pitchFamily="34" charset="-120"/>
               </a:rPr>
-              <a:t>RBAC / multi-tenant enforcement</a:t>
+              <a:t>Login UI and roles (reviewer tokens exist)</a:t>
             </a:r>
             <a:endParaRPr lang="en-US" sz="1300" dirty="0"/>
           </a:p>
@@ -8575,27 +9552,6 @@
             </a:r>
             <a:endParaRPr lang="en-US" sz="1300" dirty="0"/>
           </a:p>
-          <a:p>
-            <a:pPr marL="342900" indent="-342900">
-              <a:spcAft>
-                <a:spcPts val="600"/>
-              </a:spcAft>
-              <a:buSzPct val="100000"/>
-              <a:buChar char="•"/>
-            </a:pPr>
-            <a:r>
-              <a:rPr lang="en-US" sz="1300" dirty="0">
-                <a:solidFill>
-                  <a:srgbClr val="E2E8F0"/>
-                </a:solidFill>
-                <a:latin typeface="Calibri" pitchFamily="34" charset="0"/>
-                <a:ea typeface="Calibri" pitchFamily="34" charset="-122"/>
-                <a:cs typeface="Calibri" pitchFamily="34" charset="-120"/>
-              </a:rPr>
-              <a:t>Self-hosted LLM (today: redacted config to Groq/Gemini)</a:t>
-            </a:r>
-            <a:endParaRPr lang="en-US" sz="1300" dirty="0"/>
-          </a:p>
         </p:txBody>
       </p:sp>
       <p:sp>
@@ -8695,7 +9651,7 @@
                 <a:ea typeface="Calibri" pitchFamily="34" charset="-122"/>
                 <a:cs typeface="Calibri" pitchFamily="34" charset="-120"/>
               </a:rPr>
-              <a:t>arq/Redis job queue, per-provider rate limits</a:t>
+              <a:t>Job queue, per-provider rate limits</a:t>
             </a:r>
             <a:endParaRPr lang="en-US" sz="1300" dirty="0"/>
           </a:p>
@@ -8716,7 +9672,7 @@
                 <a:ea typeface="Calibri" pitchFamily="34" charset="-122"/>
                 <a:cs typeface="Calibri" pitchFamily="34" charset="-120"/>
               </a:rPr>
-              <a:t>Self-hosted model behind the same interface</a:t>
+              <a:t>Benchmark a local model (Ollama) on the ground truth</a:t>
             </a:r>
             <a:endParaRPr lang="en-US" sz="1300" dirty="0"/>
           </a:p>
@@ -8779,7 +9735,7 @@
                 <a:ea typeface="Calibri" pitchFamily="34" charset="-122"/>
                 <a:cs typeface="Calibri" pitchFamily="34" charset="-120"/>
               </a:rPr>
-              <a:t>Larger golden set, per vendor</a:t>
+              <a:t>Larger labelled set, per vendor</a:t>
             </a:r>
             <a:endParaRPr lang="en-US" sz="1300" dirty="0"/>
           </a:p>

</xml_diff>

<commit_message>
Docs and decks: 73/73 labelled verdicts, vendor defaults, FortiGate policies, refreshed live run
Co-Authored-By: Claude Opus 5.5 (1M context) <noreply@anthropic.com>
</commit_message>
<xml_diff>
--- a/docs/AEGIS-Technical-Presentation.pptx
+++ b/docs/AEGIS-Technical-Presentation.pptx
@@ -1938,7 +1938,7 @@
                 <a:ea typeface="Cambria" pitchFamily="34" charset="-122"/>
                 <a:cs typeface="Cambria" pitchFamily="34" charset="-120"/>
               </a:rPr>
-              <a:t>240</a:t>
+              <a:t>242</a:t>
             </a:r>
             <a:endParaRPr lang="en-US" sz="4400" dirty="0"/>
           </a:p>
@@ -4600,7 +4600,7 @@
                           <a:ea typeface="Calibri" pitchFamily="34" charset="-122"/>
                           <a:cs typeface="Calibri" pitchFamily="34" charset="-120"/>
                         </a:rPr>
-                        <a:t>14 s (640 s)</a:t>
+                        <a:t>14.3 s (640 s)</a:t>
                       </a:r>
                       <a:endParaRPr lang="en-US" sz="900" dirty="0">
                         <a:latin typeface="Calibri" charset="0"/>
@@ -4668,7 +4668,7 @@
                           <a:ea typeface="Calibri" pitchFamily="34" charset="-122"/>
                           <a:cs typeface="Calibri" pitchFamily="34" charset="-120"/>
                         </a:rPr>
-                        <a:t>36 / 14 / 31</a:t>
+                        <a:t>36 / 13 / 32</a:t>
                       </a:r>
                       <a:endParaRPr lang="en-US" sz="900" dirty="0">
                         <a:latin typeface="Calibri" charset="0"/>
@@ -4872,7 +4872,7 @@
                           <a:ea typeface="Calibri" pitchFamily="34" charset="-122"/>
                           <a:cs typeface="Calibri" pitchFamily="34" charset="-120"/>
                         </a:rPr>
-                        <a:t>15 / 7 / 12</a:t>
+                        <a:t>15 / 11 / 8</a:t>
                       </a:r>
                       <a:endParaRPr lang="en-US" sz="900" dirty="0">
                         <a:latin typeface="Calibri" charset="0"/>
@@ -5078,7 +5078,7 @@
                           <a:ea typeface="Calibri" pitchFamily="34" charset="-122"/>
                           <a:cs typeface="Calibri" pitchFamily="34" charset="-120"/>
                         </a:rPr>
-                        <a:t>11.5 s (284 s)</a:t>
+                        <a:t>11.3 s (284 s)</a:t>
                       </a:r>
                       <a:endParaRPr lang="en-US" sz="900" dirty="0">
                         <a:latin typeface="Calibri" charset="0"/>
@@ -5146,7 +5146,7 @@
                           <a:ea typeface="Calibri" pitchFamily="34" charset="-122"/>
                           <a:cs typeface="Calibri" pitchFamily="34" charset="-120"/>
                         </a:rPr>
-                        <a:t>30 / 6 / 21</a:t>
+                        <a:t>33 / 2 / 22</a:t>
                       </a:r>
                       <a:endParaRPr lang="en-US" sz="900" dirty="0">
                         <a:latin typeface="Calibri" charset="0"/>
@@ -5350,7 +5350,7 @@
                           <a:ea typeface="Calibri" pitchFamily="34" charset="-122"/>
                           <a:cs typeface="Calibri" pitchFamily="34" charset="-120"/>
                         </a:rPr>
-                        <a:t>8 / 0 / 10</a:t>
+                        <a:t>5 / 2 / 11</a:t>
                       </a:r>
                       <a:endParaRPr lang="en-US" sz="900" dirty="0">
                         <a:latin typeface="Calibri" charset="0"/>
@@ -5556,7 +5556,7 @@
                           <a:ea typeface="Calibri" pitchFamily="34" charset="-122"/>
                           <a:cs typeface="Calibri" pitchFamily="34" charset="-120"/>
                         </a:rPr>
-                        <a:t>17 s (713 s)</a:t>
+                        <a:t>9.3 s (713 s)</a:t>
                       </a:r>
                       <a:endParaRPr lang="en-US" sz="900" dirty="0">
                         <a:latin typeface="Calibri" charset="0"/>
@@ -5624,7 +5624,7 @@
                           <a:ea typeface="Calibri" pitchFamily="34" charset="-122"/>
                           <a:cs typeface="Calibri" pitchFamily="34" charset="-120"/>
                         </a:rPr>
-                        <a:t>29 / 10 / 31</a:t>
+                        <a:t>33 / 8 / 29</a:t>
                       </a:r>
                       <a:endParaRPr lang="en-US" sz="900" dirty="0">
                         <a:latin typeface="Calibri" charset="0"/>
@@ -6034,7 +6034,7 @@
                           <a:ea typeface="Calibri" pitchFamily="34" charset="-122"/>
                           <a:cs typeface="Calibri" pitchFamily="34" charset="-120"/>
                         </a:rPr>
-                        <a:t>3.1 s (387 s)</a:t>
+                        <a:t>3 s (387 s)</a:t>
                       </a:r>
                       <a:endParaRPr lang="en-US" sz="900" dirty="0">
                         <a:latin typeface="Calibri" charset="0"/>
@@ -6306,7 +6306,7 @@
                           <a:ea typeface="Calibri" pitchFamily="34" charset="-122"/>
                           <a:cs typeface="Calibri" pitchFamily="34" charset="-120"/>
                         </a:rPr>
-                        <a:t>4 / 10 / 20</a:t>
+                        <a:t>4 / 21 / 9</a:t>
                       </a:r>
                       <a:endParaRPr lang="en-US" sz="900" dirty="0">
                         <a:latin typeface="Calibri" charset="0"/>
@@ -6512,7 +6512,7 @@
                           <a:ea typeface="Calibri" pitchFamily="34" charset="-122"/>
                           <a:cs typeface="Calibri" pitchFamily="34" charset="-120"/>
                         </a:rPr>
-                        <a:t>9.1 s (120 s)</a:t>
+                        <a:t>9.2 s (120 s)</a:t>
                       </a:r>
                       <a:endParaRPr lang="en-US" sz="900" dirty="0">
                         <a:latin typeface="Calibri" charset="0"/>
@@ -6990,7 +6990,7 @@
                           <a:ea typeface="Calibri" pitchFamily="34" charset="-122"/>
                           <a:cs typeface="Calibri" pitchFamily="34" charset="-120"/>
                         </a:rPr>
-                        <a:t>3 s (505 s)</a:t>
+                        <a:t>3.2 s (505 s)</a:t>
                       </a:r>
                       <a:endParaRPr lang="en-US" sz="900" dirty="0">
                         <a:latin typeface="Calibri" charset="0"/>
@@ -7262,7 +7262,7 @@
                           <a:ea typeface="Calibri" pitchFamily="34" charset="-122"/>
                           <a:cs typeface="Calibri" pitchFamily="34" charset="-120"/>
                         </a:rPr>
-                        <a:t>21 / 1 / 12</a:t>
+                        <a:t>20 / 6 / 8</a:t>
                       </a:r>
                       <a:endParaRPr lang="en-US" sz="900" dirty="0">
                         <a:latin typeface="Calibri" charset="0"/>
@@ -7468,7 +7468,7 @@
                           <a:ea typeface="Calibri" pitchFamily="34" charset="-122"/>
                           <a:cs typeface="Calibri" pitchFamily="34" charset="-120"/>
                         </a:rPr>
-                        <a:t>2.9 s</a:t>
+                        <a:t>3 s</a:t>
                       </a:r>
                       <a:endParaRPr lang="en-US" sz="900" dirty="0">
                         <a:latin typeface="Calibri" charset="0"/>
@@ -7878,7 +7878,7 @@
                           <a:ea typeface="Calibri" pitchFamily="34" charset="-122"/>
                           <a:cs typeface="Calibri" pitchFamily="34" charset="-120"/>
                         </a:rPr>
-                        <a:t>21</a:t>
+                        <a:t>40</a:t>
                       </a:r>
                       <a:endParaRPr lang="en-US" sz="900" dirty="0">
                         <a:latin typeface="Calibri" charset="0"/>
@@ -7946,7 +7946,7 @@
                           <a:ea typeface="Calibri" pitchFamily="34" charset="-122"/>
                           <a:cs typeface="Calibri" pitchFamily="34" charset="-120"/>
                         </a:rPr>
-                        <a:t>3.6 s</a:t>
+                        <a:t>2.9 s</a:t>
                       </a:r>
                       <a:endParaRPr lang="en-US" sz="900" dirty="0">
                         <a:latin typeface="Calibri" charset="0"/>
@@ -8014,7 +8014,7 @@
                           <a:ea typeface="Calibri" pitchFamily="34" charset="-122"/>
                           <a:cs typeface="Calibri" pitchFamily="34" charset="-120"/>
                         </a:rPr>
-                        <a:t>16 / 0 / 5</a:t>
+                        <a:t>35 / 0 / 5</a:t>
                       </a:r>
                       <a:endParaRPr lang="en-US" sz="900" dirty="0">
                         <a:latin typeface="Calibri" charset="0"/>
@@ -8218,7 +8218,7 @@
                           <a:ea typeface="Calibri" pitchFamily="34" charset="-122"/>
                           <a:cs typeface="Calibri" pitchFamily="34" charset="-120"/>
                         </a:rPr>
-                        <a:t>3 / 1 / 9</a:t>
+                        <a:t>3 / 3 / 7</a:t>
                       </a:r>
                       <a:endParaRPr lang="en-US" sz="900" dirty="0">
                         <a:latin typeface="Calibri" charset="0"/>
@@ -8307,7 +8307,7 @@
                 <a:ea typeface="Calibri" pitchFamily="34" charset="-122"/>
                 <a:cs typeface="Calibri" pitchFamily="34" charset="-120"/>
               </a:rPr>
-              <a:t>Live run 2026-09-27 in the documented demo order (04 and 06 come after the review step, so their taught line is instant). Instant = knowledge-base or human-taught pattern, no AI. AI = accepted AI suggestion. Human = sent to review. Unknown = not in the config, unreadable, or AI-only evidence on a CAT I control; never assumed to pass. Before = one-call-per-line build.</a:t>
+              <a:t>Live run 2026-09-27 in the documented demo order (04 and 06 come after the review step, so their taught line is instant). Instant = knowledge-base or human-taught pattern, no AI. AI = accepted AI suggestion. Human = sent to review. Unknown = no rule-relevant setting and no vendor default, unreadable, or AI-only evidence on a CAT I control; never assumed to pass. Before = one-call-per-line build.</a:t>
             </a:r>
             <a:endParaRPr lang="en-US" sz="950" dirty="0"/>
           </a:p>
@@ -8623,7 +8623,7 @@
                 <a:ea typeface="Calibri" pitchFamily="34" charset="-122"/>
                 <a:cs typeface="Calibri" pitchFamily="34" charset="-120"/>
               </a:rPr>
-              <a:t>wrong verdicts (false PASS or FAIL) of 59 decided</a:t>
+              <a:t>wrong verdicts (false PASS or FAIL) of 73 labelled</a:t>
             </a:r>
             <a:endParaRPr lang="en-US" sz="1200" dirty="0"/>
           </a:p>
@@ -8662,7 +8662,7 @@
                 <a:ea typeface="Cambria" pitchFamily="34" charset="-122"/>
                 <a:cs typeface="Cambria" pitchFamily="34" charset="-120"/>
               </a:rPr>
-              <a:t>91%</a:t>
+              <a:t>73/73</a:t>
             </a:r>
             <a:endParaRPr lang="en-US" sz="2400" dirty="0"/>
           </a:p>
@@ -8701,7 +8701,7 @@
                 <a:ea typeface="Calibri" pitchFamily="34" charset="-122"/>
                 <a:cs typeface="Calibri" pitchFamily="34" charset="-120"/>
               </a:rPr>
-              <a:t>of 65 labelled checks decided; the rest reported unknown</a:t>
+              <a:t>labelled checks decided and correct, AI off or on</a:t>
             </a:r>
             <a:endParaRPr lang="en-US" sz="1200" dirty="0"/>
           </a:p>
@@ -8818,7 +8818,7 @@
                 <a:ea typeface="Calibri" pitchFamily="34" charset="-122"/>
                 <a:cs typeface="Calibri" pitchFamily="34" charset="-120"/>
               </a:rPr>
-              <a:t>7 configs, 5 vendors, AI off and on; enforced in CI. Classifier golden set: 95.8% precision.</a:t>
+              <a:t>7 configs, 5 vendors; enforced in CI. Classifier golden set: 95.8% precision.</a:t>
             </a:r>
             <a:endParaRPr lang="en-US" sz="950" dirty="0"/>
           </a:p>
@@ -9361,7 +9361,7 @@
                 <a:ea typeface="Calibri" pitchFamily="34" charset="-122"/>
                 <a:cs typeface="Calibri" pitchFamily="34" charset="-120"/>
               </a:rPr>
-              <a:t>240 tests + CI incl. verdict ground truth</a:t>
+              <a:t>242 tests + CI incl. verdict ground truth</a:t>
             </a:r>
             <a:endParaRPr lang="en-US" sz="1300" dirty="0"/>
           </a:p>
@@ -9443,7 +9443,7 @@
                 <a:ea typeface="Calibri" pitchFamily="34" charset="-122"/>
                 <a:cs typeface="Calibri" pitchFamily="34" charset="-120"/>
               </a:rPr>
-              <a:t>Cross-reference linking by name (AAA lists, FortiOS policies)</a:t>
+              <a:t>Cross-reference linking by name (e.g. AAA method lists)</a:t>
             </a:r>
             <a:endParaRPr lang="en-US" sz="1300" dirty="0"/>
           </a:p>
@@ -9464,7 +9464,7 @@
                 <a:ea typeface="Calibri" pitchFamily="34" charset="-122"/>
                 <a:cs typeface="Calibri" pitchFamily="34" charset="-120"/>
               </a:rPr>
-              <a:t>Vendor defaults for settings a config omits</a:t>
+              <a:t>Vendor defaults beyond Cisco IOS; per-interface CDP</a:t>
             </a:r>
             <a:endParaRPr lang="en-US" sz="1300" dirty="0"/>
           </a:p>

</xml_diff>

<commit_message>
AI-only evidence never passes any control; live held-out 41/41 on the current build
A live held-out run after the second-review fixes gave one false PASS: the
AI read a Junos `set snmp trap-group ... targets` line as a syslog host and
passed NIST AU-4(1), a CAT III rule (and a false FAIL: a zone's
host-inbound-traffic telnet read as telnet enabled). Both lines now have
Tier-1 patterns, and the asymmetric-trust guard covers every severity: AI
evidence may FAIL a control, a human confirmation turns it into a PASS.

Current build: 73/73 labelled and 41/41 held-out decided, AI off and live,
0 false PASS / FAIL. Every run, including the one with the false PASS, is in
the README table and eval/results/. 278 tests. Docs, 2-page PDF and deck
updated.

Co-Authored-By: Claude Opus 5.5 (1M context) <noreply@anthropic.com>
</commit_message>
<xml_diff>
--- a/docs/AEGIS-Technical-Presentation.pptx
+++ b/docs/AEGIS-Technical-Presentation.pptx
@@ -1287,7 +1287,7 @@
       </p:sp>
       <p:pic>
         <p:nvPicPr>
-          <p:cNvPr id="4" name="Image 0" descr="documents\tech-deck\assets\sih2026.png">    </p:cNvPr>
+          <p:cNvPr id="4" name="Image 0" descr="C:\Users\ADVAIT\SAVECODE\sih\documents\tech-deck\assets\sih2026.png">    </p:cNvPr>
           <p:cNvPicPr>
             <a:picLocks noChangeAspect="1"/>
           </p:cNvPicPr>
@@ -1311,7 +1311,7 @@
       </p:pic>
       <p:pic>
         <p:nvPicPr>
-          <p:cNvPr id="5" name="Image 1" descr="documents\tech-deck\assets\six_origins.png">    </p:cNvPr>
+          <p:cNvPr id="5" name="Image 1" descr="C:\Users\ADVAIT\SAVECODE\sih\documents\tech-deck\assets\six_origins.png">    </p:cNvPr>
           <p:cNvPicPr>
             <a:picLocks noChangeAspect="1"/>
           </p:cNvPicPr>
@@ -1650,7 +1650,7 @@
                 <a:ea typeface="Cambria" pitchFamily="34" charset="-122"/>
                 <a:cs typeface="Cambria" pitchFamily="34" charset="-120"/>
               </a:rPr>
-              <a:t>39</a:t>
+              <a:t>90</a:t>
             </a:r>
             <a:endParaRPr lang="en-US" sz="4400" dirty="0"/>
           </a:p>
@@ -1938,7 +1938,7 @@
                 <a:ea typeface="Cambria" pitchFamily="34" charset="-122"/>
                 <a:cs typeface="Cambria" pitchFamily="34" charset="-120"/>
               </a:rPr>
-              <a:t>242</a:t>
+              <a:t>278</a:t>
             </a:r>
             <a:endParaRPr lang="en-US" sz="4400" dirty="0"/>
           </a:p>
@@ -2200,7 +2200,7 @@
       </p:grpSpPr>
       <p:pic>
         <p:nvPicPr>
-          <p:cNvPr id="2" name="Image 0" descr="documents\tech-deck\assets\sih2026.png">    </p:cNvPr>
+          <p:cNvPr id="2" name="Image 0" descr="C:\Users\ADVAIT\SAVECODE\sih\documents\tech-deck\assets\sih2026.png">    </p:cNvPr>
           <p:cNvPicPr>
             <a:picLocks noChangeAspect="1"/>
           </p:cNvPicPr>
@@ -2224,7 +2224,7 @@
       </p:pic>
       <p:pic>
         <p:nvPicPr>
-          <p:cNvPr id="3" name="Image 1" descr="documents\tech-deck\assets\six_origins.png">    </p:cNvPr>
+          <p:cNvPr id="3" name="Image 1" descr="C:\Users\ADVAIT\SAVECODE\sih\documents\tech-deck\assets\six_origins.png">    </p:cNvPr>
           <p:cNvPicPr>
             <a:picLocks noChangeAspect="1"/>
           </p:cNvPicPr>
@@ -2365,7 +2365,7 @@
       </p:sp>
       <p:pic>
         <p:nvPicPr>
-          <p:cNvPr id="7" name="Image 2" descr="documents\tech-deck\assets\architecture-phases.png">    </p:cNvPr>
+          <p:cNvPr id="7" name="Image 2" descr="C:\Users\ADVAIT\SAVECODE\sih\documents\tech-deck\assets\architecture-phases.png">    </p:cNvPr>
           <p:cNvPicPr>
             <a:picLocks noChangeAspect="1"/>
           </p:cNvPicPr>
@@ -2421,7 +2421,7 @@
       </p:grpSpPr>
       <p:pic>
         <p:nvPicPr>
-          <p:cNvPr id="2" name="Image 0" descr="documents\tech-deck\assets\sih2026.png">    </p:cNvPr>
+          <p:cNvPr id="2" name="Image 0" descr="C:\Users\ADVAIT\SAVECODE\sih\documents\tech-deck\assets\sih2026.png">    </p:cNvPr>
           <p:cNvPicPr>
             <a:picLocks noChangeAspect="1"/>
           </p:cNvPicPr>
@@ -2445,7 +2445,7 @@
       </p:pic>
       <p:pic>
         <p:nvPicPr>
-          <p:cNvPr id="3" name="Image 1" descr="documents\tech-deck\assets\six_origins.png">    </p:cNvPr>
+          <p:cNvPr id="3" name="Image 1" descr="C:\Users\ADVAIT\SAVECODE\sih\documents\tech-deck\assets\six_origins.png">    </p:cNvPr>
           <p:cNvPicPr>
             <a:picLocks noChangeAspect="1"/>
           </p:cNvPicPr>
@@ -3774,7 +3774,7 @@
       </p:grpSpPr>
       <p:pic>
         <p:nvPicPr>
-          <p:cNvPr id="2" name="Image 0" descr="documents\tech-deck\assets\sih2026.png">    </p:cNvPr>
+          <p:cNvPr id="2" name="Image 0" descr="C:\Users\ADVAIT\SAVECODE\sih\documents\tech-deck\assets\sih2026.png">    </p:cNvPr>
           <p:cNvPicPr>
             <a:picLocks noChangeAspect="1"/>
           </p:cNvPicPr>
@@ -3798,7 +3798,7 @@
       </p:pic>
       <p:pic>
         <p:nvPicPr>
-          <p:cNvPr id="3" name="Image 1" descr="documents\tech-deck\assets\six_origins.png">    </p:cNvPr>
+          <p:cNvPr id="3" name="Image 1" descr="C:\Users\ADVAIT\SAVECODE\sih\documents\tech-deck\assets\six_origins.png">    </p:cNvPr>
           <p:cNvPicPr>
             <a:picLocks noChangeAspect="1"/>
           </p:cNvPicPr>
@@ -8307,7 +8307,7 @@
                 <a:ea typeface="Calibri" pitchFamily="34" charset="-122"/>
                 <a:cs typeface="Calibri" pitchFamily="34" charset="-120"/>
               </a:rPr>
-              <a:t>Live run 2026-09-27 in the documented demo order (04 and 06 come after the review step, so their taught line is instant). Instant = knowledge-base or human-taught pattern, no AI. AI = accepted AI suggestion. Human = sent to review. Unknown = no rule-relevant setting and no vendor default, unreadable, or AI-only evidence on a CAT I control; never assumed to pass. Before = one-call-per-line build.</a:t>
+              <a:t>Live run 2026-09-27 in the documented demo order (04 and 06 come after the review step, so their taught line is instant). Instant = knowledge-base or human-taught pattern, no AI. AI = accepted AI suggestion. Human = sent to review. Unknown = no rule-relevant setting and no vendor default, unreadable, or AI-only evidence (which never passes); never assumed to pass. Before = one-call-per-line build.</a:t>
             </a:r>
             <a:endParaRPr lang="en-US" sz="950" dirty="0"/>
           </a:p>
@@ -8416,7 +8416,49 @@
                 <a:ea typeface="Calibri" pitchFamily="34" charset="-122"/>
                 <a:cs typeface="Calibri" pitchFamily="34" charset="-120"/>
               </a:rPr>
-              <a:t>An adversarial review got false PASSes from mixed VTY lines, banner text and an unapplied ACL: all closed, each a regression test</a:t>
+              <a:t>Review 1: mixed VTY lines, banner text and an unapplied ACL gave false PASSes: all closed</a:t>
+            </a:r>
+            <a:endParaRPr lang="en-US" sz="1050" dirty="0"/>
+          </a:p>
+          <a:p>
+            <a:pPr marL="342900" indent="-342900">
+              <a:spcAft>
+                <a:spcPts val="100"/>
+              </a:spcAft>
+              <a:buSzPct val="100000"/>
+              <a:buChar char="•"/>
+            </a:pPr>
+            <a:r>
+              <a:rPr lang="en-US" sz="1050" dirty="0">
+                <a:solidFill>
+                  <a:srgbClr val="1E293B"/>
+                </a:solidFill>
+                <a:latin typeface="Calibri" pitchFamily="34" charset="0"/>
+                <a:ea typeface="Calibri" pitchFamily="34" charset="-122"/>
+                <a:cs typeface="Calibri" pitchFamily="34" charset="-120"/>
+              </a:rPr>
+              <a:t>Review 2: 7 more (interface QoS read as control-plane protection, an object-group ACL line dropped): all closed</a:t>
+            </a:r>
+            <a:endParaRPr lang="en-US" sz="1050" dirty="0"/>
+          </a:p>
+          <a:p>
+            <a:pPr marL="342900" indent="-342900">
+              <a:spcAft>
+                <a:spcPts val="100"/>
+              </a:spcAft>
+              <a:buSzPct val="100000"/>
+              <a:buChar char="•"/>
+            </a:pPr>
+            <a:r>
+              <a:rPr lang="en-US" sz="1050" dirty="0">
+                <a:solidFill>
+                  <a:srgbClr val="1E293B"/>
+                </a:solidFill>
+                <a:latin typeface="Calibri" pitchFamily="34" charset="0"/>
+                <a:ea typeface="Calibri" pitchFamily="34" charset="-122"/>
+                <a:cs typeface="Calibri" pitchFamily="34" charset="-120"/>
+              </a:rPr>
+              <a:t>Held-out runs: console exec-timeout failed the VTY rule; the AI read an SNMP trap target as syslog: fixed, AI never passes alone</a:t>
             </a:r>
             <a:endParaRPr lang="en-US" sz="1050" dirty="0"/>
           </a:p>
@@ -8441,48 +8483,6 @@
             </a:r>
             <a:endParaRPr lang="en-US" sz="1050" dirty="0"/>
           </a:p>
-          <a:p>
-            <a:pPr marL="342900" indent="-342900">
-              <a:spcAft>
-                <a:spcPts val="100"/>
-              </a:spcAft>
-              <a:buSzPct val="100000"/>
-              <a:buChar char="•"/>
-            </a:pPr>
-            <a:r>
-              <a:rPr lang="en-US" sz="1050" dirty="0">
-                <a:solidFill>
-                  <a:srgbClr val="1E293B"/>
-                </a:solidFill>
-                <a:latin typeface="Calibri" pitchFamily="34" charset="0"/>
-                <a:ea typeface="Calibri" pitchFamily="34" charset="-122"/>
-                <a:cs typeface="Calibri" pitchFamily="34" charset="-120"/>
-              </a:rPr>
-              <a:t>Secrets counted as redacted while the key stayed; FortiOS, Junos and PAN-OS secret shapes added</a:t>
-            </a:r>
-            <a:endParaRPr lang="en-US" sz="1050" dirty="0"/>
-          </a:p>
-          <a:p>
-            <a:pPr marL="342900" indent="-342900">
-              <a:spcAft>
-                <a:spcPts val="100"/>
-              </a:spcAft>
-              <a:buSzPct val="100000"/>
-              <a:buChar char="•"/>
-            </a:pPr>
-            <a:r>
-              <a:rPr lang="en-US" sz="1050" dirty="0">
-                <a:solidFill>
-                  <a:srgbClr val="1E293B"/>
-                </a:solidFill>
-                <a:latin typeface="Calibri" pitchFamily="34" charset="0"/>
-                <a:ea typeface="Calibri" pitchFamily="34" charset="-122"/>
-                <a:cs typeface="Calibri" pitchFamily="34" charset="-120"/>
-              </a:rPr>
-              <a:t>A pfSense rule that BLOCKS telnet read as telnet enabled; rules are now reassembled into one ACL line</a:t>
-            </a:r>
-            <a:endParaRPr lang="en-US" sz="1050" dirty="0"/>
-          </a:p>
         </p:txBody>
       </p:sp>
       <p:sp>
@@ -8623,7 +8623,7 @@
                 <a:ea typeface="Calibri" pitchFamily="34" charset="-122"/>
                 <a:cs typeface="Calibri" pitchFamily="34" charset="-120"/>
               </a:rPr>
-              <a:t>wrong verdicts (false PASS or FAIL) of 73 labelled</a:t>
+              <a:t>wrong verdicts: 73/73 labelled, 41/41 held-out decided</a:t>
             </a:r>
             <a:endParaRPr lang="en-US" sz="1200" dirty="0"/>
           </a:p>
@@ -8662,7 +8662,7 @@
                 <a:ea typeface="Cambria" pitchFamily="34" charset="-122"/>
                 <a:cs typeface="Cambria" pitchFamily="34" charset="-120"/>
               </a:rPr>
-              <a:t>73/73</a:t>
+              <a:t>33/35</a:t>
             </a:r>
             <a:endParaRPr lang="en-US" sz="2400" dirty="0"/>
           </a:p>
@@ -8701,7 +8701,7 @@
                 <a:ea typeface="Calibri" pitchFamily="34" charset="-122"/>
                 <a:cs typeface="Calibri" pitchFamily="34" charset="-120"/>
               </a:rPr>
-              <a:t>labelled checks decided and correct, AI off or on</a:t>
+              <a:t>held-out first run; labels committed first</a:t>
             </a:r>
             <a:endParaRPr lang="en-US" sz="1200" dirty="0"/>
           </a:p>
@@ -8779,7 +8779,7 @@
                 <a:ea typeface="Calibri" pitchFamily="34" charset="-122"/>
                 <a:cs typeface="Calibri" pitchFamily="34" charset="-120"/>
               </a:rPr>
-              <a:t>prompt-injection lines that reach the AI</a:t>
+              <a:t>injection lines that reach the AI</a:t>
             </a:r>
             <a:endParaRPr lang="en-US" sz="1200" dirty="0"/>
           </a:p>
@@ -8818,7 +8818,7 @@
                 <a:ea typeface="Calibri" pitchFamily="34" charset="-122"/>
                 <a:cs typeface="Calibri" pitchFamily="34" charset="-120"/>
               </a:rPr>
-              <a:t>7 configs, 5 vendors; enforced in CI. Classifier golden set: 95.8% precision.</a:t>
+              <a:t>Held-out: 7 unseen public configs; 41/41 on the current build, AI off and live; 15 left unknown. Both sets in CI.</a:t>
             </a:r>
             <a:endParaRPr lang="en-US" sz="950" dirty="0"/>
           </a:p>
@@ -8826,7 +8826,7 @@
       </p:sp>
       <p:pic>
         <p:nvPicPr>
-          <p:cNvPr id="21" name="Image 2" descr="documents\tech-deck\assets\queue_shot.png">    </p:cNvPr>
+          <p:cNvPr id="21" name="Image 2" descr="C:\Users\ADVAIT\SAVECODE\sih\documents\tech-deck\assets\queue_shot.png">    </p:cNvPr>
           <p:cNvPicPr>
             <a:picLocks noChangeAspect="1"/>
           </p:cNvPicPr>
@@ -8975,7 +8975,7 @@
       </p:sp>
       <p:pic>
         <p:nvPicPr>
-          <p:cNvPr id="4" name="Image 0" descr="documents\tech-deck\assets\sih2026.png">    </p:cNvPr>
+          <p:cNvPr id="4" name="Image 0" descr="C:\Users\ADVAIT\SAVECODE\sih\documents\tech-deck\assets\sih2026.png">    </p:cNvPr>
           <p:cNvPicPr>
             <a:picLocks noChangeAspect="1"/>
           </p:cNvPicPr>
@@ -8999,7 +8999,7 @@
       </p:pic>
       <p:pic>
         <p:nvPicPr>
-          <p:cNvPr id="5" name="Image 1" descr="documents\tech-deck\assets\six_origins.png">    </p:cNvPr>
+          <p:cNvPr id="5" name="Image 1" descr="C:\Users\ADVAIT\SAVECODE\sih\documents\tech-deck\assets\six_origins.png">    </p:cNvPr>
           <p:cNvPicPr>
             <a:picLocks noChangeAspect="1"/>
           </p:cNvPicPr>
@@ -9298,7 +9298,7 @@
                 <a:ea typeface="Calibri" pitchFamily="34" charset="-122"/>
                 <a:cs typeface="Calibri" pitchFamily="34" charset="-120"/>
               </a:rPr>
-              <a:t>39 rules; fail-closed, per-list ACL engine</a:t>
+              <a:t>39 rules + 51 DISA STIG (56 of 267 automated)</a:t>
             </a:r>
             <a:endParaRPr lang="en-US" sz="1300" dirty="0"/>
           </a:p>
@@ -9319,7 +9319,7 @@
                 <a:ea typeface="Calibri" pitchFamily="34" charset="-122"/>
                 <a:cs typeface="Calibri" pitchFamily="34" charset="-120"/>
               </a:rPr>
-              <a:t>5 vendors as data (Juniper, FortiGate: no code)</a:t>
+              <a:t>STIG releases imported; updates detected</a:t>
             </a:r>
             <a:endParaRPr lang="en-US" sz="1300" dirty="0"/>
           </a:p>
@@ -9361,7 +9361,7 @@
                 <a:ea typeface="Calibri" pitchFamily="34" charset="-122"/>
                 <a:cs typeface="Calibri" pitchFamily="34" charset="-120"/>
               </a:rPr>
-              <a:t>242 tests + CI incl. verdict ground truth</a:t>
+              <a:t>278 tests + CI incl. held-out ground truth</a:t>
             </a:r>
             <a:endParaRPr lang="en-US" sz="1300" dirty="0"/>
           </a:p>
@@ -9464,7 +9464,7 @@
                 <a:ea typeface="Calibri" pitchFamily="34" charset="-122"/>
                 <a:cs typeface="Calibri" pitchFamily="34" charset="-120"/>
               </a:rPr>
-              <a:t>Vendor defaults beyond Cisco IOS; per-interface CDP</a:t>
+              <a:t>Vendor defaults beyond Cisco, Junos, FortiOS; per-interface CDP</a:t>
             </a:r>
             <a:endParaRPr lang="en-US" sz="1300" dirty="0"/>
           </a:p>
@@ -9714,7 +9714,7 @@
                 <a:ea typeface="Calibri" pitchFamily="34" charset="-122"/>
                 <a:cs typeface="Calibri" pitchFamily="34" charset="-120"/>
               </a:rPr>
-              <a:t>Tiered rule authoring from benchmark PDFs (human-confirmed)</a:t>
+              <a:t>Automate more of the 211 manual STIG rules</a:t>
             </a:r>
             <a:endParaRPr lang="en-US" sz="1300" dirty="0"/>
           </a:p>
@@ -9735,7 +9735,7 @@
                 <a:ea typeface="Calibri" pitchFamily="34" charset="-122"/>
                 <a:cs typeface="Calibri" pitchFamily="34" charset="-120"/>
               </a:rPr>
-              <a:t>Larger labelled set, per vendor</a:t>
+              <a:t>Larger held-out set, per vendor</a:t>
             </a:r>
             <a:endParaRPr lang="en-US" sz="1300" dirty="0"/>
           </a:p>

</xml_diff>

<commit_message>
2-page PDF and deck: 304 tests
Co-Authored-By: Claude Opus 5.5 (1M context) <noreply@anthropic.com>
</commit_message>
<xml_diff>
--- a/docs/AEGIS-Technical-Presentation.pptx
+++ b/docs/AEGIS-Technical-Presentation.pptx
@@ -1938,7 +1938,7 @@
                 <a:ea typeface="Cambria" pitchFamily="34" charset="-122"/>
                 <a:cs typeface="Cambria" pitchFamily="34" charset="-120"/>
               </a:rPr>
-              <a:t>295</a:t>
+              <a:t>304</a:t>
             </a:r>
             <a:endParaRPr lang="en-US" sz="4400" dirty="0"/>
           </a:p>
@@ -9361,7 +9361,7 @@
                 <a:ea typeface="Calibri" pitchFamily="34" charset="-122"/>
                 <a:cs typeface="Calibri" pitchFamily="34" charset="-120"/>
               </a:rPr>
-              <a:t>295 tests + CI incl. held-out ground truth</a:t>
+              <a:t>304 tests + CI incl. held-out ground truth</a:t>
             </a:r>
             <a:endParaRPr lang="en-US" sz="1300" dirty="0"/>
           </a:p>

</xml_diff>

<commit_message>
Final review #4 fixes (verdict was GO): 9 more false-PASS paths closed
- FortiGate: a syslog/FortiAnalyzer server counts only when that log device
  has `set status enable` (default disable)
- NIST IA-5(1)(d) also requires every local user password to be type 8/9
- NIST-AC-17-2 titled as what it checks: the Telnet part of AC-17(2)
- ACLs: only inbound bindings count; a time-ranged deny is not always
  active; named ACLs are evaluated by sequence number
- empty banner is no banner; `no ip ssh version 2` means v1 allowed; a Junos
  syslog host with no facility sends nothing
- CRLF configs parse like LF ones (were fingerprinted `unknown`)
- /frameworks/coverage counts the 5 hand-written RTR STIG rules (101/267)
- unit_facts gains `none` (a fact that must not see a line)
314 tests; 73/73; held-out 41/41, 0 false. Docs: four review rounds.

Co-Authored-By: Claude Opus 5.5 (1M context) <noreply@anthropic.com>
</commit_message>
<xml_diff>
--- a/docs/AEGIS-Technical-Presentation.pptx
+++ b/docs/AEGIS-Technical-Presentation.pptx
@@ -1938,7 +1938,7 @@
                 <a:ea typeface="Cambria" pitchFamily="34" charset="-122"/>
                 <a:cs typeface="Cambria" pitchFamily="34" charset="-120"/>
               </a:rPr>
-              <a:t>304</a:t>
+              <a:t>314</a:t>
             </a:r>
             <a:endParaRPr lang="en-US" sz="4400" dirty="0"/>
           </a:p>
@@ -9361,7 +9361,7 @@
                 <a:ea typeface="Calibri" pitchFamily="34" charset="-122"/>
                 <a:cs typeface="Calibri" pitchFamily="34" charset="-120"/>
               </a:rPr>
-              <a:t>304 tests + CI incl. held-out ground truth</a:t>
+              <a:t>314 tests + CI incl. held-out ground truth</a:t>
             </a:r>
             <a:endParaRPr lang="en-US" sz="1300" dirty="0"/>
           </a:p>

</xml_diff>